<commit_message>
played with home template
</commit_message>
<xml_diff>
--- a/Power BI V2/Images/PPTX Template.pptx
+++ b/Power BI V2/Images/PPTX Template.pptx
@@ -7,6 +7,8 @@
   <p:sldIdLst>
     <p:sldId id="256" r:id="rId2"/>
     <p:sldId id="257" r:id="rId3"/>
+    <p:sldId id="258" r:id="rId4"/>
+    <p:sldId id="259" r:id="rId5"/>
   </p:sldIdLst>
   <p:sldSz cx="12192000" cy="6858000"/>
   <p:notesSz cx="7010400" cy="9296400"/>
@@ -105,6 +107,11 @@
       </a:defRPr>
     </a:lvl9pPr>
   </p:defaultTextStyle>
+  <p:extLst>
+    <p:ext uri="{EFAFB233-063F-42B5-8137-9DF3F51BA10A}">
+      <p15:sldGuideLst xmlns:p15="http://schemas.microsoft.com/office/powerpoint/2012/main"/>
+    </p:ext>
+  </p:extLst>
 </p:presentation>
 </file>
 
@@ -255,7 +262,7 @@
           <a:p>
             <a:fld id="{E44219A9-FE5C-4F0B-9FF8-4AC037278759}" type="datetimeFigureOut">
               <a:rPr lang="en-US" smtClean="0"/>
-              <a:t>10/8/2025</a:t>
+              <a:t>10/12/2025</a:t>
             </a:fld>
             <a:endParaRPr lang="en-US"/>
           </a:p>
@@ -453,7 +460,7 @@
           <a:p>
             <a:fld id="{E44219A9-FE5C-4F0B-9FF8-4AC037278759}" type="datetimeFigureOut">
               <a:rPr lang="en-US" smtClean="0"/>
-              <a:t>10/8/2025</a:t>
+              <a:t>10/12/2025</a:t>
             </a:fld>
             <a:endParaRPr lang="en-US"/>
           </a:p>
@@ -661,7 +668,7 @@
           <a:p>
             <a:fld id="{E44219A9-FE5C-4F0B-9FF8-4AC037278759}" type="datetimeFigureOut">
               <a:rPr lang="en-US" smtClean="0"/>
-              <a:t>10/8/2025</a:t>
+              <a:t>10/12/2025</a:t>
             </a:fld>
             <a:endParaRPr lang="en-US"/>
           </a:p>
@@ -859,7 +866,7 @@
           <a:p>
             <a:fld id="{E44219A9-FE5C-4F0B-9FF8-4AC037278759}" type="datetimeFigureOut">
               <a:rPr lang="en-US" smtClean="0"/>
-              <a:t>10/8/2025</a:t>
+              <a:t>10/12/2025</a:t>
             </a:fld>
             <a:endParaRPr lang="en-US"/>
           </a:p>
@@ -1134,7 +1141,7 @@
           <a:p>
             <a:fld id="{E44219A9-FE5C-4F0B-9FF8-4AC037278759}" type="datetimeFigureOut">
               <a:rPr lang="en-US" smtClean="0"/>
-              <a:t>10/8/2025</a:t>
+              <a:t>10/12/2025</a:t>
             </a:fld>
             <a:endParaRPr lang="en-US"/>
           </a:p>
@@ -1399,7 +1406,7 @@
           <a:p>
             <a:fld id="{E44219A9-FE5C-4F0B-9FF8-4AC037278759}" type="datetimeFigureOut">
               <a:rPr lang="en-US" smtClean="0"/>
-              <a:t>10/8/2025</a:t>
+              <a:t>10/12/2025</a:t>
             </a:fld>
             <a:endParaRPr lang="en-US"/>
           </a:p>
@@ -1811,7 +1818,7 @@
           <a:p>
             <a:fld id="{E44219A9-FE5C-4F0B-9FF8-4AC037278759}" type="datetimeFigureOut">
               <a:rPr lang="en-US" smtClean="0"/>
-              <a:t>10/8/2025</a:t>
+              <a:t>10/12/2025</a:t>
             </a:fld>
             <a:endParaRPr lang="en-US"/>
           </a:p>
@@ -1952,7 +1959,7 @@
           <a:p>
             <a:fld id="{E44219A9-FE5C-4F0B-9FF8-4AC037278759}" type="datetimeFigureOut">
               <a:rPr lang="en-US" smtClean="0"/>
-              <a:t>10/8/2025</a:t>
+              <a:t>10/12/2025</a:t>
             </a:fld>
             <a:endParaRPr lang="en-US"/>
           </a:p>
@@ -2065,7 +2072,7 @@
           <a:p>
             <a:fld id="{E44219A9-FE5C-4F0B-9FF8-4AC037278759}" type="datetimeFigureOut">
               <a:rPr lang="en-US" smtClean="0"/>
-              <a:t>10/8/2025</a:t>
+              <a:t>10/12/2025</a:t>
             </a:fld>
             <a:endParaRPr lang="en-US"/>
           </a:p>
@@ -2376,7 +2383,7 @@
           <a:p>
             <a:fld id="{E44219A9-FE5C-4F0B-9FF8-4AC037278759}" type="datetimeFigureOut">
               <a:rPr lang="en-US" smtClean="0"/>
-              <a:t>10/8/2025</a:t>
+              <a:t>10/12/2025</a:t>
             </a:fld>
             <a:endParaRPr lang="en-US"/>
           </a:p>
@@ -2664,7 +2671,7 @@
           <a:p>
             <a:fld id="{E44219A9-FE5C-4F0B-9FF8-4AC037278759}" type="datetimeFigureOut">
               <a:rPr lang="en-US" smtClean="0"/>
-              <a:t>10/8/2025</a:t>
+              <a:t>10/12/2025</a:t>
             </a:fld>
             <a:endParaRPr lang="en-US"/>
           </a:p>
@@ -2905,7 +2912,7 @@
           <a:p>
             <a:fld id="{E44219A9-FE5C-4F0B-9FF8-4AC037278759}" type="datetimeFigureOut">
               <a:rPr lang="en-US" smtClean="0"/>
-              <a:t>10/8/2025</a:t>
+              <a:t>10/12/2025</a:t>
             </a:fld>
             <a:endParaRPr lang="en-US"/>
           </a:p>
@@ -11327,6 +11334,3074 @@
 </p:sld>
 </file>
 
+<file path=ppt/slides/slide3.xml><?xml version="1.0" encoding="utf-8"?>
+<p:sld xmlns:a="http://schemas.openxmlformats.org/drawingml/2006/main" xmlns:r="http://schemas.openxmlformats.org/officeDocument/2006/relationships" xmlns:p="http://schemas.openxmlformats.org/presentationml/2006/main">
+  <p:cSld>
+    <p:spTree>
+      <p:nvGrpSpPr>
+        <p:cNvPr id="1" name=""/>
+        <p:cNvGrpSpPr/>
+        <p:nvPr/>
+      </p:nvGrpSpPr>
+      <p:grpSpPr>
+        <a:xfrm>
+          <a:off x="0" y="0"/>
+          <a:ext cx="0" cy="0"/>
+          <a:chOff x="0" y="0"/>
+          <a:chExt cx="0" cy="0"/>
+        </a:xfrm>
+      </p:grpSpPr>
+      <p:sp>
+        <p:nvSpPr>
+          <p:cNvPr id="4" name="Freeform: Shape 3">
+            <a:extLst>
+              <a:ext uri="{FF2B5EF4-FFF2-40B4-BE49-F238E27FC236}">
+                <a16:creationId xmlns:a16="http://schemas.microsoft.com/office/drawing/2014/main" id="{2827C9DD-052B-19E6-31B6-79C2E32FA6BB}"/>
+              </a:ext>
+            </a:extLst>
+          </p:cNvPr>
+          <p:cNvSpPr/>
+          <p:nvPr/>
+        </p:nvSpPr>
+        <p:spPr>
+          <a:xfrm>
+            <a:off x="20119" y="860212"/>
+            <a:ext cx="12188070" cy="427818"/>
+          </a:xfrm>
+          <a:custGeom>
+            <a:avLst/>
+            <a:gdLst>
+              <a:gd name="connsiteX0" fmla="*/ 0 w 12329639"/>
+              <a:gd name="connsiteY0" fmla="*/ 172081 h 1087698"/>
+              <a:gd name="connsiteX1" fmla="*/ 3775587 w 12329639"/>
+              <a:gd name="connsiteY1" fmla="*/ 1086481 h 1087698"/>
+              <a:gd name="connsiteX2" fmla="*/ 5220929 w 12329639"/>
+              <a:gd name="connsiteY2" fmla="*/ 378558 h 1087698"/>
+              <a:gd name="connsiteX3" fmla="*/ 7433187 w 12329639"/>
+              <a:gd name="connsiteY3" fmla="*/ 870171 h 1087698"/>
+              <a:gd name="connsiteX4" fmla="*/ 9301316 w 12329639"/>
+              <a:gd name="connsiteY4" fmla="*/ 260571 h 1087698"/>
+              <a:gd name="connsiteX5" fmla="*/ 10962968 w 12329639"/>
+              <a:gd name="connsiteY5" fmla="*/ 948829 h 1087698"/>
+              <a:gd name="connsiteX6" fmla="*/ 12270658 w 12329639"/>
+              <a:gd name="connsiteY6" fmla="*/ 54093 h 1087698"/>
+              <a:gd name="connsiteX7" fmla="*/ 12113342 w 12329639"/>
+              <a:gd name="connsiteY7" fmla="*/ 113087 h 1087698"/>
+              <a:gd name="connsiteX8" fmla="*/ 12192000 w 12329639"/>
+              <a:gd name="connsiteY8" fmla="*/ 221242 h 1087698"/>
+              <a:gd name="connsiteX0" fmla="*/ 0 w 12329639"/>
+              <a:gd name="connsiteY0" fmla="*/ 172081 h 950041"/>
+              <a:gd name="connsiteX1" fmla="*/ 2841522 w 12329639"/>
+              <a:gd name="connsiteY1" fmla="*/ 929165 h 950041"/>
+              <a:gd name="connsiteX2" fmla="*/ 5220929 w 12329639"/>
+              <a:gd name="connsiteY2" fmla="*/ 378558 h 950041"/>
+              <a:gd name="connsiteX3" fmla="*/ 7433187 w 12329639"/>
+              <a:gd name="connsiteY3" fmla="*/ 870171 h 950041"/>
+              <a:gd name="connsiteX4" fmla="*/ 9301316 w 12329639"/>
+              <a:gd name="connsiteY4" fmla="*/ 260571 h 950041"/>
+              <a:gd name="connsiteX5" fmla="*/ 10962968 w 12329639"/>
+              <a:gd name="connsiteY5" fmla="*/ 948829 h 950041"/>
+              <a:gd name="connsiteX6" fmla="*/ 12270658 w 12329639"/>
+              <a:gd name="connsiteY6" fmla="*/ 54093 h 950041"/>
+              <a:gd name="connsiteX7" fmla="*/ 12113342 w 12329639"/>
+              <a:gd name="connsiteY7" fmla="*/ 113087 h 950041"/>
+              <a:gd name="connsiteX8" fmla="*/ 12192000 w 12329639"/>
+              <a:gd name="connsiteY8" fmla="*/ 221242 h 950041"/>
+              <a:gd name="connsiteX0" fmla="*/ 0 w 12329639"/>
+              <a:gd name="connsiteY0" fmla="*/ 172081 h 950041"/>
+              <a:gd name="connsiteX1" fmla="*/ 1976284 w 12329639"/>
+              <a:gd name="connsiteY1" fmla="*/ 929165 h 950041"/>
+              <a:gd name="connsiteX2" fmla="*/ 5220929 w 12329639"/>
+              <a:gd name="connsiteY2" fmla="*/ 378558 h 950041"/>
+              <a:gd name="connsiteX3" fmla="*/ 7433187 w 12329639"/>
+              <a:gd name="connsiteY3" fmla="*/ 870171 h 950041"/>
+              <a:gd name="connsiteX4" fmla="*/ 9301316 w 12329639"/>
+              <a:gd name="connsiteY4" fmla="*/ 260571 h 950041"/>
+              <a:gd name="connsiteX5" fmla="*/ 10962968 w 12329639"/>
+              <a:gd name="connsiteY5" fmla="*/ 948829 h 950041"/>
+              <a:gd name="connsiteX6" fmla="*/ 12270658 w 12329639"/>
+              <a:gd name="connsiteY6" fmla="*/ 54093 h 950041"/>
+              <a:gd name="connsiteX7" fmla="*/ 12113342 w 12329639"/>
+              <a:gd name="connsiteY7" fmla="*/ 113087 h 950041"/>
+              <a:gd name="connsiteX8" fmla="*/ 12192000 w 12329639"/>
+              <a:gd name="connsiteY8" fmla="*/ 221242 h 950041"/>
+              <a:gd name="connsiteX0" fmla="*/ 0 w 12329639"/>
+              <a:gd name="connsiteY0" fmla="*/ 172081 h 950041"/>
+              <a:gd name="connsiteX1" fmla="*/ 1976284 w 12329639"/>
+              <a:gd name="connsiteY1" fmla="*/ 929165 h 950041"/>
+              <a:gd name="connsiteX2" fmla="*/ 5093110 w 12329639"/>
+              <a:gd name="connsiteY2" fmla="*/ 201578 h 950041"/>
+              <a:gd name="connsiteX3" fmla="*/ 7433187 w 12329639"/>
+              <a:gd name="connsiteY3" fmla="*/ 870171 h 950041"/>
+              <a:gd name="connsiteX4" fmla="*/ 9301316 w 12329639"/>
+              <a:gd name="connsiteY4" fmla="*/ 260571 h 950041"/>
+              <a:gd name="connsiteX5" fmla="*/ 10962968 w 12329639"/>
+              <a:gd name="connsiteY5" fmla="*/ 948829 h 950041"/>
+              <a:gd name="connsiteX6" fmla="*/ 12270658 w 12329639"/>
+              <a:gd name="connsiteY6" fmla="*/ 54093 h 950041"/>
+              <a:gd name="connsiteX7" fmla="*/ 12113342 w 12329639"/>
+              <a:gd name="connsiteY7" fmla="*/ 113087 h 950041"/>
+              <a:gd name="connsiteX8" fmla="*/ 12192000 w 12329639"/>
+              <a:gd name="connsiteY8" fmla="*/ 221242 h 950041"/>
+              <a:gd name="connsiteX0" fmla="*/ 0 w 12329639"/>
+              <a:gd name="connsiteY0" fmla="*/ 172081 h 950041"/>
+              <a:gd name="connsiteX1" fmla="*/ 1976284 w 12329639"/>
+              <a:gd name="connsiteY1" fmla="*/ 929165 h 950041"/>
+              <a:gd name="connsiteX2" fmla="*/ 3480619 w 12329639"/>
+              <a:gd name="connsiteY2" fmla="*/ 181914 h 950041"/>
+              <a:gd name="connsiteX3" fmla="*/ 7433187 w 12329639"/>
+              <a:gd name="connsiteY3" fmla="*/ 870171 h 950041"/>
+              <a:gd name="connsiteX4" fmla="*/ 9301316 w 12329639"/>
+              <a:gd name="connsiteY4" fmla="*/ 260571 h 950041"/>
+              <a:gd name="connsiteX5" fmla="*/ 10962968 w 12329639"/>
+              <a:gd name="connsiteY5" fmla="*/ 948829 h 950041"/>
+              <a:gd name="connsiteX6" fmla="*/ 12270658 w 12329639"/>
+              <a:gd name="connsiteY6" fmla="*/ 54093 h 950041"/>
+              <a:gd name="connsiteX7" fmla="*/ 12113342 w 12329639"/>
+              <a:gd name="connsiteY7" fmla="*/ 113087 h 950041"/>
+              <a:gd name="connsiteX8" fmla="*/ 12192000 w 12329639"/>
+              <a:gd name="connsiteY8" fmla="*/ 221242 h 950041"/>
+              <a:gd name="connsiteX0" fmla="*/ 0 w 12329639"/>
+              <a:gd name="connsiteY0" fmla="*/ 172081 h 950020"/>
+              <a:gd name="connsiteX1" fmla="*/ 1976284 w 12329639"/>
+              <a:gd name="connsiteY1" fmla="*/ 929165 h 950020"/>
+              <a:gd name="connsiteX2" fmla="*/ 3480619 w 12329639"/>
+              <a:gd name="connsiteY2" fmla="*/ 181914 h 950020"/>
+              <a:gd name="connsiteX3" fmla="*/ 5378245 w 12329639"/>
+              <a:gd name="connsiteY3" fmla="*/ 948829 h 950020"/>
+              <a:gd name="connsiteX4" fmla="*/ 9301316 w 12329639"/>
+              <a:gd name="connsiteY4" fmla="*/ 260571 h 950020"/>
+              <a:gd name="connsiteX5" fmla="*/ 10962968 w 12329639"/>
+              <a:gd name="connsiteY5" fmla="*/ 948829 h 950020"/>
+              <a:gd name="connsiteX6" fmla="*/ 12270658 w 12329639"/>
+              <a:gd name="connsiteY6" fmla="*/ 54093 h 950020"/>
+              <a:gd name="connsiteX7" fmla="*/ 12113342 w 12329639"/>
+              <a:gd name="connsiteY7" fmla="*/ 113087 h 950020"/>
+              <a:gd name="connsiteX8" fmla="*/ 12192000 w 12329639"/>
+              <a:gd name="connsiteY8" fmla="*/ 221242 h 950020"/>
+              <a:gd name="connsiteX0" fmla="*/ 0 w 12329639"/>
+              <a:gd name="connsiteY0" fmla="*/ 172081 h 949580"/>
+              <a:gd name="connsiteX1" fmla="*/ 1976284 w 12329639"/>
+              <a:gd name="connsiteY1" fmla="*/ 929165 h 949580"/>
+              <a:gd name="connsiteX2" fmla="*/ 3480619 w 12329639"/>
+              <a:gd name="connsiteY2" fmla="*/ 181914 h 949580"/>
+              <a:gd name="connsiteX3" fmla="*/ 5378245 w 12329639"/>
+              <a:gd name="connsiteY3" fmla="*/ 948829 h 949580"/>
+              <a:gd name="connsiteX4" fmla="*/ 7541342 w 12329639"/>
+              <a:gd name="connsiteY4" fmla="*/ 221242 h 949580"/>
+              <a:gd name="connsiteX5" fmla="*/ 10962968 w 12329639"/>
+              <a:gd name="connsiteY5" fmla="*/ 948829 h 949580"/>
+              <a:gd name="connsiteX6" fmla="*/ 12270658 w 12329639"/>
+              <a:gd name="connsiteY6" fmla="*/ 54093 h 949580"/>
+              <a:gd name="connsiteX7" fmla="*/ 12113342 w 12329639"/>
+              <a:gd name="connsiteY7" fmla="*/ 113087 h 949580"/>
+              <a:gd name="connsiteX8" fmla="*/ 12192000 w 12329639"/>
+              <a:gd name="connsiteY8" fmla="*/ 221242 h 949580"/>
+              <a:gd name="connsiteX0" fmla="*/ 0 w 12425620"/>
+              <a:gd name="connsiteY0" fmla="*/ 164941 h 941733"/>
+              <a:gd name="connsiteX1" fmla="*/ 1976284 w 12425620"/>
+              <a:gd name="connsiteY1" fmla="*/ 922025 h 941733"/>
+              <a:gd name="connsiteX2" fmla="*/ 3480619 w 12425620"/>
+              <a:gd name="connsiteY2" fmla="*/ 174774 h 941733"/>
+              <a:gd name="connsiteX3" fmla="*/ 5378245 w 12425620"/>
+              <a:gd name="connsiteY3" fmla="*/ 941689 h 941733"/>
+              <a:gd name="connsiteX4" fmla="*/ 7541342 w 12425620"/>
+              <a:gd name="connsiteY4" fmla="*/ 214102 h 941733"/>
+              <a:gd name="connsiteX5" fmla="*/ 9596284 w 12425620"/>
+              <a:gd name="connsiteY5" fmla="*/ 843366 h 941733"/>
+              <a:gd name="connsiteX6" fmla="*/ 12270658 w 12425620"/>
+              <a:gd name="connsiteY6" fmla="*/ 46953 h 941733"/>
+              <a:gd name="connsiteX7" fmla="*/ 12113342 w 12425620"/>
+              <a:gd name="connsiteY7" fmla="*/ 105947 h 941733"/>
+              <a:gd name="connsiteX8" fmla="*/ 12192000 w 12425620"/>
+              <a:gd name="connsiteY8" fmla="*/ 214102 h 941733"/>
+              <a:gd name="connsiteX0" fmla="*/ 0 w 12446934"/>
+              <a:gd name="connsiteY0" fmla="*/ 552701 h 1329493"/>
+              <a:gd name="connsiteX1" fmla="*/ 1976284 w 12446934"/>
+              <a:gd name="connsiteY1" fmla="*/ 1309785 h 1329493"/>
+              <a:gd name="connsiteX2" fmla="*/ 3480619 w 12446934"/>
+              <a:gd name="connsiteY2" fmla="*/ 562534 h 1329493"/>
+              <a:gd name="connsiteX3" fmla="*/ 5378245 w 12446934"/>
+              <a:gd name="connsiteY3" fmla="*/ 1329449 h 1329493"/>
+              <a:gd name="connsiteX4" fmla="*/ 7541342 w 12446934"/>
+              <a:gd name="connsiteY4" fmla="*/ 601862 h 1329493"/>
+              <a:gd name="connsiteX5" fmla="*/ 9596284 w 12446934"/>
+              <a:gd name="connsiteY5" fmla="*/ 1231126 h 1329493"/>
+              <a:gd name="connsiteX6" fmla="*/ 12270658 w 12446934"/>
+              <a:gd name="connsiteY6" fmla="*/ 434713 h 1329493"/>
+              <a:gd name="connsiteX7" fmla="*/ 12192000 w 12446934"/>
+              <a:gd name="connsiteY7" fmla="*/ 2094 h 1329493"/>
+              <a:gd name="connsiteX8" fmla="*/ 12192000 w 12446934"/>
+              <a:gd name="connsiteY8" fmla="*/ 601862 h 1329493"/>
+              <a:gd name="connsiteX0" fmla="*/ 0 w 12193282"/>
+              <a:gd name="connsiteY0" fmla="*/ 551070 h 1492944"/>
+              <a:gd name="connsiteX1" fmla="*/ 1976284 w 12193282"/>
+              <a:gd name="connsiteY1" fmla="*/ 1308154 h 1492944"/>
+              <a:gd name="connsiteX2" fmla="*/ 3480619 w 12193282"/>
+              <a:gd name="connsiteY2" fmla="*/ 560903 h 1492944"/>
+              <a:gd name="connsiteX3" fmla="*/ 5378245 w 12193282"/>
+              <a:gd name="connsiteY3" fmla="*/ 1327818 h 1492944"/>
+              <a:gd name="connsiteX4" fmla="*/ 7541342 w 12193282"/>
+              <a:gd name="connsiteY4" fmla="*/ 600231 h 1492944"/>
+              <a:gd name="connsiteX5" fmla="*/ 9596284 w 12193282"/>
+              <a:gd name="connsiteY5" fmla="*/ 1229495 h 1492944"/>
+              <a:gd name="connsiteX6" fmla="*/ 11690554 w 12193282"/>
+              <a:gd name="connsiteY6" fmla="*/ 1416307 h 1492944"/>
+              <a:gd name="connsiteX7" fmla="*/ 12192000 w 12193282"/>
+              <a:gd name="connsiteY7" fmla="*/ 463 h 1492944"/>
+              <a:gd name="connsiteX8" fmla="*/ 12192000 w 12193282"/>
+              <a:gd name="connsiteY8" fmla="*/ 600231 h 1492944"/>
+              <a:gd name="connsiteX0" fmla="*/ 0 w 12192176"/>
+              <a:gd name="connsiteY0" fmla="*/ 551890 h 1328682"/>
+              <a:gd name="connsiteX1" fmla="*/ 1976284 w 12192176"/>
+              <a:gd name="connsiteY1" fmla="*/ 1308974 h 1328682"/>
+              <a:gd name="connsiteX2" fmla="*/ 3480619 w 12192176"/>
+              <a:gd name="connsiteY2" fmla="*/ 561723 h 1328682"/>
+              <a:gd name="connsiteX3" fmla="*/ 5378245 w 12192176"/>
+              <a:gd name="connsiteY3" fmla="*/ 1328638 h 1328682"/>
+              <a:gd name="connsiteX4" fmla="*/ 7541342 w 12192176"/>
+              <a:gd name="connsiteY4" fmla="*/ 601051 h 1328682"/>
+              <a:gd name="connsiteX5" fmla="*/ 9596284 w 12192176"/>
+              <a:gd name="connsiteY5" fmla="*/ 1230315 h 1328682"/>
+              <a:gd name="connsiteX6" fmla="*/ 11051457 w 12192176"/>
+              <a:gd name="connsiteY6" fmla="*/ 610882 h 1328682"/>
+              <a:gd name="connsiteX7" fmla="*/ 12192000 w 12192176"/>
+              <a:gd name="connsiteY7" fmla="*/ 1283 h 1328682"/>
+              <a:gd name="connsiteX8" fmla="*/ 12192000 w 12192176"/>
+              <a:gd name="connsiteY8" fmla="*/ 601051 h 1328682"/>
+              <a:gd name="connsiteX0" fmla="*/ 0 w 12192000"/>
+              <a:gd name="connsiteY0" fmla="*/ 0 h 776792"/>
+              <a:gd name="connsiteX1" fmla="*/ 1976284 w 12192000"/>
+              <a:gd name="connsiteY1" fmla="*/ 757084 h 776792"/>
+              <a:gd name="connsiteX2" fmla="*/ 3480619 w 12192000"/>
+              <a:gd name="connsiteY2" fmla="*/ 9833 h 776792"/>
+              <a:gd name="connsiteX3" fmla="*/ 5378245 w 12192000"/>
+              <a:gd name="connsiteY3" fmla="*/ 776748 h 776792"/>
+              <a:gd name="connsiteX4" fmla="*/ 7541342 w 12192000"/>
+              <a:gd name="connsiteY4" fmla="*/ 49161 h 776792"/>
+              <a:gd name="connsiteX5" fmla="*/ 9596284 w 12192000"/>
+              <a:gd name="connsiteY5" fmla="*/ 678425 h 776792"/>
+              <a:gd name="connsiteX6" fmla="*/ 11051457 w 12192000"/>
+              <a:gd name="connsiteY6" fmla="*/ 58992 h 776792"/>
+              <a:gd name="connsiteX7" fmla="*/ 11808542 w 12192000"/>
+              <a:gd name="connsiteY7" fmla="*/ 727587 h 776792"/>
+              <a:gd name="connsiteX8" fmla="*/ 12192000 w 12192000"/>
+              <a:gd name="connsiteY8" fmla="*/ 49161 h 776792"/>
+              <a:gd name="connsiteX0" fmla="*/ 0 w 12270658"/>
+              <a:gd name="connsiteY0" fmla="*/ 0 h 776792"/>
+              <a:gd name="connsiteX1" fmla="*/ 1976284 w 12270658"/>
+              <a:gd name="connsiteY1" fmla="*/ 757084 h 776792"/>
+              <a:gd name="connsiteX2" fmla="*/ 3480619 w 12270658"/>
+              <a:gd name="connsiteY2" fmla="*/ 9833 h 776792"/>
+              <a:gd name="connsiteX3" fmla="*/ 5378245 w 12270658"/>
+              <a:gd name="connsiteY3" fmla="*/ 776748 h 776792"/>
+              <a:gd name="connsiteX4" fmla="*/ 7541342 w 12270658"/>
+              <a:gd name="connsiteY4" fmla="*/ 49161 h 776792"/>
+              <a:gd name="connsiteX5" fmla="*/ 9596284 w 12270658"/>
+              <a:gd name="connsiteY5" fmla="*/ 678425 h 776792"/>
+              <a:gd name="connsiteX6" fmla="*/ 11051457 w 12270658"/>
+              <a:gd name="connsiteY6" fmla="*/ 58992 h 776792"/>
+              <a:gd name="connsiteX7" fmla="*/ 11808542 w 12270658"/>
+              <a:gd name="connsiteY7" fmla="*/ 727587 h 776792"/>
+              <a:gd name="connsiteX8" fmla="*/ 12270658 w 12270658"/>
+              <a:gd name="connsiteY8" fmla="*/ 19665 h 776792"/>
+              <a:gd name="connsiteX0" fmla="*/ 0 w 12270658"/>
+              <a:gd name="connsiteY0" fmla="*/ 0 h 776792"/>
+              <a:gd name="connsiteX1" fmla="*/ 1976284 w 12270658"/>
+              <a:gd name="connsiteY1" fmla="*/ 757084 h 776792"/>
+              <a:gd name="connsiteX2" fmla="*/ 3480619 w 12270658"/>
+              <a:gd name="connsiteY2" fmla="*/ 9833 h 776792"/>
+              <a:gd name="connsiteX3" fmla="*/ 5378245 w 12270658"/>
+              <a:gd name="connsiteY3" fmla="*/ 776748 h 776792"/>
+              <a:gd name="connsiteX4" fmla="*/ 7541342 w 12270658"/>
+              <a:gd name="connsiteY4" fmla="*/ 49161 h 776792"/>
+              <a:gd name="connsiteX5" fmla="*/ 9596284 w 12270658"/>
+              <a:gd name="connsiteY5" fmla="*/ 678425 h 776792"/>
+              <a:gd name="connsiteX6" fmla="*/ 11051457 w 12270658"/>
+              <a:gd name="connsiteY6" fmla="*/ 58992 h 776792"/>
+              <a:gd name="connsiteX7" fmla="*/ 11769213 w 12270658"/>
+              <a:gd name="connsiteY7" fmla="*/ 363793 h 776792"/>
+              <a:gd name="connsiteX8" fmla="*/ 12270658 w 12270658"/>
+              <a:gd name="connsiteY8" fmla="*/ 19665 h 776792"/>
+              <a:gd name="connsiteX0" fmla="*/ 0 w 12182168"/>
+              <a:gd name="connsiteY0" fmla="*/ 0 h 776792"/>
+              <a:gd name="connsiteX1" fmla="*/ 1887794 w 12182168"/>
+              <a:gd name="connsiteY1" fmla="*/ 757084 h 776792"/>
+              <a:gd name="connsiteX2" fmla="*/ 3392129 w 12182168"/>
+              <a:gd name="connsiteY2" fmla="*/ 9833 h 776792"/>
+              <a:gd name="connsiteX3" fmla="*/ 5289755 w 12182168"/>
+              <a:gd name="connsiteY3" fmla="*/ 776748 h 776792"/>
+              <a:gd name="connsiteX4" fmla="*/ 7452852 w 12182168"/>
+              <a:gd name="connsiteY4" fmla="*/ 49161 h 776792"/>
+              <a:gd name="connsiteX5" fmla="*/ 9507794 w 12182168"/>
+              <a:gd name="connsiteY5" fmla="*/ 678425 h 776792"/>
+              <a:gd name="connsiteX6" fmla="*/ 10962967 w 12182168"/>
+              <a:gd name="connsiteY6" fmla="*/ 58992 h 776792"/>
+              <a:gd name="connsiteX7" fmla="*/ 11680723 w 12182168"/>
+              <a:gd name="connsiteY7" fmla="*/ 363793 h 776792"/>
+              <a:gd name="connsiteX8" fmla="*/ 12182168 w 12182168"/>
+              <a:gd name="connsiteY8" fmla="*/ 19665 h 776792"/>
+              <a:gd name="connsiteX0" fmla="*/ 0 w 12182168"/>
+              <a:gd name="connsiteY0" fmla="*/ 0 h 776792"/>
+              <a:gd name="connsiteX1" fmla="*/ 1887794 w 12182168"/>
+              <a:gd name="connsiteY1" fmla="*/ 757084 h 776792"/>
+              <a:gd name="connsiteX2" fmla="*/ 3392129 w 12182168"/>
+              <a:gd name="connsiteY2" fmla="*/ 9833 h 776792"/>
+              <a:gd name="connsiteX3" fmla="*/ 5289755 w 12182168"/>
+              <a:gd name="connsiteY3" fmla="*/ 776748 h 776792"/>
+              <a:gd name="connsiteX4" fmla="*/ 7452852 w 12182168"/>
+              <a:gd name="connsiteY4" fmla="*/ 49161 h 776792"/>
+              <a:gd name="connsiteX5" fmla="*/ 9507794 w 12182168"/>
+              <a:gd name="connsiteY5" fmla="*/ 678425 h 776792"/>
+              <a:gd name="connsiteX6" fmla="*/ 10962967 w 12182168"/>
+              <a:gd name="connsiteY6" fmla="*/ 58992 h 776792"/>
+              <a:gd name="connsiteX7" fmla="*/ 11700355 w 12182168"/>
+              <a:gd name="connsiteY7" fmla="*/ 314632 h 776792"/>
+              <a:gd name="connsiteX8" fmla="*/ 12182168 w 12182168"/>
+              <a:gd name="connsiteY8" fmla="*/ 19665 h 776792"/>
+              <a:gd name="connsiteX0" fmla="*/ 0 w 12182168"/>
+              <a:gd name="connsiteY0" fmla="*/ 0 h 776792"/>
+              <a:gd name="connsiteX1" fmla="*/ 1887794 w 12182168"/>
+              <a:gd name="connsiteY1" fmla="*/ 757084 h 776792"/>
+              <a:gd name="connsiteX2" fmla="*/ 3392129 w 12182168"/>
+              <a:gd name="connsiteY2" fmla="*/ 9833 h 776792"/>
+              <a:gd name="connsiteX3" fmla="*/ 5289755 w 12182168"/>
+              <a:gd name="connsiteY3" fmla="*/ 776748 h 776792"/>
+              <a:gd name="connsiteX4" fmla="*/ 7452852 w 12182168"/>
+              <a:gd name="connsiteY4" fmla="*/ 49161 h 776792"/>
+              <a:gd name="connsiteX5" fmla="*/ 9507794 w 12182168"/>
+              <a:gd name="connsiteY5" fmla="*/ 678425 h 776792"/>
+              <a:gd name="connsiteX6" fmla="*/ 10962967 w 12182168"/>
+              <a:gd name="connsiteY6" fmla="*/ 58992 h 776792"/>
+              <a:gd name="connsiteX7" fmla="*/ 11700355 w 12182168"/>
+              <a:gd name="connsiteY7" fmla="*/ 314632 h 776792"/>
+              <a:gd name="connsiteX8" fmla="*/ 12182168 w 12182168"/>
+              <a:gd name="connsiteY8" fmla="*/ 19665 h 776792"/>
+              <a:gd name="connsiteX0" fmla="*/ 0 w 12182168"/>
+              <a:gd name="connsiteY0" fmla="*/ 0 h 776792"/>
+              <a:gd name="connsiteX1" fmla="*/ 1887794 w 12182168"/>
+              <a:gd name="connsiteY1" fmla="*/ 757084 h 776792"/>
+              <a:gd name="connsiteX2" fmla="*/ 3392129 w 12182168"/>
+              <a:gd name="connsiteY2" fmla="*/ 9833 h 776792"/>
+              <a:gd name="connsiteX3" fmla="*/ 5289755 w 12182168"/>
+              <a:gd name="connsiteY3" fmla="*/ 776748 h 776792"/>
+              <a:gd name="connsiteX4" fmla="*/ 7452852 w 12182168"/>
+              <a:gd name="connsiteY4" fmla="*/ 49161 h 776792"/>
+              <a:gd name="connsiteX5" fmla="*/ 9507794 w 12182168"/>
+              <a:gd name="connsiteY5" fmla="*/ 678425 h 776792"/>
+              <a:gd name="connsiteX6" fmla="*/ 10962967 w 12182168"/>
+              <a:gd name="connsiteY6" fmla="*/ 58992 h 776792"/>
+              <a:gd name="connsiteX7" fmla="*/ 11614768 w 12182168"/>
+              <a:gd name="connsiteY7" fmla="*/ 724207 h 776792"/>
+              <a:gd name="connsiteX8" fmla="*/ 12182168 w 12182168"/>
+              <a:gd name="connsiteY8" fmla="*/ 19665 h 776792"/>
+              <a:gd name="connsiteX0" fmla="*/ 0 w 12182168"/>
+              <a:gd name="connsiteY0" fmla="*/ 0 h 776792"/>
+              <a:gd name="connsiteX1" fmla="*/ 1887794 w 12182168"/>
+              <a:gd name="connsiteY1" fmla="*/ 757084 h 776792"/>
+              <a:gd name="connsiteX2" fmla="*/ 3392129 w 12182168"/>
+              <a:gd name="connsiteY2" fmla="*/ 9833 h 776792"/>
+              <a:gd name="connsiteX3" fmla="*/ 5289755 w 12182168"/>
+              <a:gd name="connsiteY3" fmla="*/ 776748 h 776792"/>
+              <a:gd name="connsiteX4" fmla="*/ 7452852 w 12182168"/>
+              <a:gd name="connsiteY4" fmla="*/ 49161 h 776792"/>
+              <a:gd name="connsiteX5" fmla="*/ 9507794 w 12182168"/>
+              <a:gd name="connsiteY5" fmla="*/ 678425 h 776792"/>
+              <a:gd name="connsiteX6" fmla="*/ 10962967 w 12182168"/>
+              <a:gd name="connsiteY6" fmla="*/ 58992 h 776792"/>
+              <a:gd name="connsiteX7" fmla="*/ 11614768 w 12182168"/>
+              <a:gd name="connsiteY7" fmla="*/ 724207 h 776792"/>
+              <a:gd name="connsiteX8" fmla="*/ 12182168 w 12182168"/>
+              <a:gd name="connsiteY8" fmla="*/ 19665 h 776792"/>
+              <a:gd name="connsiteX0" fmla="*/ 0 w 12182168"/>
+              <a:gd name="connsiteY0" fmla="*/ 0 h 776793"/>
+              <a:gd name="connsiteX1" fmla="*/ 1887794 w 12182168"/>
+              <a:gd name="connsiteY1" fmla="*/ 757084 h 776793"/>
+              <a:gd name="connsiteX2" fmla="*/ 3392129 w 12182168"/>
+              <a:gd name="connsiteY2" fmla="*/ 9833 h 776793"/>
+              <a:gd name="connsiteX3" fmla="*/ 5289755 w 12182168"/>
+              <a:gd name="connsiteY3" fmla="*/ 776748 h 776793"/>
+              <a:gd name="connsiteX4" fmla="*/ 7452852 w 12182168"/>
+              <a:gd name="connsiteY4" fmla="*/ 49161 h 776793"/>
+              <a:gd name="connsiteX5" fmla="*/ 8837364 w 12182168"/>
+              <a:gd name="connsiteY5" fmla="*/ 616512 h 776793"/>
+              <a:gd name="connsiteX6" fmla="*/ 10962967 w 12182168"/>
+              <a:gd name="connsiteY6" fmla="*/ 58992 h 776793"/>
+              <a:gd name="connsiteX7" fmla="*/ 11614768 w 12182168"/>
+              <a:gd name="connsiteY7" fmla="*/ 724207 h 776793"/>
+              <a:gd name="connsiteX8" fmla="*/ 12182168 w 12182168"/>
+              <a:gd name="connsiteY8" fmla="*/ 19665 h 776793"/>
+              <a:gd name="connsiteX0" fmla="*/ 0 w 12182168"/>
+              <a:gd name="connsiteY0" fmla="*/ 0 h 776793"/>
+              <a:gd name="connsiteX1" fmla="*/ 1887794 w 12182168"/>
+              <a:gd name="connsiteY1" fmla="*/ 757084 h 776793"/>
+              <a:gd name="connsiteX2" fmla="*/ 3392129 w 12182168"/>
+              <a:gd name="connsiteY2" fmla="*/ 9833 h 776793"/>
+              <a:gd name="connsiteX3" fmla="*/ 5289755 w 12182168"/>
+              <a:gd name="connsiteY3" fmla="*/ 776748 h 776793"/>
+              <a:gd name="connsiteX4" fmla="*/ 7452852 w 12182168"/>
+              <a:gd name="connsiteY4" fmla="*/ 49161 h 776793"/>
+              <a:gd name="connsiteX5" fmla="*/ 8837364 w 12182168"/>
+              <a:gd name="connsiteY5" fmla="*/ 616512 h 776793"/>
+              <a:gd name="connsiteX6" fmla="*/ 10378124 w 12182168"/>
+              <a:gd name="connsiteY6" fmla="*/ 44704 h 776793"/>
+              <a:gd name="connsiteX7" fmla="*/ 11614768 w 12182168"/>
+              <a:gd name="connsiteY7" fmla="*/ 724207 h 776793"/>
+              <a:gd name="connsiteX8" fmla="*/ 12182168 w 12182168"/>
+              <a:gd name="connsiteY8" fmla="*/ 19665 h 776793"/>
+              <a:gd name="connsiteX0" fmla="*/ 0 w 12182168"/>
+              <a:gd name="connsiteY0" fmla="*/ 0 h 776793"/>
+              <a:gd name="connsiteX1" fmla="*/ 1488389 w 12182168"/>
+              <a:gd name="connsiteY1" fmla="*/ 766609 h 776793"/>
+              <a:gd name="connsiteX2" fmla="*/ 3392129 w 12182168"/>
+              <a:gd name="connsiteY2" fmla="*/ 9833 h 776793"/>
+              <a:gd name="connsiteX3" fmla="*/ 5289755 w 12182168"/>
+              <a:gd name="connsiteY3" fmla="*/ 776748 h 776793"/>
+              <a:gd name="connsiteX4" fmla="*/ 7452852 w 12182168"/>
+              <a:gd name="connsiteY4" fmla="*/ 49161 h 776793"/>
+              <a:gd name="connsiteX5" fmla="*/ 8837364 w 12182168"/>
+              <a:gd name="connsiteY5" fmla="*/ 616512 h 776793"/>
+              <a:gd name="connsiteX6" fmla="*/ 10378124 w 12182168"/>
+              <a:gd name="connsiteY6" fmla="*/ 44704 h 776793"/>
+              <a:gd name="connsiteX7" fmla="*/ 11614768 w 12182168"/>
+              <a:gd name="connsiteY7" fmla="*/ 724207 h 776793"/>
+              <a:gd name="connsiteX8" fmla="*/ 12182168 w 12182168"/>
+              <a:gd name="connsiteY8" fmla="*/ 19665 h 776793"/>
+              <a:gd name="connsiteX0" fmla="*/ 0 w 12182168"/>
+              <a:gd name="connsiteY0" fmla="*/ 0 h 776793"/>
+              <a:gd name="connsiteX1" fmla="*/ 1516918 w 12182168"/>
+              <a:gd name="connsiteY1" fmla="*/ 757084 h 776793"/>
+              <a:gd name="connsiteX2" fmla="*/ 3392129 w 12182168"/>
+              <a:gd name="connsiteY2" fmla="*/ 9833 h 776793"/>
+              <a:gd name="connsiteX3" fmla="*/ 5289755 w 12182168"/>
+              <a:gd name="connsiteY3" fmla="*/ 776748 h 776793"/>
+              <a:gd name="connsiteX4" fmla="*/ 7452852 w 12182168"/>
+              <a:gd name="connsiteY4" fmla="*/ 49161 h 776793"/>
+              <a:gd name="connsiteX5" fmla="*/ 8837364 w 12182168"/>
+              <a:gd name="connsiteY5" fmla="*/ 616512 h 776793"/>
+              <a:gd name="connsiteX6" fmla="*/ 10378124 w 12182168"/>
+              <a:gd name="connsiteY6" fmla="*/ 44704 h 776793"/>
+              <a:gd name="connsiteX7" fmla="*/ 11614768 w 12182168"/>
+              <a:gd name="connsiteY7" fmla="*/ 724207 h 776793"/>
+              <a:gd name="connsiteX8" fmla="*/ 12182168 w 12182168"/>
+              <a:gd name="connsiteY8" fmla="*/ 19665 h 776793"/>
+              <a:gd name="connsiteX0" fmla="*/ 0 w 12182168"/>
+              <a:gd name="connsiteY0" fmla="*/ 0 h 776774"/>
+              <a:gd name="connsiteX1" fmla="*/ 1516918 w 12182168"/>
+              <a:gd name="connsiteY1" fmla="*/ 757084 h 776774"/>
+              <a:gd name="connsiteX2" fmla="*/ 3021253 w 12182168"/>
+              <a:gd name="connsiteY2" fmla="*/ 19358 h 776774"/>
+              <a:gd name="connsiteX3" fmla="*/ 5289755 w 12182168"/>
+              <a:gd name="connsiteY3" fmla="*/ 776748 h 776774"/>
+              <a:gd name="connsiteX4" fmla="*/ 7452852 w 12182168"/>
+              <a:gd name="connsiteY4" fmla="*/ 49161 h 776774"/>
+              <a:gd name="connsiteX5" fmla="*/ 8837364 w 12182168"/>
+              <a:gd name="connsiteY5" fmla="*/ 616512 h 776774"/>
+              <a:gd name="connsiteX6" fmla="*/ 10378124 w 12182168"/>
+              <a:gd name="connsiteY6" fmla="*/ 44704 h 776774"/>
+              <a:gd name="connsiteX7" fmla="*/ 11614768 w 12182168"/>
+              <a:gd name="connsiteY7" fmla="*/ 724207 h 776774"/>
+              <a:gd name="connsiteX8" fmla="*/ 12182168 w 12182168"/>
+              <a:gd name="connsiteY8" fmla="*/ 19665 h 776774"/>
+              <a:gd name="connsiteX0" fmla="*/ 0 w 12182168"/>
+              <a:gd name="connsiteY0" fmla="*/ 0 h 776817"/>
+              <a:gd name="connsiteX1" fmla="*/ 1516918 w 12182168"/>
+              <a:gd name="connsiteY1" fmla="*/ 757084 h 776817"/>
+              <a:gd name="connsiteX2" fmla="*/ 3078311 w 12182168"/>
+              <a:gd name="connsiteY2" fmla="*/ 308 h 776817"/>
+              <a:gd name="connsiteX3" fmla="*/ 5289755 w 12182168"/>
+              <a:gd name="connsiteY3" fmla="*/ 776748 h 776817"/>
+              <a:gd name="connsiteX4" fmla="*/ 7452852 w 12182168"/>
+              <a:gd name="connsiteY4" fmla="*/ 49161 h 776817"/>
+              <a:gd name="connsiteX5" fmla="*/ 8837364 w 12182168"/>
+              <a:gd name="connsiteY5" fmla="*/ 616512 h 776817"/>
+              <a:gd name="connsiteX6" fmla="*/ 10378124 w 12182168"/>
+              <a:gd name="connsiteY6" fmla="*/ 44704 h 776817"/>
+              <a:gd name="connsiteX7" fmla="*/ 11614768 w 12182168"/>
+              <a:gd name="connsiteY7" fmla="*/ 724207 h 776817"/>
+              <a:gd name="connsiteX8" fmla="*/ 12182168 w 12182168"/>
+              <a:gd name="connsiteY8" fmla="*/ 19665 h 776817"/>
+              <a:gd name="connsiteX0" fmla="*/ 0 w 12182168"/>
+              <a:gd name="connsiteY0" fmla="*/ 0 h 776817"/>
+              <a:gd name="connsiteX1" fmla="*/ 1516918 w 12182168"/>
+              <a:gd name="connsiteY1" fmla="*/ 757084 h 776817"/>
+              <a:gd name="connsiteX2" fmla="*/ 3078311 w 12182168"/>
+              <a:gd name="connsiteY2" fmla="*/ 308 h 776817"/>
+              <a:gd name="connsiteX3" fmla="*/ 5289755 w 12182168"/>
+              <a:gd name="connsiteY3" fmla="*/ 776748 h 776817"/>
+              <a:gd name="connsiteX4" fmla="*/ 7452852 w 12182168"/>
+              <a:gd name="connsiteY4" fmla="*/ 49161 h 776817"/>
+              <a:gd name="connsiteX5" fmla="*/ 8837364 w 12182168"/>
+              <a:gd name="connsiteY5" fmla="*/ 616512 h 776817"/>
+              <a:gd name="connsiteX6" fmla="*/ 10378124 w 12182168"/>
+              <a:gd name="connsiteY6" fmla="*/ 44704 h 776817"/>
+              <a:gd name="connsiteX7" fmla="*/ 11614768 w 12182168"/>
+              <a:gd name="connsiteY7" fmla="*/ 724207 h 776817"/>
+              <a:gd name="connsiteX8" fmla="*/ 12182168 w 12182168"/>
+              <a:gd name="connsiteY8" fmla="*/ 19665 h 776817"/>
+              <a:gd name="connsiteX0" fmla="*/ 0 w 12182168"/>
+              <a:gd name="connsiteY0" fmla="*/ 0 h 776817"/>
+              <a:gd name="connsiteX1" fmla="*/ 1516918 w 12182168"/>
+              <a:gd name="connsiteY1" fmla="*/ 757084 h 776817"/>
+              <a:gd name="connsiteX2" fmla="*/ 3078311 w 12182168"/>
+              <a:gd name="connsiteY2" fmla="*/ 308 h 776817"/>
+              <a:gd name="connsiteX3" fmla="*/ 5289755 w 12182168"/>
+              <a:gd name="connsiteY3" fmla="*/ 776748 h 776817"/>
+              <a:gd name="connsiteX4" fmla="*/ 7452852 w 12182168"/>
+              <a:gd name="connsiteY4" fmla="*/ 49161 h 776817"/>
+              <a:gd name="connsiteX5" fmla="*/ 8837364 w 12182168"/>
+              <a:gd name="connsiteY5" fmla="*/ 616512 h 776817"/>
+              <a:gd name="connsiteX6" fmla="*/ 10378124 w 12182168"/>
+              <a:gd name="connsiteY6" fmla="*/ 44704 h 776817"/>
+              <a:gd name="connsiteX7" fmla="*/ 11614768 w 12182168"/>
+              <a:gd name="connsiteY7" fmla="*/ 724207 h 776817"/>
+              <a:gd name="connsiteX8" fmla="*/ 12182168 w 12182168"/>
+              <a:gd name="connsiteY8" fmla="*/ 19665 h 776817"/>
+              <a:gd name="connsiteX0" fmla="*/ 0 w 12182168"/>
+              <a:gd name="connsiteY0" fmla="*/ 0 h 767293"/>
+              <a:gd name="connsiteX1" fmla="*/ 1516918 w 12182168"/>
+              <a:gd name="connsiteY1" fmla="*/ 757084 h 767293"/>
+              <a:gd name="connsiteX2" fmla="*/ 3078311 w 12182168"/>
+              <a:gd name="connsiteY2" fmla="*/ 308 h 767293"/>
+              <a:gd name="connsiteX3" fmla="*/ 4557513 w 12182168"/>
+              <a:gd name="connsiteY3" fmla="*/ 767223 h 767293"/>
+              <a:gd name="connsiteX4" fmla="*/ 7452852 w 12182168"/>
+              <a:gd name="connsiteY4" fmla="*/ 49161 h 767293"/>
+              <a:gd name="connsiteX5" fmla="*/ 8837364 w 12182168"/>
+              <a:gd name="connsiteY5" fmla="*/ 616512 h 767293"/>
+              <a:gd name="connsiteX6" fmla="*/ 10378124 w 12182168"/>
+              <a:gd name="connsiteY6" fmla="*/ 44704 h 767293"/>
+              <a:gd name="connsiteX7" fmla="*/ 11614768 w 12182168"/>
+              <a:gd name="connsiteY7" fmla="*/ 724207 h 767293"/>
+              <a:gd name="connsiteX8" fmla="*/ 12182168 w 12182168"/>
+              <a:gd name="connsiteY8" fmla="*/ 19665 h 767293"/>
+              <a:gd name="connsiteX0" fmla="*/ 0 w 12182168"/>
+              <a:gd name="connsiteY0" fmla="*/ 0 h 767223"/>
+              <a:gd name="connsiteX1" fmla="*/ 1516918 w 12182168"/>
+              <a:gd name="connsiteY1" fmla="*/ 757084 h 767223"/>
+              <a:gd name="connsiteX2" fmla="*/ 3078311 w 12182168"/>
+              <a:gd name="connsiteY2" fmla="*/ 308 h 767223"/>
+              <a:gd name="connsiteX3" fmla="*/ 4557513 w 12182168"/>
+              <a:gd name="connsiteY3" fmla="*/ 767223 h 767223"/>
+              <a:gd name="connsiteX4" fmla="*/ 6083464 w 12182168"/>
+              <a:gd name="connsiteY4" fmla="*/ 1536 h 767223"/>
+              <a:gd name="connsiteX5" fmla="*/ 8837364 w 12182168"/>
+              <a:gd name="connsiteY5" fmla="*/ 616512 h 767223"/>
+              <a:gd name="connsiteX6" fmla="*/ 10378124 w 12182168"/>
+              <a:gd name="connsiteY6" fmla="*/ 44704 h 767223"/>
+              <a:gd name="connsiteX7" fmla="*/ 11614768 w 12182168"/>
+              <a:gd name="connsiteY7" fmla="*/ 724207 h 767223"/>
+              <a:gd name="connsiteX8" fmla="*/ 12182168 w 12182168"/>
+              <a:gd name="connsiteY8" fmla="*/ 19665 h 767223"/>
+              <a:gd name="connsiteX0" fmla="*/ 0 w 12182168"/>
+              <a:gd name="connsiteY0" fmla="*/ 0 h 767223"/>
+              <a:gd name="connsiteX1" fmla="*/ 1516918 w 12182168"/>
+              <a:gd name="connsiteY1" fmla="*/ 757084 h 767223"/>
+              <a:gd name="connsiteX2" fmla="*/ 3078311 w 12182168"/>
+              <a:gd name="connsiteY2" fmla="*/ 308 h 767223"/>
+              <a:gd name="connsiteX3" fmla="*/ 4557513 w 12182168"/>
+              <a:gd name="connsiteY3" fmla="*/ 767223 h 767223"/>
+              <a:gd name="connsiteX4" fmla="*/ 6083464 w 12182168"/>
+              <a:gd name="connsiteY4" fmla="*/ 1536 h 767223"/>
+              <a:gd name="connsiteX5" fmla="*/ 7650560 w 12182168"/>
+              <a:gd name="connsiteY5" fmla="*/ 753672 h 767223"/>
+              <a:gd name="connsiteX6" fmla="*/ 10378124 w 12182168"/>
+              <a:gd name="connsiteY6" fmla="*/ 44704 h 767223"/>
+              <a:gd name="connsiteX7" fmla="*/ 11614768 w 12182168"/>
+              <a:gd name="connsiteY7" fmla="*/ 724207 h 767223"/>
+              <a:gd name="connsiteX8" fmla="*/ 12182168 w 12182168"/>
+              <a:gd name="connsiteY8" fmla="*/ 19665 h 767223"/>
+              <a:gd name="connsiteX0" fmla="*/ 0 w 12182168"/>
+              <a:gd name="connsiteY0" fmla="*/ 0 h 767223"/>
+              <a:gd name="connsiteX1" fmla="*/ 1516918 w 12182168"/>
+              <a:gd name="connsiteY1" fmla="*/ 757084 h 767223"/>
+              <a:gd name="connsiteX2" fmla="*/ 3078311 w 12182168"/>
+              <a:gd name="connsiteY2" fmla="*/ 308 h 767223"/>
+              <a:gd name="connsiteX3" fmla="*/ 4557513 w 12182168"/>
+              <a:gd name="connsiteY3" fmla="*/ 767223 h 767223"/>
+              <a:gd name="connsiteX4" fmla="*/ 6083464 w 12182168"/>
+              <a:gd name="connsiteY4" fmla="*/ 1536 h 767223"/>
+              <a:gd name="connsiteX5" fmla="*/ 7650560 w 12182168"/>
+              <a:gd name="connsiteY5" fmla="*/ 753672 h 767223"/>
+              <a:gd name="connsiteX6" fmla="*/ 9145674 w 12182168"/>
+              <a:gd name="connsiteY6" fmla="*/ 21844 h 767223"/>
+              <a:gd name="connsiteX7" fmla="*/ 11614768 w 12182168"/>
+              <a:gd name="connsiteY7" fmla="*/ 724207 h 767223"/>
+              <a:gd name="connsiteX8" fmla="*/ 12182168 w 12182168"/>
+              <a:gd name="connsiteY8" fmla="*/ 19665 h 767223"/>
+              <a:gd name="connsiteX0" fmla="*/ 0 w 12182168"/>
+              <a:gd name="connsiteY0" fmla="*/ 0 h 767223"/>
+              <a:gd name="connsiteX1" fmla="*/ 1516918 w 12182168"/>
+              <a:gd name="connsiteY1" fmla="*/ 757084 h 767223"/>
+              <a:gd name="connsiteX2" fmla="*/ 3078311 w 12182168"/>
+              <a:gd name="connsiteY2" fmla="*/ 308 h 767223"/>
+              <a:gd name="connsiteX3" fmla="*/ 4557513 w 12182168"/>
+              <a:gd name="connsiteY3" fmla="*/ 767223 h 767223"/>
+              <a:gd name="connsiteX4" fmla="*/ 6083464 w 12182168"/>
+              <a:gd name="connsiteY4" fmla="*/ 1536 h 767223"/>
+              <a:gd name="connsiteX5" fmla="*/ 7650560 w 12182168"/>
+              <a:gd name="connsiteY5" fmla="*/ 753672 h 767223"/>
+              <a:gd name="connsiteX6" fmla="*/ 9145674 w 12182168"/>
+              <a:gd name="connsiteY6" fmla="*/ 21844 h 767223"/>
+              <a:gd name="connsiteX7" fmla="*/ 10679019 w 12182168"/>
+              <a:gd name="connsiteY7" fmla="*/ 747067 h 767223"/>
+              <a:gd name="connsiteX8" fmla="*/ 12182168 w 12182168"/>
+              <a:gd name="connsiteY8" fmla="*/ 19665 h 767223"/>
+              <a:gd name="connsiteX0" fmla="*/ 0 w 12048819"/>
+              <a:gd name="connsiteY0" fmla="*/ 0 h 767223"/>
+              <a:gd name="connsiteX1" fmla="*/ 1383569 w 12048819"/>
+              <a:gd name="connsiteY1" fmla="*/ 757084 h 767223"/>
+              <a:gd name="connsiteX2" fmla="*/ 2944962 w 12048819"/>
+              <a:gd name="connsiteY2" fmla="*/ 308 h 767223"/>
+              <a:gd name="connsiteX3" fmla="*/ 4424164 w 12048819"/>
+              <a:gd name="connsiteY3" fmla="*/ 767223 h 767223"/>
+              <a:gd name="connsiteX4" fmla="*/ 5950115 w 12048819"/>
+              <a:gd name="connsiteY4" fmla="*/ 1536 h 767223"/>
+              <a:gd name="connsiteX5" fmla="*/ 7517211 w 12048819"/>
+              <a:gd name="connsiteY5" fmla="*/ 753672 h 767223"/>
+              <a:gd name="connsiteX6" fmla="*/ 9012325 w 12048819"/>
+              <a:gd name="connsiteY6" fmla="*/ 21844 h 767223"/>
+              <a:gd name="connsiteX7" fmla="*/ 10545670 w 12048819"/>
+              <a:gd name="connsiteY7" fmla="*/ 747067 h 767223"/>
+              <a:gd name="connsiteX8" fmla="*/ 12048819 w 12048819"/>
+              <a:gd name="connsiteY8" fmla="*/ 19665 h 767223"/>
+              <a:gd name="connsiteX0" fmla="*/ 0 w 12223197"/>
+              <a:gd name="connsiteY0" fmla="*/ 0 h 767223"/>
+              <a:gd name="connsiteX1" fmla="*/ 1557947 w 12223197"/>
+              <a:gd name="connsiteY1" fmla="*/ 757084 h 767223"/>
+              <a:gd name="connsiteX2" fmla="*/ 3119340 w 12223197"/>
+              <a:gd name="connsiteY2" fmla="*/ 308 h 767223"/>
+              <a:gd name="connsiteX3" fmla="*/ 4598542 w 12223197"/>
+              <a:gd name="connsiteY3" fmla="*/ 767223 h 767223"/>
+              <a:gd name="connsiteX4" fmla="*/ 6124493 w 12223197"/>
+              <a:gd name="connsiteY4" fmla="*/ 1536 h 767223"/>
+              <a:gd name="connsiteX5" fmla="*/ 7691589 w 12223197"/>
+              <a:gd name="connsiteY5" fmla="*/ 753672 h 767223"/>
+              <a:gd name="connsiteX6" fmla="*/ 9186703 w 12223197"/>
+              <a:gd name="connsiteY6" fmla="*/ 21844 h 767223"/>
+              <a:gd name="connsiteX7" fmla="*/ 10720048 w 12223197"/>
+              <a:gd name="connsiteY7" fmla="*/ 747067 h 767223"/>
+              <a:gd name="connsiteX8" fmla="*/ 12223197 w 12223197"/>
+              <a:gd name="connsiteY8" fmla="*/ 19665 h 767223"/>
+              <a:gd name="connsiteX0" fmla="*/ 0 w 12582213"/>
+              <a:gd name="connsiteY0" fmla="*/ 40792 h 766918"/>
+              <a:gd name="connsiteX1" fmla="*/ 1916963 w 12582213"/>
+              <a:gd name="connsiteY1" fmla="*/ 756779 h 766918"/>
+              <a:gd name="connsiteX2" fmla="*/ 3478356 w 12582213"/>
+              <a:gd name="connsiteY2" fmla="*/ 3 h 766918"/>
+              <a:gd name="connsiteX3" fmla="*/ 4957558 w 12582213"/>
+              <a:gd name="connsiteY3" fmla="*/ 766918 h 766918"/>
+              <a:gd name="connsiteX4" fmla="*/ 6483509 w 12582213"/>
+              <a:gd name="connsiteY4" fmla="*/ 1231 h 766918"/>
+              <a:gd name="connsiteX5" fmla="*/ 8050605 w 12582213"/>
+              <a:gd name="connsiteY5" fmla="*/ 753367 h 766918"/>
+              <a:gd name="connsiteX6" fmla="*/ 9545719 w 12582213"/>
+              <a:gd name="connsiteY6" fmla="*/ 21539 h 766918"/>
+              <a:gd name="connsiteX7" fmla="*/ 11079064 w 12582213"/>
+              <a:gd name="connsiteY7" fmla="*/ 746762 h 766918"/>
+              <a:gd name="connsiteX8" fmla="*/ 12582213 w 12582213"/>
+              <a:gd name="connsiteY8" fmla="*/ 19360 h 766918"/>
+              <a:gd name="connsiteX0" fmla="*/ 0 w 12571956"/>
+              <a:gd name="connsiteY0" fmla="*/ 0 h 798045"/>
+              <a:gd name="connsiteX1" fmla="*/ 1906706 w 12571956"/>
+              <a:gd name="connsiteY1" fmla="*/ 787906 h 798045"/>
+              <a:gd name="connsiteX2" fmla="*/ 3468099 w 12571956"/>
+              <a:gd name="connsiteY2" fmla="*/ 31130 h 798045"/>
+              <a:gd name="connsiteX3" fmla="*/ 4947301 w 12571956"/>
+              <a:gd name="connsiteY3" fmla="*/ 798045 h 798045"/>
+              <a:gd name="connsiteX4" fmla="*/ 6473252 w 12571956"/>
+              <a:gd name="connsiteY4" fmla="*/ 32358 h 798045"/>
+              <a:gd name="connsiteX5" fmla="*/ 8040348 w 12571956"/>
+              <a:gd name="connsiteY5" fmla="*/ 784494 h 798045"/>
+              <a:gd name="connsiteX6" fmla="*/ 9535462 w 12571956"/>
+              <a:gd name="connsiteY6" fmla="*/ 52666 h 798045"/>
+              <a:gd name="connsiteX7" fmla="*/ 11068807 w 12571956"/>
+              <a:gd name="connsiteY7" fmla="*/ 777889 h 798045"/>
+              <a:gd name="connsiteX8" fmla="*/ 12571956 w 12571956"/>
+              <a:gd name="connsiteY8" fmla="*/ 50487 h 798045"/>
+              <a:gd name="connsiteX0" fmla="*/ 0 w 12571956"/>
+              <a:gd name="connsiteY0" fmla="*/ 20243 h 766918"/>
+              <a:gd name="connsiteX1" fmla="*/ 1906706 w 12571956"/>
+              <a:gd name="connsiteY1" fmla="*/ 756779 h 766918"/>
+              <a:gd name="connsiteX2" fmla="*/ 3468099 w 12571956"/>
+              <a:gd name="connsiteY2" fmla="*/ 3 h 766918"/>
+              <a:gd name="connsiteX3" fmla="*/ 4947301 w 12571956"/>
+              <a:gd name="connsiteY3" fmla="*/ 766918 h 766918"/>
+              <a:gd name="connsiteX4" fmla="*/ 6473252 w 12571956"/>
+              <a:gd name="connsiteY4" fmla="*/ 1231 h 766918"/>
+              <a:gd name="connsiteX5" fmla="*/ 8040348 w 12571956"/>
+              <a:gd name="connsiteY5" fmla="*/ 753367 h 766918"/>
+              <a:gd name="connsiteX6" fmla="*/ 9535462 w 12571956"/>
+              <a:gd name="connsiteY6" fmla="*/ 21539 h 766918"/>
+              <a:gd name="connsiteX7" fmla="*/ 11068807 w 12571956"/>
+              <a:gd name="connsiteY7" fmla="*/ 746762 h 766918"/>
+              <a:gd name="connsiteX8" fmla="*/ 12571956 w 12571956"/>
+              <a:gd name="connsiteY8" fmla="*/ 19360 h 766918"/>
+              <a:gd name="connsiteX0" fmla="*/ 0 w 12571956"/>
+              <a:gd name="connsiteY0" fmla="*/ 0 h 777497"/>
+              <a:gd name="connsiteX1" fmla="*/ 1906706 w 12571956"/>
+              <a:gd name="connsiteY1" fmla="*/ 767358 h 777497"/>
+              <a:gd name="connsiteX2" fmla="*/ 3468099 w 12571956"/>
+              <a:gd name="connsiteY2" fmla="*/ 10582 h 777497"/>
+              <a:gd name="connsiteX3" fmla="*/ 4947301 w 12571956"/>
+              <a:gd name="connsiteY3" fmla="*/ 777497 h 777497"/>
+              <a:gd name="connsiteX4" fmla="*/ 6473252 w 12571956"/>
+              <a:gd name="connsiteY4" fmla="*/ 11810 h 777497"/>
+              <a:gd name="connsiteX5" fmla="*/ 8040348 w 12571956"/>
+              <a:gd name="connsiteY5" fmla="*/ 763946 h 777497"/>
+              <a:gd name="connsiteX6" fmla="*/ 9535462 w 12571956"/>
+              <a:gd name="connsiteY6" fmla="*/ 32118 h 777497"/>
+              <a:gd name="connsiteX7" fmla="*/ 11068807 w 12571956"/>
+              <a:gd name="connsiteY7" fmla="*/ 757341 h 777497"/>
+              <a:gd name="connsiteX8" fmla="*/ 12571956 w 12571956"/>
+              <a:gd name="connsiteY8" fmla="*/ 29939 h 777497"/>
+              <a:gd name="connsiteX0" fmla="*/ 0 w 12212940"/>
+              <a:gd name="connsiteY0" fmla="*/ 30517 h 766918"/>
+              <a:gd name="connsiteX1" fmla="*/ 1547690 w 12212940"/>
+              <a:gd name="connsiteY1" fmla="*/ 756779 h 766918"/>
+              <a:gd name="connsiteX2" fmla="*/ 3109083 w 12212940"/>
+              <a:gd name="connsiteY2" fmla="*/ 3 h 766918"/>
+              <a:gd name="connsiteX3" fmla="*/ 4588285 w 12212940"/>
+              <a:gd name="connsiteY3" fmla="*/ 766918 h 766918"/>
+              <a:gd name="connsiteX4" fmla="*/ 6114236 w 12212940"/>
+              <a:gd name="connsiteY4" fmla="*/ 1231 h 766918"/>
+              <a:gd name="connsiteX5" fmla="*/ 7681332 w 12212940"/>
+              <a:gd name="connsiteY5" fmla="*/ 753367 h 766918"/>
+              <a:gd name="connsiteX6" fmla="*/ 9176446 w 12212940"/>
+              <a:gd name="connsiteY6" fmla="*/ 21539 h 766918"/>
+              <a:gd name="connsiteX7" fmla="*/ 10709791 w 12212940"/>
+              <a:gd name="connsiteY7" fmla="*/ 746762 h 766918"/>
+              <a:gd name="connsiteX8" fmla="*/ 12212940 w 12212940"/>
+              <a:gd name="connsiteY8" fmla="*/ 19360 h 766918"/>
+              <a:gd name="connsiteX0" fmla="*/ 0 w 12161653"/>
+              <a:gd name="connsiteY0" fmla="*/ 9969 h 766918"/>
+              <a:gd name="connsiteX1" fmla="*/ 1496403 w 12161653"/>
+              <a:gd name="connsiteY1" fmla="*/ 756779 h 766918"/>
+              <a:gd name="connsiteX2" fmla="*/ 3057796 w 12161653"/>
+              <a:gd name="connsiteY2" fmla="*/ 3 h 766918"/>
+              <a:gd name="connsiteX3" fmla="*/ 4536998 w 12161653"/>
+              <a:gd name="connsiteY3" fmla="*/ 766918 h 766918"/>
+              <a:gd name="connsiteX4" fmla="*/ 6062949 w 12161653"/>
+              <a:gd name="connsiteY4" fmla="*/ 1231 h 766918"/>
+              <a:gd name="connsiteX5" fmla="*/ 7630045 w 12161653"/>
+              <a:gd name="connsiteY5" fmla="*/ 753367 h 766918"/>
+              <a:gd name="connsiteX6" fmla="*/ 9125159 w 12161653"/>
+              <a:gd name="connsiteY6" fmla="*/ 21539 h 766918"/>
+              <a:gd name="connsiteX7" fmla="*/ 10658504 w 12161653"/>
+              <a:gd name="connsiteY7" fmla="*/ 746762 h 766918"/>
+              <a:gd name="connsiteX8" fmla="*/ 12161653 w 12161653"/>
+              <a:gd name="connsiteY8" fmla="*/ 19360 h 766918"/>
+              <a:gd name="connsiteX0" fmla="*/ 0 w 12161653"/>
+              <a:gd name="connsiteY0" fmla="*/ 9969 h 766918"/>
+              <a:gd name="connsiteX1" fmla="*/ 1496403 w 12161653"/>
+              <a:gd name="connsiteY1" fmla="*/ 756779 h 766918"/>
+              <a:gd name="connsiteX2" fmla="*/ 3027023 w 12161653"/>
+              <a:gd name="connsiteY2" fmla="*/ 3 h 766918"/>
+              <a:gd name="connsiteX3" fmla="*/ 4536998 w 12161653"/>
+              <a:gd name="connsiteY3" fmla="*/ 766918 h 766918"/>
+              <a:gd name="connsiteX4" fmla="*/ 6062949 w 12161653"/>
+              <a:gd name="connsiteY4" fmla="*/ 1231 h 766918"/>
+              <a:gd name="connsiteX5" fmla="*/ 7630045 w 12161653"/>
+              <a:gd name="connsiteY5" fmla="*/ 753367 h 766918"/>
+              <a:gd name="connsiteX6" fmla="*/ 9125159 w 12161653"/>
+              <a:gd name="connsiteY6" fmla="*/ 21539 h 766918"/>
+              <a:gd name="connsiteX7" fmla="*/ 10658504 w 12161653"/>
+              <a:gd name="connsiteY7" fmla="*/ 746762 h 766918"/>
+              <a:gd name="connsiteX8" fmla="*/ 12161653 w 12161653"/>
+              <a:gd name="connsiteY8" fmla="*/ 19360 h 766918"/>
+              <a:gd name="connsiteX0" fmla="*/ 0 w 12161653"/>
+              <a:gd name="connsiteY0" fmla="*/ 9969 h 766918"/>
+              <a:gd name="connsiteX1" fmla="*/ 1496403 w 12161653"/>
+              <a:gd name="connsiteY1" fmla="*/ 756779 h 766918"/>
+              <a:gd name="connsiteX2" fmla="*/ 3027023 w 12161653"/>
+              <a:gd name="connsiteY2" fmla="*/ 3 h 766918"/>
+              <a:gd name="connsiteX3" fmla="*/ 4536998 w 12161653"/>
+              <a:gd name="connsiteY3" fmla="*/ 766918 h 766918"/>
+              <a:gd name="connsiteX4" fmla="*/ 6062949 w 12161653"/>
+              <a:gd name="connsiteY4" fmla="*/ 1231 h 766918"/>
+              <a:gd name="connsiteX5" fmla="*/ 7630045 w 12161653"/>
+              <a:gd name="connsiteY5" fmla="*/ 753367 h 766918"/>
+              <a:gd name="connsiteX6" fmla="*/ 9125159 w 12161653"/>
+              <a:gd name="connsiteY6" fmla="*/ 21539 h 766918"/>
+              <a:gd name="connsiteX7" fmla="*/ 10658504 w 12161653"/>
+              <a:gd name="connsiteY7" fmla="*/ 746762 h 766918"/>
+              <a:gd name="connsiteX8" fmla="*/ 12161653 w 12161653"/>
+              <a:gd name="connsiteY8" fmla="*/ 19360 h 766918"/>
+              <a:gd name="connsiteX0" fmla="*/ 1412 w 12163065"/>
+              <a:gd name="connsiteY0" fmla="*/ 9969 h 766918"/>
+              <a:gd name="connsiteX1" fmla="*/ 1497815 w 12163065"/>
+              <a:gd name="connsiteY1" fmla="*/ 756779 h 766918"/>
+              <a:gd name="connsiteX2" fmla="*/ 3028435 w 12163065"/>
+              <a:gd name="connsiteY2" fmla="*/ 3 h 766918"/>
+              <a:gd name="connsiteX3" fmla="*/ 4538410 w 12163065"/>
+              <a:gd name="connsiteY3" fmla="*/ 766918 h 766918"/>
+              <a:gd name="connsiteX4" fmla="*/ 6064361 w 12163065"/>
+              <a:gd name="connsiteY4" fmla="*/ 1231 h 766918"/>
+              <a:gd name="connsiteX5" fmla="*/ 7631457 w 12163065"/>
+              <a:gd name="connsiteY5" fmla="*/ 753367 h 766918"/>
+              <a:gd name="connsiteX6" fmla="*/ 9126571 w 12163065"/>
+              <a:gd name="connsiteY6" fmla="*/ 21539 h 766918"/>
+              <a:gd name="connsiteX7" fmla="*/ 10659916 w 12163065"/>
+              <a:gd name="connsiteY7" fmla="*/ 746762 h 766918"/>
+              <a:gd name="connsiteX8" fmla="*/ 12163065 w 12163065"/>
+              <a:gd name="connsiteY8" fmla="*/ 19360 h 766918"/>
+              <a:gd name="connsiteX0" fmla="*/ 0 w 12161653"/>
+              <a:gd name="connsiteY0" fmla="*/ 9969 h 766918"/>
+              <a:gd name="connsiteX1" fmla="*/ 1496403 w 12161653"/>
+              <a:gd name="connsiteY1" fmla="*/ 756779 h 766918"/>
+              <a:gd name="connsiteX2" fmla="*/ 3027023 w 12161653"/>
+              <a:gd name="connsiteY2" fmla="*/ 3 h 766918"/>
+              <a:gd name="connsiteX3" fmla="*/ 4536998 w 12161653"/>
+              <a:gd name="connsiteY3" fmla="*/ 766918 h 766918"/>
+              <a:gd name="connsiteX4" fmla="*/ 6062949 w 12161653"/>
+              <a:gd name="connsiteY4" fmla="*/ 1231 h 766918"/>
+              <a:gd name="connsiteX5" fmla="*/ 7630045 w 12161653"/>
+              <a:gd name="connsiteY5" fmla="*/ 753367 h 766918"/>
+              <a:gd name="connsiteX6" fmla="*/ 9125159 w 12161653"/>
+              <a:gd name="connsiteY6" fmla="*/ 21539 h 766918"/>
+              <a:gd name="connsiteX7" fmla="*/ 10658504 w 12161653"/>
+              <a:gd name="connsiteY7" fmla="*/ 746762 h 766918"/>
+              <a:gd name="connsiteX8" fmla="*/ 12161653 w 12161653"/>
+              <a:gd name="connsiteY8" fmla="*/ 19360 h 766918"/>
+              <a:gd name="connsiteX0" fmla="*/ 0 w 12161653"/>
+              <a:gd name="connsiteY0" fmla="*/ 16526 h 773475"/>
+              <a:gd name="connsiteX1" fmla="*/ 1496403 w 12161653"/>
+              <a:gd name="connsiteY1" fmla="*/ 383192 h 773475"/>
+              <a:gd name="connsiteX2" fmla="*/ 3027023 w 12161653"/>
+              <a:gd name="connsiteY2" fmla="*/ 6560 h 773475"/>
+              <a:gd name="connsiteX3" fmla="*/ 4536998 w 12161653"/>
+              <a:gd name="connsiteY3" fmla="*/ 773475 h 773475"/>
+              <a:gd name="connsiteX4" fmla="*/ 6062949 w 12161653"/>
+              <a:gd name="connsiteY4" fmla="*/ 7788 h 773475"/>
+              <a:gd name="connsiteX5" fmla="*/ 7630045 w 12161653"/>
+              <a:gd name="connsiteY5" fmla="*/ 759924 h 773475"/>
+              <a:gd name="connsiteX6" fmla="*/ 9125159 w 12161653"/>
+              <a:gd name="connsiteY6" fmla="*/ 28096 h 773475"/>
+              <a:gd name="connsiteX7" fmla="*/ 10658504 w 12161653"/>
+              <a:gd name="connsiteY7" fmla="*/ 753319 h 773475"/>
+              <a:gd name="connsiteX8" fmla="*/ 12161653 w 12161653"/>
+              <a:gd name="connsiteY8" fmla="*/ 25917 h 773475"/>
+              <a:gd name="connsiteX0" fmla="*/ 0 w 12161653"/>
+              <a:gd name="connsiteY0" fmla="*/ 16526 h 773475"/>
+              <a:gd name="connsiteX1" fmla="*/ 1496403 w 12161653"/>
+              <a:gd name="connsiteY1" fmla="*/ 383192 h 773475"/>
+              <a:gd name="connsiteX2" fmla="*/ 3027023 w 12161653"/>
+              <a:gd name="connsiteY2" fmla="*/ 6560 h 773475"/>
+              <a:gd name="connsiteX3" fmla="*/ 4536998 w 12161653"/>
+              <a:gd name="connsiteY3" fmla="*/ 773475 h 773475"/>
+              <a:gd name="connsiteX4" fmla="*/ 6062949 w 12161653"/>
+              <a:gd name="connsiteY4" fmla="*/ 7788 h 773475"/>
+              <a:gd name="connsiteX5" fmla="*/ 7630045 w 12161653"/>
+              <a:gd name="connsiteY5" fmla="*/ 759924 h 773475"/>
+              <a:gd name="connsiteX6" fmla="*/ 9125159 w 12161653"/>
+              <a:gd name="connsiteY6" fmla="*/ 28096 h 773475"/>
+              <a:gd name="connsiteX7" fmla="*/ 10658504 w 12161653"/>
+              <a:gd name="connsiteY7" fmla="*/ 753319 h 773475"/>
+              <a:gd name="connsiteX8" fmla="*/ 12161653 w 12161653"/>
+              <a:gd name="connsiteY8" fmla="*/ 25917 h 773475"/>
+              <a:gd name="connsiteX0" fmla="*/ 0 w 12161653"/>
+              <a:gd name="connsiteY0" fmla="*/ 13702 h 757111"/>
+              <a:gd name="connsiteX1" fmla="*/ 1496403 w 12161653"/>
+              <a:gd name="connsiteY1" fmla="*/ 380368 h 757111"/>
+              <a:gd name="connsiteX2" fmla="*/ 3027023 w 12161653"/>
+              <a:gd name="connsiteY2" fmla="*/ 3736 h 757111"/>
+              <a:gd name="connsiteX3" fmla="*/ 4536998 w 12161653"/>
+              <a:gd name="connsiteY3" fmla="*/ 411056 h 757111"/>
+              <a:gd name="connsiteX4" fmla="*/ 6062949 w 12161653"/>
+              <a:gd name="connsiteY4" fmla="*/ 4964 h 757111"/>
+              <a:gd name="connsiteX5" fmla="*/ 7630045 w 12161653"/>
+              <a:gd name="connsiteY5" fmla="*/ 757100 h 757111"/>
+              <a:gd name="connsiteX6" fmla="*/ 9125159 w 12161653"/>
+              <a:gd name="connsiteY6" fmla="*/ 25272 h 757111"/>
+              <a:gd name="connsiteX7" fmla="*/ 10658504 w 12161653"/>
+              <a:gd name="connsiteY7" fmla="*/ 750495 h 757111"/>
+              <a:gd name="connsiteX8" fmla="*/ 12161653 w 12161653"/>
+              <a:gd name="connsiteY8" fmla="*/ 23093 h 757111"/>
+              <a:gd name="connsiteX0" fmla="*/ 0 w 12161653"/>
+              <a:gd name="connsiteY0" fmla="*/ 10018 h 746811"/>
+              <a:gd name="connsiteX1" fmla="*/ 1496403 w 12161653"/>
+              <a:gd name="connsiteY1" fmla="*/ 376684 h 746811"/>
+              <a:gd name="connsiteX2" fmla="*/ 3027023 w 12161653"/>
+              <a:gd name="connsiteY2" fmla="*/ 52 h 746811"/>
+              <a:gd name="connsiteX3" fmla="*/ 4536998 w 12161653"/>
+              <a:gd name="connsiteY3" fmla="*/ 407372 h 746811"/>
+              <a:gd name="connsiteX4" fmla="*/ 6062949 w 12161653"/>
+              <a:gd name="connsiteY4" fmla="*/ 1280 h 746811"/>
+              <a:gd name="connsiteX5" fmla="*/ 7609531 w 12161653"/>
+              <a:gd name="connsiteY5" fmla="*/ 414369 h 746811"/>
+              <a:gd name="connsiteX6" fmla="*/ 9125159 w 12161653"/>
+              <a:gd name="connsiteY6" fmla="*/ 21588 h 746811"/>
+              <a:gd name="connsiteX7" fmla="*/ 10658504 w 12161653"/>
+              <a:gd name="connsiteY7" fmla="*/ 746811 h 746811"/>
+              <a:gd name="connsiteX8" fmla="*/ 12161653 w 12161653"/>
+              <a:gd name="connsiteY8" fmla="*/ 19409 h 746811"/>
+              <a:gd name="connsiteX0" fmla="*/ 0 w 12161653"/>
+              <a:gd name="connsiteY0" fmla="*/ 10018 h 414390"/>
+              <a:gd name="connsiteX1" fmla="*/ 1496403 w 12161653"/>
+              <a:gd name="connsiteY1" fmla="*/ 376684 h 414390"/>
+              <a:gd name="connsiteX2" fmla="*/ 3027023 w 12161653"/>
+              <a:gd name="connsiteY2" fmla="*/ 52 h 414390"/>
+              <a:gd name="connsiteX3" fmla="*/ 4536998 w 12161653"/>
+              <a:gd name="connsiteY3" fmla="*/ 407372 h 414390"/>
+              <a:gd name="connsiteX4" fmla="*/ 6062949 w 12161653"/>
+              <a:gd name="connsiteY4" fmla="*/ 1280 h 414390"/>
+              <a:gd name="connsiteX5" fmla="*/ 7609531 w 12161653"/>
+              <a:gd name="connsiteY5" fmla="*/ 414369 h 414390"/>
+              <a:gd name="connsiteX6" fmla="*/ 9125159 w 12161653"/>
+              <a:gd name="connsiteY6" fmla="*/ 21588 h 414390"/>
+              <a:gd name="connsiteX7" fmla="*/ 10637989 w 12161653"/>
+              <a:gd name="connsiteY7" fmla="*/ 407763 h 414390"/>
+              <a:gd name="connsiteX8" fmla="*/ 12161653 w 12161653"/>
+              <a:gd name="connsiteY8" fmla="*/ 19409 h 414390"/>
+              <a:gd name="connsiteX0" fmla="*/ 0 w 12161653"/>
+              <a:gd name="connsiteY0" fmla="*/ 10018 h 479682"/>
+              <a:gd name="connsiteX1" fmla="*/ 1496403 w 12161653"/>
+              <a:gd name="connsiteY1" fmla="*/ 376684 h 479682"/>
+              <a:gd name="connsiteX2" fmla="*/ 3027023 w 12161653"/>
+              <a:gd name="connsiteY2" fmla="*/ 52 h 479682"/>
+              <a:gd name="connsiteX3" fmla="*/ 4536998 w 12161653"/>
+              <a:gd name="connsiteY3" fmla="*/ 407372 h 479682"/>
+              <a:gd name="connsiteX4" fmla="*/ 6062949 w 12161653"/>
+              <a:gd name="connsiteY4" fmla="*/ 1280 h 479682"/>
+              <a:gd name="connsiteX5" fmla="*/ 7609531 w 12161653"/>
+              <a:gd name="connsiteY5" fmla="*/ 414369 h 479682"/>
+              <a:gd name="connsiteX6" fmla="*/ 9125159 w 12161653"/>
+              <a:gd name="connsiteY6" fmla="*/ 21588 h 479682"/>
+              <a:gd name="connsiteX7" fmla="*/ 10637989 w 12161653"/>
+              <a:gd name="connsiteY7" fmla="*/ 479682 h 479682"/>
+              <a:gd name="connsiteX8" fmla="*/ 12161653 w 12161653"/>
+              <a:gd name="connsiteY8" fmla="*/ 19409 h 479682"/>
+              <a:gd name="connsiteX0" fmla="*/ 430 w 12162083"/>
+              <a:gd name="connsiteY0" fmla="*/ 10018 h 479682"/>
+              <a:gd name="connsiteX1" fmla="*/ 1496833 w 12162083"/>
+              <a:gd name="connsiteY1" fmla="*/ 376684 h 479682"/>
+              <a:gd name="connsiteX2" fmla="*/ 3027453 w 12162083"/>
+              <a:gd name="connsiteY2" fmla="*/ 52 h 479682"/>
+              <a:gd name="connsiteX3" fmla="*/ 4537428 w 12162083"/>
+              <a:gd name="connsiteY3" fmla="*/ 407372 h 479682"/>
+              <a:gd name="connsiteX4" fmla="*/ 6063379 w 12162083"/>
+              <a:gd name="connsiteY4" fmla="*/ 1280 h 479682"/>
+              <a:gd name="connsiteX5" fmla="*/ 7609961 w 12162083"/>
+              <a:gd name="connsiteY5" fmla="*/ 414369 h 479682"/>
+              <a:gd name="connsiteX6" fmla="*/ 9125589 w 12162083"/>
+              <a:gd name="connsiteY6" fmla="*/ 21588 h 479682"/>
+              <a:gd name="connsiteX7" fmla="*/ 10638419 w 12162083"/>
+              <a:gd name="connsiteY7" fmla="*/ 479682 h 479682"/>
+              <a:gd name="connsiteX8" fmla="*/ 12162083 w 12162083"/>
+              <a:gd name="connsiteY8" fmla="*/ 19409 h 479682"/>
+              <a:gd name="connsiteX0" fmla="*/ 430 w 12162083"/>
+              <a:gd name="connsiteY0" fmla="*/ 10043 h 479707"/>
+              <a:gd name="connsiteX1" fmla="*/ 1496833 w 12162083"/>
+              <a:gd name="connsiteY1" fmla="*/ 376709 h 479707"/>
+              <a:gd name="connsiteX2" fmla="*/ 3027453 w 12162083"/>
+              <a:gd name="connsiteY2" fmla="*/ 77 h 479707"/>
+              <a:gd name="connsiteX3" fmla="*/ 4563580 w 12162083"/>
+              <a:gd name="connsiteY3" fmla="*/ 414541 h 479707"/>
+              <a:gd name="connsiteX4" fmla="*/ 6063379 w 12162083"/>
+              <a:gd name="connsiteY4" fmla="*/ 1305 h 479707"/>
+              <a:gd name="connsiteX5" fmla="*/ 7609961 w 12162083"/>
+              <a:gd name="connsiteY5" fmla="*/ 414394 h 479707"/>
+              <a:gd name="connsiteX6" fmla="*/ 9125589 w 12162083"/>
+              <a:gd name="connsiteY6" fmla="*/ 21613 h 479707"/>
+              <a:gd name="connsiteX7" fmla="*/ 10638419 w 12162083"/>
+              <a:gd name="connsiteY7" fmla="*/ 479707 h 479707"/>
+              <a:gd name="connsiteX8" fmla="*/ 12162083 w 12162083"/>
+              <a:gd name="connsiteY8" fmla="*/ 19434 h 479707"/>
+              <a:gd name="connsiteX0" fmla="*/ 430 w 12162083"/>
+              <a:gd name="connsiteY0" fmla="*/ 10053 h 479717"/>
+              <a:gd name="connsiteX1" fmla="*/ 1496833 w 12162083"/>
+              <a:gd name="connsiteY1" fmla="*/ 376719 h 479717"/>
+              <a:gd name="connsiteX2" fmla="*/ 3027453 w 12162083"/>
+              <a:gd name="connsiteY2" fmla="*/ 87 h 479717"/>
+              <a:gd name="connsiteX3" fmla="*/ 4539805 w 12162083"/>
+              <a:gd name="connsiteY3" fmla="*/ 416932 h 479717"/>
+              <a:gd name="connsiteX4" fmla="*/ 6063379 w 12162083"/>
+              <a:gd name="connsiteY4" fmla="*/ 1315 h 479717"/>
+              <a:gd name="connsiteX5" fmla="*/ 7609961 w 12162083"/>
+              <a:gd name="connsiteY5" fmla="*/ 414404 h 479717"/>
+              <a:gd name="connsiteX6" fmla="*/ 9125589 w 12162083"/>
+              <a:gd name="connsiteY6" fmla="*/ 21623 h 479717"/>
+              <a:gd name="connsiteX7" fmla="*/ 10638419 w 12162083"/>
+              <a:gd name="connsiteY7" fmla="*/ 479717 h 479717"/>
+              <a:gd name="connsiteX8" fmla="*/ 12162083 w 12162083"/>
+              <a:gd name="connsiteY8" fmla="*/ 19444 h 479717"/>
+              <a:gd name="connsiteX0" fmla="*/ 430 w 12162083"/>
+              <a:gd name="connsiteY0" fmla="*/ 10063 h 479727"/>
+              <a:gd name="connsiteX1" fmla="*/ 1496833 w 12162083"/>
+              <a:gd name="connsiteY1" fmla="*/ 376729 h 479727"/>
+              <a:gd name="connsiteX2" fmla="*/ 3027453 w 12162083"/>
+              <a:gd name="connsiteY2" fmla="*/ 97 h 479727"/>
+              <a:gd name="connsiteX3" fmla="*/ 4549315 w 12162083"/>
+              <a:gd name="connsiteY3" fmla="*/ 419323 h 479727"/>
+              <a:gd name="connsiteX4" fmla="*/ 6063379 w 12162083"/>
+              <a:gd name="connsiteY4" fmla="*/ 1325 h 479727"/>
+              <a:gd name="connsiteX5" fmla="*/ 7609961 w 12162083"/>
+              <a:gd name="connsiteY5" fmla="*/ 414414 h 479727"/>
+              <a:gd name="connsiteX6" fmla="*/ 9125589 w 12162083"/>
+              <a:gd name="connsiteY6" fmla="*/ 21633 h 479727"/>
+              <a:gd name="connsiteX7" fmla="*/ 10638419 w 12162083"/>
+              <a:gd name="connsiteY7" fmla="*/ 479727 h 479727"/>
+              <a:gd name="connsiteX8" fmla="*/ 12162083 w 12162083"/>
+              <a:gd name="connsiteY8" fmla="*/ 19454 h 479727"/>
+              <a:gd name="connsiteX0" fmla="*/ 428 w 12162081"/>
+              <a:gd name="connsiteY0" fmla="*/ 9967 h 479631"/>
+              <a:gd name="connsiteX1" fmla="*/ 1503962 w 12162081"/>
+              <a:gd name="connsiteY1" fmla="*/ 419496 h 479631"/>
+              <a:gd name="connsiteX2" fmla="*/ 3027451 w 12162081"/>
+              <a:gd name="connsiteY2" fmla="*/ 1 h 479631"/>
+              <a:gd name="connsiteX3" fmla="*/ 4549313 w 12162081"/>
+              <a:gd name="connsiteY3" fmla="*/ 419227 h 479631"/>
+              <a:gd name="connsiteX4" fmla="*/ 6063377 w 12162081"/>
+              <a:gd name="connsiteY4" fmla="*/ 1229 h 479631"/>
+              <a:gd name="connsiteX5" fmla="*/ 7609959 w 12162081"/>
+              <a:gd name="connsiteY5" fmla="*/ 414318 h 479631"/>
+              <a:gd name="connsiteX6" fmla="*/ 9125587 w 12162081"/>
+              <a:gd name="connsiteY6" fmla="*/ 21537 h 479631"/>
+              <a:gd name="connsiteX7" fmla="*/ 10638417 w 12162081"/>
+              <a:gd name="connsiteY7" fmla="*/ 479631 h 479631"/>
+              <a:gd name="connsiteX8" fmla="*/ 12162081 w 12162081"/>
+              <a:gd name="connsiteY8" fmla="*/ 19358 h 479631"/>
+              <a:gd name="connsiteX0" fmla="*/ 428 w 12162081"/>
+              <a:gd name="connsiteY0" fmla="*/ 9967 h 419500"/>
+              <a:gd name="connsiteX1" fmla="*/ 1503962 w 12162081"/>
+              <a:gd name="connsiteY1" fmla="*/ 419496 h 419500"/>
+              <a:gd name="connsiteX2" fmla="*/ 3027451 w 12162081"/>
+              <a:gd name="connsiteY2" fmla="*/ 1 h 419500"/>
+              <a:gd name="connsiteX3" fmla="*/ 4549313 w 12162081"/>
+              <a:gd name="connsiteY3" fmla="*/ 419227 h 419500"/>
+              <a:gd name="connsiteX4" fmla="*/ 6063377 w 12162081"/>
+              <a:gd name="connsiteY4" fmla="*/ 1229 h 419500"/>
+              <a:gd name="connsiteX5" fmla="*/ 7609959 w 12162081"/>
+              <a:gd name="connsiteY5" fmla="*/ 414318 h 419500"/>
+              <a:gd name="connsiteX6" fmla="*/ 9125587 w 12162081"/>
+              <a:gd name="connsiteY6" fmla="*/ 21537 h 419500"/>
+              <a:gd name="connsiteX7" fmla="*/ 10626531 w 12162081"/>
+              <a:gd name="connsiteY7" fmla="*/ 417718 h 419500"/>
+              <a:gd name="connsiteX8" fmla="*/ 12162081 w 12162081"/>
+              <a:gd name="connsiteY8" fmla="*/ 19358 h 419500"/>
+              <a:gd name="connsiteX0" fmla="*/ 428 w 12162081"/>
+              <a:gd name="connsiteY0" fmla="*/ 9967 h 422480"/>
+              <a:gd name="connsiteX1" fmla="*/ 1503962 w 12162081"/>
+              <a:gd name="connsiteY1" fmla="*/ 419496 h 422480"/>
+              <a:gd name="connsiteX2" fmla="*/ 3027451 w 12162081"/>
+              <a:gd name="connsiteY2" fmla="*/ 1 h 422480"/>
+              <a:gd name="connsiteX3" fmla="*/ 4549313 w 12162081"/>
+              <a:gd name="connsiteY3" fmla="*/ 419227 h 422480"/>
+              <a:gd name="connsiteX4" fmla="*/ 6063377 w 12162081"/>
+              <a:gd name="connsiteY4" fmla="*/ 1229 h 422480"/>
+              <a:gd name="connsiteX5" fmla="*/ 7609959 w 12162081"/>
+              <a:gd name="connsiteY5" fmla="*/ 414318 h 422480"/>
+              <a:gd name="connsiteX6" fmla="*/ 9125587 w 12162081"/>
+              <a:gd name="connsiteY6" fmla="*/ 21537 h 422480"/>
+              <a:gd name="connsiteX7" fmla="*/ 10650304 w 12162081"/>
+              <a:gd name="connsiteY7" fmla="*/ 422480 h 422480"/>
+              <a:gd name="connsiteX8" fmla="*/ 12162081 w 12162081"/>
+              <a:gd name="connsiteY8" fmla="*/ 19358 h 422480"/>
+              <a:gd name="connsiteX0" fmla="*/ 428 w 12162081"/>
+              <a:gd name="connsiteY0" fmla="*/ 9967 h 422480"/>
+              <a:gd name="connsiteX1" fmla="*/ 1503962 w 12162081"/>
+              <a:gd name="connsiteY1" fmla="*/ 419496 h 422480"/>
+              <a:gd name="connsiteX2" fmla="*/ 3027451 w 12162081"/>
+              <a:gd name="connsiteY2" fmla="*/ 1 h 422480"/>
+              <a:gd name="connsiteX3" fmla="*/ 4549313 w 12162081"/>
+              <a:gd name="connsiteY3" fmla="*/ 419227 h 422480"/>
+              <a:gd name="connsiteX4" fmla="*/ 6063377 w 12162081"/>
+              <a:gd name="connsiteY4" fmla="*/ 1229 h 422480"/>
+              <a:gd name="connsiteX5" fmla="*/ 7609959 w 12162081"/>
+              <a:gd name="connsiteY5" fmla="*/ 414318 h 422480"/>
+              <a:gd name="connsiteX6" fmla="*/ 9125587 w 12162081"/>
+              <a:gd name="connsiteY6" fmla="*/ 21537 h 422480"/>
+              <a:gd name="connsiteX7" fmla="*/ 10640795 w 12162081"/>
+              <a:gd name="connsiteY7" fmla="*/ 422480 h 422480"/>
+              <a:gd name="connsiteX8" fmla="*/ 12162081 w 12162081"/>
+              <a:gd name="connsiteY8" fmla="*/ 19358 h 422480"/>
+              <a:gd name="connsiteX0" fmla="*/ 428 w 12162081"/>
+              <a:gd name="connsiteY0" fmla="*/ 9967 h 422480"/>
+              <a:gd name="connsiteX1" fmla="*/ 1503962 w 12162081"/>
+              <a:gd name="connsiteY1" fmla="*/ 419496 h 422480"/>
+              <a:gd name="connsiteX2" fmla="*/ 3027451 w 12162081"/>
+              <a:gd name="connsiteY2" fmla="*/ 1 h 422480"/>
+              <a:gd name="connsiteX3" fmla="*/ 4549313 w 12162081"/>
+              <a:gd name="connsiteY3" fmla="*/ 419227 h 422480"/>
+              <a:gd name="connsiteX4" fmla="*/ 6063377 w 12162081"/>
+              <a:gd name="connsiteY4" fmla="*/ 1229 h 422480"/>
+              <a:gd name="connsiteX5" fmla="*/ 7598073 w 12162081"/>
+              <a:gd name="connsiteY5" fmla="*/ 414318 h 422480"/>
+              <a:gd name="connsiteX6" fmla="*/ 9125587 w 12162081"/>
+              <a:gd name="connsiteY6" fmla="*/ 21537 h 422480"/>
+              <a:gd name="connsiteX7" fmla="*/ 10640795 w 12162081"/>
+              <a:gd name="connsiteY7" fmla="*/ 422480 h 422480"/>
+              <a:gd name="connsiteX8" fmla="*/ 12162081 w 12162081"/>
+              <a:gd name="connsiteY8" fmla="*/ 19358 h 422480"/>
+              <a:gd name="connsiteX0" fmla="*/ 428 w 12162081"/>
+              <a:gd name="connsiteY0" fmla="*/ 9967 h 422480"/>
+              <a:gd name="connsiteX1" fmla="*/ 1503962 w 12162081"/>
+              <a:gd name="connsiteY1" fmla="*/ 419496 h 422480"/>
+              <a:gd name="connsiteX2" fmla="*/ 3027451 w 12162081"/>
+              <a:gd name="connsiteY2" fmla="*/ 1 h 422480"/>
+              <a:gd name="connsiteX3" fmla="*/ 4549313 w 12162081"/>
+              <a:gd name="connsiteY3" fmla="*/ 419227 h 422480"/>
+              <a:gd name="connsiteX4" fmla="*/ 6063377 w 12162081"/>
+              <a:gd name="connsiteY4" fmla="*/ 1229 h 422480"/>
+              <a:gd name="connsiteX5" fmla="*/ 7595696 w 12162081"/>
+              <a:gd name="connsiteY5" fmla="*/ 421461 h 422480"/>
+              <a:gd name="connsiteX6" fmla="*/ 9125587 w 12162081"/>
+              <a:gd name="connsiteY6" fmla="*/ 21537 h 422480"/>
+              <a:gd name="connsiteX7" fmla="*/ 10640795 w 12162081"/>
+              <a:gd name="connsiteY7" fmla="*/ 422480 h 422480"/>
+              <a:gd name="connsiteX8" fmla="*/ 12162081 w 12162081"/>
+              <a:gd name="connsiteY8" fmla="*/ 19358 h 422480"/>
+              <a:gd name="connsiteX0" fmla="*/ 428 w 12162081"/>
+              <a:gd name="connsiteY0" fmla="*/ 15088 h 427601"/>
+              <a:gd name="connsiteX1" fmla="*/ 1503962 w 12162081"/>
+              <a:gd name="connsiteY1" fmla="*/ 424617 h 427601"/>
+              <a:gd name="connsiteX2" fmla="*/ 3027451 w 12162081"/>
+              <a:gd name="connsiteY2" fmla="*/ 5122 h 427601"/>
+              <a:gd name="connsiteX3" fmla="*/ 4549313 w 12162081"/>
+              <a:gd name="connsiteY3" fmla="*/ 424348 h 427601"/>
+              <a:gd name="connsiteX4" fmla="*/ 6072887 w 12162081"/>
+              <a:gd name="connsiteY4" fmla="*/ 0 h 427601"/>
+              <a:gd name="connsiteX5" fmla="*/ 7595696 w 12162081"/>
+              <a:gd name="connsiteY5" fmla="*/ 426582 h 427601"/>
+              <a:gd name="connsiteX6" fmla="*/ 9125587 w 12162081"/>
+              <a:gd name="connsiteY6" fmla="*/ 26658 h 427601"/>
+              <a:gd name="connsiteX7" fmla="*/ 10640795 w 12162081"/>
+              <a:gd name="connsiteY7" fmla="*/ 427601 h 427601"/>
+              <a:gd name="connsiteX8" fmla="*/ 12162081 w 12162081"/>
+              <a:gd name="connsiteY8" fmla="*/ 24479 h 427601"/>
+              <a:gd name="connsiteX0" fmla="*/ 428 w 12162081"/>
+              <a:gd name="connsiteY0" fmla="*/ 15088 h 427606"/>
+              <a:gd name="connsiteX1" fmla="*/ 1503962 w 12162081"/>
+              <a:gd name="connsiteY1" fmla="*/ 424617 h 427606"/>
+              <a:gd name="connsiteX2" fmla="*/ 3027451 w 12162081"/>
+              <a:gd name="connsiteY2" fmla="*/ 5122 h 427606"/>
+              <a:gd name="connsiteX3" fmla="*/ 4549313 w 12162081"/>
+              <a:gd name="connsiteY3" fmla="*/ 424348 h 427606"/>
+              <a:gd name="connsiteX4" fmla="*/ 6072887 w 12162081"/>
+              <a:gd name="connsiteY4" fmla="*/ 0 h 427606"/>
+              <a:gd name="connsiteX5" fmla="*/ 7595696 w 12162081"/>
+              <a:gd name="connsiteY5" fmla="*/ 426582 h 427606"/>
+              <a:gd name="connsiteX6" fmla="*/ 9122417 w 12162081"/>
+              <a:gd name="connsiteY6" fmla="*/ 13958 h 427606"/>
+              <a:gd name="connsiteX7" fmla="*/ 10640795 w 12162081"/>
+              <a:gd name="connsiteY7" fmla="*/ 427601 h 427606"/>
+              <a:gd name="connsiteX8" fmla="*/ 12162081 w 12162081"/>
+              <a:gd name="connsiteY8" fmla="*/ 24479 h 427606"/>
+              <a:gd name="connsiteX0" fmla="*/ 428 w 12168421"/>
+              <a:gd name="connsiteY0" fmla="*/ 15299 h 427818"/>
+              <a:gd name="connsiteX1" fmla="*/ 1503962 w 12168421"/>
+              <a:gd name="connsiteY1" fmla="*/ 424828 h 427818"/>
+              <a:gd name="connsiteX2" fmla="*/ 3027451 w 12168421"/>
+              <a:gd name="connsiteY2" fmla="*/ 5333 h 427818"/>
+              <a:gd name="connsiteX3" fmla="*/ 4549313 w 12168421"/>
+              <a:gd name="connsiteY3" fmla="*/ 424559 h 427818"/>
+              <a:gd name="connsiteX4" fmla="*/ 6072887 w 12168421"/>
+              <a:gd name="connsiteY4" fmla="*/ 211 h 427818"/>
+              <a:gd name="connsiteX5" fmla="*/ 7595696 w 12168421"/>
+              <a:gd name="connsiteY5" fmla="*/ 426793 h 427818"/>
+              <a:gd name="connsiteX6" fmla="*/ 9122417 w 12168421"/>
+              <a:gd name="connsiteY6" fmla="*/ 14169 h 427818"/>
+              <a:gd name="connsiteX7" fmla="*/ 10640795 w 12168421"/>
+              <a:gd name="connsiteY7" fmla="*/ 427812 h 427818"/>
+              <a:gd name="connsiteX8" fmla="*/ 12168421 w 12168421"/>
+              <a:gd name="connsiteY8" fmla="*/ 2465 h 427818"/>
+            </a:gdLst>
+            <a:ahLst/>
+            <a:cxnLst>
+              <a:cxn ang="0">
+                <a:pos x="connsiteX0" y="connsiteY0"/>
+              </a:cxn>
+              <a:cxn ang="0">
+                <a:pos x="connsiteX1" y="connsiteY1"/>
+              </a:cxn>
+              <a:cxn ang="0">
+                <a:pos x="connsiteX2" y="connsiteY2"/>
+              </a:cxn>
+              <a:cxn ang="0">
+                <a:pos x="connsiteX3" y="connsiteY3"/>
+              </a:cxn>
+              <a:cxn ang="0">
+                <a:pos x="connsiteX4" y="connsiteY4"/>
+              </a:cxn>
+              <a:cxn ang="0">
+                <a:pos x="connsiteX5" y="connsiteY5"/>
+              </a:cxn>
+              <a:cxn ang="0">
+                <a:pos x="connsiteX6" y="connsiteY6"/>
+              </a:cxn>
+              <a:cxn ang="0">
+                <a:pos x="connsiteX7" y="connsiteY7"/>
+              </a:cxn>
+              <a:cxn ang="0">
+                <a:pos x="connsiteX8" y="connsiteY8"/>
+              </a:cxn>
+            </a:cxnLst>
+            <a:rect l="l" t="t" r="r" b="b"/>
+            <a:pathLst>
+              <a:path w="12168421" h="427818">
+                <a:moveTo>
+                  <a:pt x="428" y="15299"/>
+                </a:moveTo>
+                <a:cubicBezTo>
+                  <a:pt x="-23949" y="3229"/>
+                  <a:pt x="999458" y="426489"/>
+                  <a:pt x="1503962" y="424828"/>
+                </a:cubicBezTo>
+                <a:cubicBezTo>
+                  <a:pt x="2008466" y="423167"/>
+                  <a:pt x="2519893" y="5378"/>
+                  <a:pt x="3027451" y="5333"/>
+                </a:cubicBezTo>
+                <a:cubicBezTo>
+                  <a:pt x="3535009" y="5288"/>
+                  <a:pt x="4041740" y="425413"/>
+                  <a:pt x="4549313" y="424559"/>
+                </a:cubicBezTo>
+                <a:cubicBezTo>
+                  <a:pt x="5056886" y="423705"/>
+                  <a:pt x="5565157" y="-161"/>
+                  <a:pt x="6072887" y="211"/>
+                </a:cubicBezTo>
+                <a:cubicBezTo>
+                  <a:pt x="6580618" y="583"/>
+                  <a:pt x="7087441" y="424467"/>
+                  <a:pt x="7595696" y="426793"/>
+                </a:cubicBezTo>
+                <a:cubicBezTo>
+                  <a:pt x="8103951" y="429119"/>
+                  <a:pt x="8614901" y="13999"/>
+                  <a:pt x="9122417" y="14169"/>
+                </a:cubicBezTo>
+                <a:cubicBezTo>
+                  <a:pt x="9629933" y="14339"/>
+                  <a:pt x="10133128" y="429763"/>
+                  <a:pt x="10640795" y="427812"/>
+                </a:cubicBezTo>
+                <a:cubicBezTo>
+                  <a:pt x="11148462" y="425861"/>
+                  <a:pt x="12122537" y="-37684"/>
+                  <a:pt x="12168421" y="2465"/>
+                </a:cubicBezTo>
+              </a:path>
+            </a:pathLst>
+          </a:custGeom>
+          <a:solidFill>
+            <a:schemeClr val="tx2">
+              <a:lumMod val="75000"/>
+              <a:lumOff val="25000"/>
+            </a:schemeClr>
+          </a:solidFill>
+        </p:spPr>
+        <p:style>
+          <a:lnRef idx="2">
+            <a:schemeClr val="accent1">
+              <a:shade val="15000"/>
+            </a:schemeClr>
+          </a:lnRef>
+          <a:fillRef idx="1">
+            <a:schemeClr val="accent1"/>
+          </a:fillRef>
+          <a:effectRef idx="0">
+            <a:schemeClr val="accent1"/>
+          </a:effectRef>
+          <a:fontRef idx="minor">
+            <a:schemeClr val="lt1"/>
+          </a:fontRef>
+        </p:style>
+        <p:txBody>
+          <a:bodyPr rtlCol="0" anchor="ctr"/>
+          <a:lstStyle/>
+          <a:p>
+            <a:pPr algn="ctr"/>
+            <a:endParaRPr lang="en-US" dirty="0"/>
+          </a:p>
+        </p:txBody>
+      </p:sp>
+      <p:cxnSp>
+        <p:nvCxnSpPr>
+          <p:cNvPr id="7" name="Straight Connector 6">
+            <a:extLst>
+              <a:ext uri="{FF2B5EF4-FFF2-40B4-BE49-F238E27FC236}">
+                <a16:creationId xmlns:a16="http://schemas.microsoft.com/office/drawing/2014/main" id="{137F16BB-108A-3466-9C7A-C8CB520D275C}"/>
+              </a:ext>
+            </a:extLst>
+          </p:cNvPr>
+          <p:cNvCxnSpPr/>
+          <p:nvPr/>
+        </p:nvCxnSpPr>
+        <p:spPr>
+          <a:xfrm>
+            <a:off x="20117" y="1291432"/>
+            <a:ext cx="12201839" cy="0"/>
+          </a:xfrm>
+          <a:prstGeom prst="line">
+            <a:avLst/>
+          </a:prstGeom>
+        </p:spPr>
+        <p:style>
+          <a:lnRef idx="2">
+            <a:schemeClr val="accent1"/>
+          </a:lnRef>
+          <a:fillRef idx="0">
+            <a:schemeClr val="accent1"/>
+          </a:fillRef>
+          <a:effectRef idx="1">
+            <a:schemeClr val="accent1"/>
+          </a:effectRef>
+          <a:fontRef idx="minor">
+            <a:schemeClr val="tx1"/>
+          </a:fontRef>
+        </p:style>
+      </p:cxnSp>
+      <p:cxnSp>
+        <p:nvCxnSpPr>
+          <p:cNvPr id="9" name="Straight Connector 8">
+            <a:extLst>
+              <a:ext uri="{FF2B5EF4-FFF2-40B4-BE49-F238E27FC236}">
+                <a16:creationId xmlns:a16="http://schemas.microsoft.com/office/drawing/2014/main" id="{F9A66B23-FB34-0B6E-7A46-CDC96F6E8074}"/>
+              </a:ext>
+            </a:extLst>
+          </p:cNvPr>
+          <p:cNvCxnSpPr/>
+          <p:nvPr/>
+        </p:nvCxnSpPr>
+        <p:spPr>
+          <a:xfrm>
+            <a:off x="12201525" y="0"/>
+            <a:ext cx="0" cy="6858000"/>
+          </a:xfrm>
+          <a:prstGeom prst="line">
+            <a:avLst/>
+          </a:prstGeom>
+        </p:spPr>
+        <p:style>
+          <a:lnRef idx="2">
+            <a:schemeClr val="accent1"/>
+          </a:lnRef>
+          <a:fillRef idx="0">
+            <a:schemeClr val="accent1"/>
+          </a:fillRef>
+          <a:effectRef idx="1">
+            <a:schemeClr val="accent1"/>
+          </a:effectRef>
+          <a:fontRef idx="minor">
+            <a:schemeClr val="tx1"/>
+          </a:fontRef>
+        </p:style>
+      </p:cxnSp>
+      <p:cxnSp>
+        <p:nvCxnSpPr>
+          <p:cNvPr id="10" name="Straight Connector 9">
+            <a:extLst>
+              <a:ext uri="{FF2B5EF4-FFF2-40B4-BE49-F238E27FC236}">
+                <a16:creationId xmlns:a16="http://schemas.microsoft.com/office/drawing/2014/main" id="{19A7B978-079B-FF80-8166-47E027ED590B}"/>
+              </a:ext>
+            </a:extLst>
+          </p:cNvPr>
+          <p:cNvCxnSpPr/>
+          <p:nvPr/>
+        </p:nvCxnSpPr>
+        <p:spPr>
+          <a:xfrm>
+            <a:off x="0" y="0"/>
+            <a:ext cx="0" cy="6858000"/>
+          </a:xfrm>
+          <a:prstGeom prst="line">
+            <a:avLst/>
+          </a:prstGeom>
+        </p:spPr>
+        <p:style>
+          <a:lnRef idx="2">
+            <a:schemeClr val="accent1"/>
+          </a:lnRef>
+          <a:fillRef idx="0">
+            <a:schemeClr val="accent1"/>
+          </a:fillRef>
+          <a:effectRef idx="1">
+            <a:schemeClr val="accent1"/>
+          </a:effectRef>
+          <a:fontRef idx="minor">
+            <a:schemeClr val="tx1"/>
+          </a:fontRef>
+        </p:style>
+      </p:cxnSp>
+      <p:cxnSp>
+        <p:nvCxnSpPr>
+          <p:cNvPr id="11" name="Straight Connector 10">
+            <a:extLst>
+              <a:ext uri="{FF2B5EF4-FFF2-40B4-BE49-F238E27FC236}">
+                <a16:creationId xmlns:a16="http://schemas.microsoft.com/office/drawing/2014/main" id="{4409FB79-DADB-E172-A36B-97061898AB98}"/>
+              </a:ext>
+            </a:extLst>
+          </p:cNvPr>
+          <p:cNvCxnSpPr/>
+          <p:nvPr/>
+        </p:nvCxnSpPr>
+        <p:spPr>
+          <a:xfrm>
+            <a:off x="1525191" y="0"/>
+            <a:ext cx="0" cy="6858000"/>
+          </a:xfrm>
+          <a:prstGeom prst="line">
+            <a:avLst/>
+          </a:prstGeom>
+        </p:spPr>
+        <p:style>
+          <a:lnRef idx="2">
+            <a:schemeClr val="accent1"/>
+          </a:lnRef>
+          <a:fillRef idx="0">
+            <a:schemeClr val="accent1"/>
+          </a:fillRef>
+          <a:effectRef idx="1">
+            <a:schemeClr val="accent1"/>
+          </a:effectRef>
+          <a:fontRef idx="minor">
+            <a:schemeClr val="tx1"/>
+          </a:fontRef>
+        </p:style>
+      </p:cxnSp>
+      <p:cxnSp>
+        <p:nvCxnSpPr>
+          <p:cNvPr id="12" name="Straight Connector 11">
+            <a:extLst>
+              <a:ext uri="{FF2B5EF4-FFF2-40B4-BE49-F238E27FC236}">
+                <a16:creationId xmlns:a16="http://schemas.microsoft.com/office/drawing/2014/main" id="{6A17E7F6-43D8-A3FC-4702-9520FDD33D86}"/>
+              </a:ext>
+            </a:extLst>
+          </p:cNvPr>
+          <p:cNvCxnSpPr/>
+          <p:nvPr/>
+        </p:nvCxnSpPr>
+        <p:spPr>
+          <a:xfrm>
+            <a:off x="3050382" y="0"/>
+            <a:ext cx="0" cy="6858000"/>
+          </a:xfrm>
+          <a:prstGeom prst="line">
+            <a:avLst/>
+          </a:prstGeom>
+        </p:spPr>
+        <p:style>
+          <a:lnRef idx="2">
+            <a:schemeClr val="accent1"/>
+          </a:lnRef>
+          <a:fillRef idx="0">
+            <a:schemeClr val="accent1"/>
+          </a:fillRef>
+          <a:effectRef idx="1">
+            <a:schemeClr val="accent1"/>
+          </a:effectRef>
+          <a:fontRef idx="minor">
+            <a:schemeClr val="tx1"/>
+          </a:fontRef>
+        </p:style>
+      </p:cxnSp>
+      <p:cxnSp>
+        <p:nvCxnSpPr>
+          <p:cNvPr id="13" name="Straight Connector 12">
+            <a:extLst>
+              <a:ext uri="{FF2B5EF4-FFF2-40B4-BE49-F238E27FC236}">
+                <a16:creationId xmlns:a16="http://schemas.microsoft.com/office/drawing/2014/main" id="{DBE492AC-2AC9-47F5-A056-F879A840C9C0}"/>
+              </a:ext>
+            </a:extLst>
+          </p:cNvPr>
+          <p:cNvCxnSpPr/>
+          <p:nvPr/>
+        </p:nvCxnSpPr>
+        <p:spPr>
+          <a:xfrm>
+            <a:off x="6100764" y="0"/>
+            <a:ext cx="0" cy="6858000"/>
+          </a:xfrm>
+          <a:prstGeom prst="line">
+            <a:avLst/>
+          </a:prstGeom>
+        </p:spPr>
+        <p:style>
+          <a:lnRef idx="2">
+            <a:schemeClr val="accent1"/>
+          </a:lnRef>
+          <a:fillRef idx="0">
+            <a:schemeClr val="accent1"/>
+          </a:fillRef>
+          <a:effectRef idx="1">
+            <a:schemeClr val="accent1"/>
+          </a:effectRef>
+          <a:fontRef idx="minor">
+            <a:schemeClr val="tx1"/>
+          </a:fontRef>
+        </p:style>
+      </p:cxnSp>
+      <p:cxnSp>
+        <p:nvCxnSpPr>
+          <p:cNvPr id="14" name="Straight Connector 13">
+            <a:extLst>
+              <a:ext uri="{FF2B5EF4-FFF2-40B4-BE49-F238E27FC236}">
+                <a16:creationId xmlns:a16="http://schemas.microsoft.com/office/drawing/2014/main" id="{F138298B-2746-49A7-D232-E4EC4BD5C4B8}"/>
+              </a:ext>
+            </a:extLst>
+          </p:cNvPr>
+          <p:cNvCxnSpPr/>
+          <p:nvPr/>
+        </p:nvCxnSpPr>
+        <p:spPr>
+          <a:xfrm>
+            <a:off x="4575573" y="0"/>
+            <a:ext cx="0" cy="6858000"/>
+          </a:xfrm>
+          <a:prstGeom prst="line">
+            <a:avLst/>
+          </a:prstGeom>
+        </p:spPr>
+        <p:style>
+          <a:lnRef idx="2">
+            <a:schemeClr val="accent1"/>
+          </a:lnRef>
+          <a:fillRef idx="0">
+            <a:schemeClr val="accent1"/>
+          </a:fillRef>
+          <a:effectRef idx="1">
+            <a:schemeClr val="accent1"/>
+          </a:effectRef>
+          <a:fontRef idx="minor">
+            <a:schemeClr val="tx1"/>
+          </a:fontRef>
+        </p:style>
+      </p:cxnSp>
+      <p:cxnSp>
+        <p:nvCxnSpPr>
+          <p:cNvPr id="15" name="Straight Connector 14">
+            <a:extLst>
+              <a:ext uri="{FF2B5EF4-FFF2-40B4-BE49-F238E27FC236}">
+                <a16:creationId xmlns:a16="http://schemas.microsoft.com/office/drawing/2014/main" id="{34847D8A-374C-19B7-DE8B-B8CBB12FBF19}"/>
+              </a:ext>
+            </a:extLst>
+          </p:cNvPr>
+          <p:cNvCxnSpPr/>
+          <p:nvPr/>
+        </p:nvCxnSpPr>
+        <p:spPr>
+          <a:xfrm>
+            <a:off x="7625955" y="0"/>
+            <a:ext cx="0" cy="6858000"/>
+          </a:xfrm>
+          <a:prstGeom prst="line">
+            <a:avLst/>
+          </a:prstGeom>
+        </p:spPr>
+        <p:style>
+          <a:lnRef idx="2">
+            <a:schemeClr val="accent1"/>
+          </a:lnRef>
+          <a:fillRef idx="0">
+            <a:schemeClr val="accent1"/>
+          </a:fillRef>
+          <a:effectRef idx="1">
+            <a:schemeClr val="accent1"/>
+          </a:effectRef>
+          <a:fontRef idx="minor">
+            <a:schemeClr val="tx1"/>
+          </a:fontRef>
+        </p:style>
+      </p:cxnSp>
+      <p:cxnSp>
+        <p:nvCxnSpPr>
+          <p:cNvPr id="16" name="Straight Connector 15">
+            <a:extLst>
+              <a:ext uri="{FF2B5EF4-FFF2-40B4-BE49-F238E27FC236}">
+                <a16:creationId xmlns:a16="http://schemas.microsoft.com/office/drawing/2014/main" id="{3A169B71-26AE-1EC3-1555-4199FE62E1ED}"/>
+              </a:ext>
+            </a:extLst>
+          </p:cNvPr>
+          <p:cNvCxnSpPr/>
+          <p:nvPr/>
+        </p:nvCxnSpPr>
+        <p:spPr>
+          <a:xfrm>
+            <a:off x="9151146" y="0"/>
+            <a:ext cx="0" cy="6858000"/>
+          </a:xfrm>
+          <a:prstGeom prst="line">
+            <a:avLst/>
+          </a:prstGeom>
+        </p:spPr>
+        <p:style>
+          <a:lnRef idx="2">
+            <a:schemeClr val="accent1"/>
+          </a:lnRef>
+          <a:fillRef idx="0">
+            <a:schemeClr val="accent1"/>
+          </a:fillRef>
+          <a:effectRef idx="1">
+            <a:schemeClr val="accent1"/>
+          </a:effectRef>
+          <a:fontRef idx="minor">
+            <a:schemeClr val="tx1"/>
+          </a:fontRef>
+        </p:style>
+      </p:cxnSp>
+      <p:cxnSp>
+        <p:nvCxnSpPr>
+          <p:cNvPr id="17" name="Straight Connector 16">
+            <a:extLst>
+              <a:ext uri="{FF2B5EF4-FFF2-40B4-BE49-F238E27FC236}">
+                <a16:creationId xmlns:a16="http://schemas.microsoft.com/office/drawing/2014/main" id="{4FE2B865-0943-6594-4190-B6050EEAEFD5}"/>
+              </a:ext>
+            </a:extLst>
+          </p:cNvPr>
+          <p:cNvCxnSpPr/>
+          <p:nvPr/>
+        </p:nvCxnSpPr>
+        <p:spPr>
+          <a:xfrm>
+            <a:off x="10676337" y="66675"/>
+            <a:ext cx="0" cy="6858000"/>
+          </a:xfrm>
+          <a:prstGeom prst="line">
+            <a:avLst/>
+          </a:prstGeom>
+        </p:spPr>
+        <p:style>
+          <a:lnRef idx="2">
+            <a:schemeClr val="accent1"/>
+          </a:lnRef>
+          <a:fillRef idx="0">
+            <a:schemeClr val="accent1"/>
+          </a:fillRef>
+          <a:effectRef idx="1">
+            <a:schemeClr val="accent1"/>
+          </a:effectRef>
+          <a:fontRef idx="minor">
+            <a:schemeClr val="tx1"/>
+          </a:fontRef>
+        </p:style>
+      </p:cxnSp>
+      <p:cxnSp>
+        <p:nvCxnSpPr>
+          <p:cNvPr id="18" name="Straight Connector 17">
+            <a:extLst>
+              <a:ext uri="{FF2B5EF4-FFF2-40B4-BE49-F238E27FC236}">
+                <a16:creationId xmlns:a16="http://schemas.microsoft.com/office/drawing/2014/main" id="{61074C76-65B6-0477-C6A9-4BEBD51E1583}"/>
+              </a:ext>
+            </a:extLst>
+          </p:cNvPr>
+          <p:cNvCxnSpPr/>
+          <p:nvPr/>
+        </p:nvCxnSpPr>
+        <p:spPr>
+          <a:xfrm>
+            <a:off x="156642" y="865544"/>
+            <a:ext cx="12201839" cy="0"/>
+          </a:xfrm>
+          <a:prstGeom prst="line">
+            <a:avLst/>
+          </a:prstGeom>
+        </p:spPr>
+        <p:style>
+          <a:lnRef idx="2">
+            <a:schemeClr val="accent1"/>
+          </a:lnRef>
+          <a:fillRef idx="0">
+            <a:schemeClr val="accent1"/>
+          </a:fillRef>
+          <a:effectRef idx="1">
+            <a:schemeClr val="accent1"/>
+          </a:effectRef>
+          <a:fontRef idx="minor">
+            <a:schemeClr val="tx1"/>
+          </a:fontRef>
+        </p:style>
+      </p:cxnSp>
+    </p:spTree>
+    <p:extLst>
+      <p:ext uri="{BB962C8B-B14F-4D97-AF65-F5344CB8AC3E}">
+        <p14:creationId xmlns:p14="http://schemas.microsoft.com/office/powerpoint/2010/main" val="639471583"/>
+      </p:ext>
+    </p:extLst>
+  </p:cSld>
+  <p:clrMapOvr>
+    <a:masterClrMapping/>
+  </p:clrMapOvr>
+</p:sld>
+</file>
+
+<file path=ppt/slides/slide4.xml><?xml version="1.0" encoding="utf-8"?>
+<p:sld xmlns:a="http://schemas.openxmlformats.org/drawingml/2006/main" xmlns:r="http://schemas.openxmlformats.org/officeDocument/2006/relationships" xmlns:p="http://schemas.openxmlformats.org/presentationml/2006/main">
+  <p:cSld>
+    <p:spTree>
+      <p:nvGrpSpPr>
+        <p:cNvPr id="1" name="">
+          <a:extLst>
+            <a:ext uri="{FF2B5EF4-FFF2-40B4-BE49-F238E27FC236}">
+              <a16:creationId xmlns:a16="http://schemas.microsoft.com/office/drawing/2014/main" id="{1F0EA539-EC7C-D0D7-8713-8766EB04F062}"/>
+            </a:ext>
+          </a:extLst>
+        </p:cNvPr>
+        <p:cNvGrpSpPr/>
+        <p:nvPr/>
+      </p:nvGrpSpPr>
+      <p:grpSpPr>
+        <a:xfrm>
+          <a:off x="0" y="0"/>
+          <a:ext cx="0" cy="0"/>
+          <a:chOff x="0" y="0"/>
+          <a:chExt cx="0" cy="0"/>
+        </a:xfrm>
+      </p:grpSpPr>
+      <p:sp>
+        <p:nvSpPr>
+          <p:cNvPr id="4" name="Freeform: Shape 3">
+            <a:extLst>
+              <a:ext uri="{FF2B5EF4-FFF2-40B4-BE49-F238E27FC236}">
+                <a16:creationId xmlns:a16="http://schemas.microsoft.com/office/drawing/2014/main" id="{ACF6E9DA-4278-7864-F656-9F8FC31C86B1}"/>
+              </a:ext>
+            </a:extLst>
+          </p:cNvPr>
+          <p:cNvSpPr/>
+          <p:nvPr/>
+        </p:nvSpPr>
+        <p:spPr>
+          <a:xfrm>
+            <a:off x="20119" y="860212"/>
+            <a:ext cx="12188070" cy="427818"/>
+          </a:xfrm>
+          <a:custGeom>
+            <a:avLst/>
+            <a:gdLst>
+              <a:gd name="connsiteX0" fmla="*/ 0 w 12329639"/>
+              <a:gd name="connsiteY0" fmla="*/ 172081 h 1087698"/>
+              <a:gd name="connsiteX1" fmla="*/ 3775587 w 12329639"/>
+              <a:gd name="connsiteY1" fmla="*/ 1086481 h 1087698"/>
+              <a:gd name="connsiteX2" fmla="*/ 5220929 w 12329639"/>
+              <a:gd name="connsiteY2" fmla="*/ 378558 h 1087698"/>
+              <a:gd name="connsiteX3" fmla="*/ 7433187 w 12329639"/>
+              <a:gd name="connsiteY3" fmla="*/ 870171 h 1087698"/>
+              <a:gd name="connsiteX4" fmla="*/ 9301316 w 12329639"/>
+              <a:gd name="connsiteY4" fmla="*/ 260571 h 1087698"/>
+              <a:gd name="connsiteX5" fmla="*/ 10962968 w 12329639"/>
+              <a:gd name="connsiteY5" fmla="*/ 948829 h 1087698"/>
+              <a:gd name="connsiteX6" fmla="*/ 12270658 w 12329639"/>
+              <a:gd name="connsiteY6" fmla="*/ 54093 h 1087698"/>
+              <a:gd name="connsiteX7" fmla="*/ 12113342 w 12329639"/>
+              <a:gd name="connsiteY7" fmla="*/ 113087 h 1087698"/>
+              <a:gd name="connsiteX8" fmla="*/ 12192000 w 12329639"/>
+              <a:gd name="connsiteY8" fmla="*/ 221242 h 1087698"/>
+              <a:gd name="connsiteX0" fmla="*/ 0 w 12329639"/>
+              <a:gd name="connsiteY0" fmla="*/ 172081 h 950041"/>
+              <a:gd name="connsiteX1" fmla="*/ 2841522 w 12329639"/>
+              <a:gd name="connsiteY1" fmla="*/ 929165 h 950041"/>
+              <a:gd name="connsiteX2" fmla="*/ 5220929 w 12329639"/>
+              <a:gd name="connsiteY2" fmla="*/ 378558 h 950041"/>
+              <a:gd name="connsiteX3" fmla="*/ 7433187 w 12329639"/>
+              <a:gd name="connsiteY3" fmla="*/ 870171 h 950041"/>
+              <a:gd name="connsiteX4" fmla="*/ 9301316 w 12329639"/>
+              <a:gd name="connsiteY4" fmla="*/ 260571 h 950041"/>
+              <a:gd name="connsiteX5" fmla="*/ 10962968 w 12329639"/>
+              <a:gd name="connsiteY5" fmla="*/ 948829 h 950041"/>
+              <a:gd name="connsiteX6" fmla="*/ 12270658 w 12329639"/>
+              <a:gd name="connsiteY6" fmla="*/ 54093 h 950041"/>
+              <a:gd name="connsiteX7" fmla="*/ 12113342 w 12329639"/>
+              <a:gd name="connsiteY7" fmla="*/ 113087 h 950041"/>
+              <a:gd name="connsiteX8" fmla="*/ 12192000 w 12329639"/>
+              <a:gd name="connsiteY8" fmla="*/ 221242 h 950041"/>
+              <a:gd name="connsiteX0" fmla="*/ 0 w 12329639"/>
+              <a:gd name="connsiteY0" fmla="*/ 172081 h 950041"/>
+              <a:gd name="connsiteX1" fmla="*/ 1976284 w 12329639"/>
+              <a:gd name="connsiteY1" fmla="*/ 929165 h 950041"/>
+              <a:gd name="connsiteX2" fmla="*/ 5220929 w 12329639"/>
+              <a:gd name="connsiteY2" fmla="*/ 378558 h 950041"/>
+              <a:gd name="connsiteX3" fmla="*/ 7433187 w 12329639"/>
+              <a:gd name="connsiteY3" fmla="*/ 870171 h 950041"/>
+              <a:gd name="connsiteX4" fmla="*/ 9301316 w 12329639"/>
+              <a:gd name="connsiteY4" fmla="*/ 260571 h 950041"/>
+              <a:gd name="connsiteX5" fmla="*/ 10962968 w 12329639"/>
+              <a:gd name="connsiteY5" fmla="*/ 948829 h 950041"/>
+              <a:gd name="connsiteX6" fmla="*/ 12270658 w 12329639"/>
+              <a:gd name="connsiteY6" fmla="*/ 54093 h 950041"/>
+              <a:gd name="connsiteX7" fmla="*/ 12113342 w 12329639"/>
+              <a:gd name="connsiteY7" fmla="*/ 113087 h 950041"/>
+              <a:gd name="connsiteX8" fmla="*/ 12192000 w 12329639"/>
+              <a:gd name="connsiteY8" fmla="*/ 221242 h 950041"/>
+              <a:gd name="connsiteX0" fmla="*/ 0 w 12329639"/>
+              <a:gd name="connsiteY0" fmla="*/ 172081 h 950041"/>
+              <a:gd name="connsiteX1" fmla="*/ 1976284 w 12329639"/>
+              <a:gd name="connsiteY1" fmla="*/ 929165 h 950041"/>
+              <a:gd name="connsiteX2" fmla="*/ 5093110 w 12329639"/>
+              <a:gd name="connsiteY2" fmla="*/ 201578 h 950041"/>
+              <a:gd name="connsiteX3" fmla="*/ 7433187 w 12329639"/>
+              <a:gd name="connsiteY3" fmla="*/ 870171 h 950041"/>
+              <a:gd name="connsiteX4" fmla="*/ 9301316 w 12329639"/>
+              <a:gd name="connsiteY4" fmla="*/ 260571 h 950041"/>
+              <a:gd name="connsiteX5" fmla="*/ 10962968 w 12329639"/>
+              <a:gd name="connsiteY5" fmla="*/ 948829 h 950041"/>
+              <a:gd name="connsiteX6" fmla="*/ 12270658 w 12329639"/>
+              <a:gd name="connsiteY6" fmla="*/ 54093 h 950041"/>
+              <a:gd name="connsiteX7" fmla="*/ 12113342 w 12329639"/>
+              <a:gd name="connsiteY7" fmla="*/ 113087 h 950041"/>
+              <a:gd name="connsiteX8" fmla="*/ 12192000 w 12329639"/>
+              <a:gd name="connsiteY8" fmla="*/ 221242 h 950041"/>
+              <a:gd name="connsiteX0" fmla="*/ 0 w 12329639"/>
+              <a:gd name="connsiteY0" fmla="*/ 172081 h 950041"/>
+              <a:gd name="connsiteX1" fmla="*/ 1976284 w 12329639"/>
+              <a:gd name="connsiteY1" fmla="*/ 929165 h 950041"/>
+              <a:gd name="connsiteX2" fmla="*/ 3480619 w 12329639"/>
+              <a:gd name="connsiteY2" fmla="*/ 181914 h 950041"/>
+              <a:gd name="connsiteX3" fmla="*/ 7433187 w 12329639"/>
+              <a:gd name="connsiteY3" fmla="*/ 870171 h 950041"/>
+              <a:gd name="connsiteX4" fmla="*/ 9301316 w 12329639"/>
+              <a:gd name="connsiteY4" fmla="*/ 260571 h 950041"/>
+              <a:gd name="connsiteX5" fmla="*/ 10962968 w 12329639"/>
+              <a:gd name="connsiteY5" fmla="*/ 948829 h 950041"/>
+              <a:gd name="connsiteX6" fmla="*/ 12270658 w 12329639"/>
+              <a:gd name="connsiteY6" fmla="*/ 54093 h 950041"/>
+              <a:gd name="connsiteX7" fmla="*/ 12113342 w 12329639"/>
+              <a:gd name="connsiteY7" fmla="*/ 113087 h 950041"/>
+              <a:gd name="connsiteX8" fmla="*/ 12192000 w 12329639"/>
+              <a:gd name="connsiteY8" fmla="*/ 221242 h 950041"/>
+              <a:gd name="connsiteX0" fmla="*/ 0 w 12329639"/>
+              <a:gd name="connsiteY0" fmla="*/ 172081 h 950020"/>
+              <a:gd name="connsiteX1" fmla="*/ 1976284 w 12329639"/>
+              <a:gd name="connsiteY1" fmla="*/ 929165 h 950020"/>
+              <a:gd name="connsiteX2" fmla="*/ 3480619 w 12329639"/>
+              <a:gd name="connsiteY2" fmla="*/ 181914 h 950020"/>
+              <a:gd name="connsiteX3" fmla="*/ 5378245 w 12329639"/>
+              <a:gd name="connsiteY3" fmla="*/ 948829 h 950020"/>
+              <a:gd name="connsiteX4" fmla="*/ 9301316 w 12329639"/>
+              <a:gd name="connsiteY4" fmla="*/ 260571 h 950020"/>
+              <a:gd name="connsiteX5" fmla="*/ 10962968 w 12329639"/>
+              <a:gd name="connsiteY5" fmla="*/ 948829 h 950020"/>
+              <a:gd name="connsiteX6" fmla="*/ 12270658 w 12329639"/>
+              <a:gd name="connsiteY6" fmla="*/ 54093 h 950020"/>
+              <a:gd name="connsiteX7" fmla="*/ 12113342 w 12329639"/>
+              <a:gd name="connsiteY7" fmla="*/ 113087 h 950020"/>
+              <a:gd name="connsiteX8" fmla="*/ 12192000 w 12329639"/>
+              <a:gd name="connsiteY8" fmla="*/ 221242 h 950020"/>
+              <a:gd name="connsiteX0" fmla="*/ 0 w 12329639"/>
+              <a:gd name="connsiteY0" fmla="*/ 172081 h 949580"/>
+              <a:gd name="connsiteX1" fmla="*/ 1976284 w 12329639"/>
+              <a:gd name="connsiteY1" fmla="*/ 929165 h 949580"/>
+              <a:gd name="connsiteX2" fmla="*/ 3480619 w 12329639"/>
+              <a:gd name="connsiteY2" fmla="*/ 181914 h 949580"/>
+              <a:gd name="connsiteX3" fmla="*/ 5378245 w 12329639"/>
+              <a:gd name="connsiteY3" fmla="*/ 948829 h 949580"/>
+              <a:gd name="connsiteX4" fmla="*/ 7541342 w 12329639"/>
+              <a:gd name="connsiteY4" fmla="*/ 221242 h 949580"/>
+              <a:gd name="connsiteX5" fmla="*/ 10962968 w 12329639"/>
+              <a:gd name="connsiteY5" fmla="*/ 948829 h 949580"/>
+              <a:gd name="connsiteX6" fmla="*/ 12270658 w 12329639"/>
+              <a:gd name="connsiteY6" fmla="*/ 54093 h 949580"/>
+              <a:gd name="connsiteX7" fmla="*/ 12113342 w 12329639"/>
+              <a:gd name="connsiteY7" fmla="*/ 113087 h 949580"/>
+              <a:gd name="connsiteX8" fmla="*/ 12192000 w 12329639"/>
+              <a:gd name="connsiteY8" fmla="*/ 221242 h 949580"/>
+              <a:gd name="connsiteX0" fmla="*/ 0 w 12425620"/>
+              <a:gd name="connsiteY0" fmla="*/ 164941 h 941733"/>
+              <a:gd name="connsiteX1" fmla="*/ 1976284 w 12425620"/>
+              <a:gd name="connsiteY1" fmla="*/ 922025 h 941733"/>
+              <a:gd name="connsiteX2" fmla="*/ 3480619 w 12425620"/>
+              <a:gd name="connsiteY2" fmla="*/ 174774 h 941733"/>
+              <a:gd name="connsiteX3" fmla="*/ 5378245 w 12425620"/>
+              <a:gd name="connsiteY3" fmla="*/ 941689 h 941733"/>
+              <a:gd name="connsiteX4" fmla="*/ 7541342 w 12425620"/>
+              <a:gd name="connsiteY4" fmla="*/ 214102 h 941733"/>
+              <a:gd name="connsiteX5" fmla="*/ 9596284 w 12425620"/>
+              <a:gd name="connsiteY5" fmla="*/ 843366 h 941733"/>
+              <a:gd name="connsiteX6" fmla="*/ 12270658 w 12425620"/>
+              <a:gd name="connsiteY6" fmla="*/ 46953 h 941733"/>
+              <a:gd name="connsiteX7" fmla="*/ 12113342 w 12425620"/>
+              <a:gd name="connsiteY7" fmla="*/ 105947 h 941733"/>
+              <a:gd name="connsiteX8" fmla="*/ 12192000 w 12425620"/>
+              <a:gd name="connsiteY8" fmla="*/ 214102 h 941733"/>
+              <a:gd name="connsiteX0" fmla="*/ 0 w 12446934"/>
+              <a:gd name="connsiteY0" fmla="*/ 552701 h 1329493"/>
+              <a:gd name="connsiteX1" fmla="*/ 1976284 w 12446934"/>
+              <a:gd name="connsiteY1" fmla="*/ 1309785 h 1329493"/>
+              <a:gd name="connsiteX2" fmla="*/ 3480619 w 12446934"/>
+              <a:gd name="connsiteY2" fmla="*/ 562534 h 1329493"/>
+              <a:gd name="connsiteX3" fmla="*/ 5378245 w 12446934"/>
+              <a:gd name="connsiteY3" fmla="*/ 1329449 h 1329493"/>
+              <a:gd name="connsiteX4" fmla="*/ 7541342 w 12446934"/>
+              <a:gd name="connsiteY4" fmla="*/ 601862 h 1329493"/>
+              <a:gd name="connsiteX5" fmla="*/ 9596284 w 12446934"/>
+              <a:gd name="connsiteY5" fmla="*/ 1231126 h 1329493"/>
+              <a:gd name="connsiteX6" fmla="*/ 12270658 w 12446934"/>
+              <a:gd name="connsiteY6" fmla="*/ 434713 h 1329493"/>
+              <a:gd name="connsiteX7" fmla="*/ 12192000 w 12446934"/>
+              <a:gd name="connsiteY7" fmla="*/ 2094 h 1329493"/>
+              <a:gd name="connsiteX8" fmla="*/ 12192000 w 12446934"/>
+              <a:gd name="connsiteY8" fmla="*/ 601862 h 1329493"/>
+              <a:gd name="connsiteX0" fmla="*/ 0 w 12193282"/>
+              <a:gd name="connsiteY0" fmla="*/ 551070 h 1492944"/>
+              <a:gd name="connsiteX1" fmla="*/ 1976284 w 12193282"/>
+              <a:gd name="connsiteY1" fmla="*/ 1308154 h 1492944"/>
+              <a:gd name="connsiteX2" fmla="*/ 3480619 w 12193282"/>
+              <a:gd name="connsiteY2" fmla="*/ 560903 h 1492944"/>
+              <a:gd name="connsiteX3" fmla="*/ 5378245 w 12193282"/>
+              <a:gd name="connsiteY3" fmla="*/ 1327818 h 1492944"/>
+              <a:gd name="connsiteX4" fmla="*/ 7541342 w 12193282"/>
+              <a:gd name="connsiteY4" fmla="*/ 600231 h 1492944"/>
+              <a:gd name="connsiteX5" fmla="*/ 9596284 w 12193282"/>
+              <a:gd name="connsiteY5" fmla="*/ 1229495 h 1492944"/>
+              <a:gd name="connsiteX6" fmla="*/ 11690554 w 12193282"/>
+              <a:gd name="connsiteY6" fmla="*/ 1416307 h 1492944"/>
+              <a:gd name="connsiteX7" fmla="*/ 12192000 w 12193282"/>
+              <a:gd name="connsiteY7" fmla="*/ 463 h 1492944"/>
+              <a:gd name="connsiteX8" fmla="*/ 12192000 w 12193282"/>
+              <a:gd name="connsiteY8" fmla="*/ 600231 h 1492944"/>
+              <a:gd name="connsiteX0" fmla="*/ 0 w 12192176"/>
+              <a:gd name="connsiteY0" fmla="*/ 551890 h 1328682"/>
+              <a:gd name="connsiteX1" fmla="*/ 1976284 w 12192176"/>
+              <a:gd name="connsiteY1" fmla="*/ 1308974 h 1328682"/>
+              <a:gd name="connsiteX2" fmla="*/ 3480619 w 12192176"/>
+              <a:gd name="connsiteY2" fmla="*/ 561723 h 1328682"/>
+              <a:gd name="connsiteX3" fmla="*/ 5378245 w 12192176"/>
+              <a:gd name="connsiteY3" fmla="*/ 1328638 h 1328682"/>
+              <a:gd name="connsiteX4" fmla="*/ 7541342 w 12192176"/>
+              <a:gd name="connsiteY4" fmla="*/ 601051 h 1328682"/>
+              <a:gd name="connsiteX5" fmla="*/ 9596284 w 12192176"/>
+              <a:gd name="connsiteY5" fmla="*/ 1230315 h 1328682"/>
+              <a:gd name="connsiteX6" fmla="*/ 11051457 w 12192176"/>
+              <a:gd name="connsiteY6" fmla="*/ 610882 h 1328682"/>
+              <a:gd name="connsiteX7" fmla="*/ 12192000 w 12192176"/>
+              <a:gd name="connsiteY7" fmla="*/ 1283 h 1328682"/>
+              <a:gd name="connsiteX8" fmla="*/ 12192000 w 12192176"/>
+              <a:gd name="connsiteY8" fmla="*/ 601051 h 1328682"/>
+              <a:gd name="connsiteX0" fmla="*/ 0 w 12192000"/>
+              <a:gd name="connsiteY0" fmla="*/ 0 h 776792"/>
+              <a:gd name="connsiteX1" fmla="*/ 1976284 w 12192000"/>
+              <a:gd name="connsiteY1" fmla="*/ 757084 h 776792"/>
+              <a:gd name="connsiteX2" fmla="*/ 3480619 w 12192000"/>
+              <a:gd name="connsiteY2" fmla="*/ 9833 h 776792"/>
+              <a:gd name="connsiteX3" fmla="*/ 5378245 w 12192000"/>
+              <a:gd name="connsiteY3" fmla="*/ 776748 h 776792"/>
+              <a:gd name="connsiteX4" fmla="*/ 7541342 w 12192000"/>
+              <a:gd name="connsiteY4" fmla="*/ 49161 h 776792"/>
+              <a:gd name="connsiteX5" fmla="*/ 9596284 w 12192000"/>
+              <a:gd name="connsiteY5" fmla="*/ 678425 h 776792"/>
+              <a:gd name="connsiteX6" fmla="*/ 11051457 w 12192000"/>
+              <a:gd name="connsiteY6" fmla="*/ 58992 h 776792"/>
+              <a:gd name="connsiteX7" fmla="*/ 11808542 w 12192000"/>
+              <a:gd name="connsiteY7" fmla="*/ 727587 h 776792"/>
+              <a:gd name="connsiteX8" fmla="*/ 12192000 w 12192000"/>
+              <a:gd name="connsiteY8" fmla="*/ 49161 h 776792"/>
+              <a:gd name="connsiteX0" fmla="*/ 0 w 12270658"/>
+              <a:gd name="connsiteY0" fmla="*/ 0 h 776792"/>
+              <a:gd name="connsiteX1" fmla="*/ 1976284 w 12270658"/>
+              <a:gd name="connsiteY1" fmla="*/ 757084 h 776792"/>
+              <a:gd name="connsiteX2" fmla="*/ 3480619 w 12270658"/>
+              <a:gd name="connsiteY2" fmla="*/ 9833 h 776792"/>
+              <a:gd name="connsiteX3" fmla="*/ 5378245 w 12270658"/>
+              <a:gd name="connsiteY3" fmla="*/ 776748 h 776792"/>
+              <a:gd name="connsiteX4" fmla="*/ 7541342 w 12270658"/>
+              <a:gd name="connsiteY4" fmla="*/ 49161 h 776792"/>
+              <a:gd name="connsiteX5" fmla="*/ 9596284 w 12270658"/>
+              <a:gd name="connsiteY5" fmla="*/ 678425 h 776792"/>
+              <a:gd name="connsiteX6" fmla="*/ 11051457 w 12270658"/>
+              <a:gd name="connsiteY6" fmla="*/ 58992 h 776792"/>
+              <a:gd name="connsiteX7" fmla="*/ 11808542 w 12270658"/>
+              <a:gd name="connsiteY7" fmla="*/ 727587 h 776792"/>
+              <a:gd name="connsiteX8" fmla="*/ 12270658 w 12270658"/>
+              <a:gd name="connsiteY8" fmla="*/ 19665 h 776792"/>
+              <a:gd name="connsiteX0" fmla="*/ 0 w 12270658"/>
+              <a:gd name="connsiteY0" fmla="*/ 0 h 776792"/>
+              <a:gd name="connsiteX1" fmla="*/ 1976284 w 12270658"/>
+              <a:gd name="connsiteY1" fmla="*/ 757084 h 776792"/>
+              <a:gd name="connsiteX2" fmla="*/ 3480619 w 12270658"/>
+              <a:gd name="connsiteY2" fmla="*/ 9833 h 776792"/>
+              <a:gd name="connsiteX3" fmla="*/ 5378245 w 12270658"/>
+              <a:gd name="connsiteY3" fmla="*/ 776748 h 776792"/>
+              <a:gd name="connsiteX4" fmla="*/ 7541342 w 12270658"/>
+              <a:gd name="connsiteY4" fmla="*/ 49161 h 776792"/>
+              <a:gd name="connsiteX5" fmla="*/ 9596284 w 12270658"/>
+              <a:gd name="connsiteY5" fmla="*/ 678425 h 776792"/>
+              <a:gd name="connsiteX6" fmla="*/ 11051457 w 12270658"/>
+              <a:gd name="connsiteY6" fmla="*/ 58992 h 776792"/>
+              <a:gd name="connsiteX7" fmla="*/ 11769213 w 12270658"/>
+              <a:gd name="connsiteY7" fmla="*/ 363793 h 776792"/>
+              <a:gd name="connsiteX8" fmla="*/ 12270658 w 12270658"/>
+              <a:gd name="connsiteY8" fmla="*/ 19665 h 776792"/>
+              <a:gd name="connsiteX0" fmla="*/ 0 w 12182168"/>
+              <a:gd name="connsiteY0" fmla="*/ 0 h 776792"/>
+              <a:gd name="connsiteX1" fmla="*/ 1887794 w 12182168"/>
+              <a:gd name="connsiteY1" fmla="*/ 757084 h 776792"/>
+              <a:gd name="connsiteX2" fmla="*/ 3392129 w 12182168"/>
+              <a:gd name="connsiteY2" fmla="*/ 9833 h 776792"/>
+              <a:gd name="connsiteX3" fmla="*/ 5289755 w 12182168"/>
+              <a:gd name="connsiteY3" fmla="*/ 776748 h 776792"/>
+              <a:gd name="connsiteX4" fmla="*/ 7452852 w 12182168"/>
+              <a:gd name="connsiteY4" fmla="*/ 49161 h 776792"/>
+              <a:gd name="connsiteX5" fmla="*/ 9507794 w 12182168"/>
+              <a:gd name="connsiteY5" fmla="*/ 678425 h 776792"/>
+              <a:gd name="connsiteX6" fmla="*/ 10962967 w 12182168"/>
+              <a:gd name="connsiteY6" fmla="*/ 58992 h 776792"/>
+              <a:gd name="connsiteX7" fmla="*/ 11680723 w 12182168"/>
+              <a:gd name="connsiteY7" fmla="*/ 363793 h 776792"/>
+              <a:gd name="connsiteX8" fmla="*/ 12182168 w 12182168"/>
+              <a:gd name="connsiteY8" fmla="*/ 19665 h 776792"/>
+              <a:gd name="connsiteX0" fmla="*/ 0 w 12182168"/>
+              <a:gd name="connsiteY0" fmla="*/ 0 h 776792"/>
+              <a:gd name="connsiteX1" fmla="*/ 1887794 w 12182168"/>
+              <a:gd name="connsiteY1" fmla="*/ 757084 h 776792"/>
+              <a:gd name="connsiteX2" fmla="*/ 3392129 w 12182168"/>
+              <a:gd name="connsiteY2" fmla="*/ 9833 h 776792"/>
+              <a:gd name="connsiteX3" fmla="*/ 5289755 w 12182168"/>
+              <a:gd name="connsiteY3" fmla="*/ 776748 h 776792"/>
+              <a:gd name="connsiteX4" fmla="*/ 7452852 w 12182168"/>
+              <a:gd name="connsiteY4" fmla="*/ 49161 h 776792"/>
+              <a:gd name="connsiteX5" fmla="*/ 9507794 w 12182168"/>
+              <a:gd name="connsiteY5" fmla="*/ 678425 h 776792"/>
+              <a:gd name="connsiteX6" fmla="*/ 10962967 w 12182168"/>
+              <a:gd name="connsiteY6" fmla="*/ 58992 h 776792"/>
+              <a:gd name="connsiteX7" fmla="*/ 11700355 w 12182168"/>
+              <a:gd name="connsiteY7" fmla="*/ 314632 h 776792"/>
+              <a:gd name="connsiteX8" fmla="*/ 12182168 w 12182168"/>
+              <a:gd name="connsiteY8" fmla="*/ 19665 h 776792"/>
+              <a:gd name="connsiteX0" fmla="*/ 0 w 12182168"/>
+              <a:gd name="connsiteY0" fmla="*/ 0 h 776792"/>
+              <a:gd name="connsiteX1" fmla="*/ 1887794 w 12182168"/>
+              <a:gd name="connsiteY1" fmla="*/ 757084 h 776792"/>
+              <a:gd name="connsiteX2" fmla="*/ 3392129 w 12182168"/>
+              <a:gd name="connsiteY2" fmla="*/ 9833 h 776792"/>
+              <a:gd name="connsiteX3" fmla="*/ 5289755 w 12182168"/>
+              <a:gd name="connsiteY3" fmla="*/ 776748 h 776792"/>
+              <a:gd name="connsiteX4" fmla="*/ 7452852 w 12182168"/>
+              <a:gd name="connsiteY4" fmla="*/ 49161 h 776792"/>
+              <a:gd name="connsiteX5" fmla="*/ 9507794 w 12182168"/>
+              <a:gd name="connsiteY5" fmla="*/ 678425 h 776792"/>
+              <a:gd name="connsiteX6" fmla="*/ 10962967 w 12182168"/>
+              <a:gd name="connsiteY6" fmla="*/ 58992 h 776792"/>
+              <a:gd name="connsiteX7" fmla="*/ 11700355 w 12182168"/>
+              <a:gd name="connsiteY7" fmla="*/ 314632 h 776792"/>
+              <a:gd name="connsiteX8" fmla="*/ 12182168 w 12182168"/>
+              <a:gd name="connsiteY8" fmla="*/ 19665 h 776792"/>
+              <a:gd name="connsiteX0" fmla="*/ 0 w 12182168"/>
+              <a:gd name="connsiteY0" fmla="*/ 0 h 776792"/>
+              <a:gd name="connsiteX1" fmla="*/ 1887794 w 12182168"/>
+              <a:gd name="connsiteY1" fmla="*/ 757084 h 776792"/>
+              <a:gd name="connsiteX2" fmla="*/ 3392129 w 12182168"/>
+              <a:gd name="connsiteY2" fmla="*/ 9833 h 776792"/>
+              <a:gd name="connsiteX3" fmla="*/ 5289755 w 12182168"/>
+              <a:gd name="connsiteY3" fmla="*/ 776748 h 776792"/>
+              <a:gd name="connsiteX4" fmla="*/ 7452852 w 12182168"/>
+              <a:gd name="connsiteY4" fmla="*/ 49161 h 776792"/>
+              <a:gd name="connsiteX5" fmla="*/ 9507794 w 12182168"/>
+              <a:gd name="connsiteY5" fmla="*/ 678425 h 776792"/>
+              <a:gd name="connsiteX6" fmla="*/ 10962967 w 12182168"/>
+              <a:gd name="connsiteY6" fmla="*/ 58992 h 776792"/>
+              <a:gd name="connsiteX7" fmla="*/ 11614768 w 12182168"/>
+              <a:gd name="connsiteY7" fmla="*/ 724207 h 776792"/>
+              <a:gd name="connsiteX8" fmla="*/ 12182168 w 12182168"/>
+              <a:gd name="connsiteY8" fmla="*/ 19665 h 776792"/>
+              <a:gd name="connsiteX0" fmla="*/ 0 w 12182168"/>
+              <a:gd name="connsiteY0" fmla="*/ 0 h 776792"/>
+              <a:gd name="connsiteX1" fmla="*/ 1887794 w 12182168"/>
+              <a:gd name="connsiteY1" fmla="*/ 757084 h 776792"/>
+              <a:gd name="connsiteX2" fmla="*/ 3392129 w 12182168"/>
+              <a:gd name="connsiteY2" fmla="*/ 9833 h 776792"/>
+              <a:gd name="connsiteX3" fmla="*/ 5289755 w 12182168"/>
+              <a:gd name="connsiteY3" fmla="*/ 776748 h 776792"/>
+              <a:gd name="connsiteX4" fmla="*/ 7452852 w 12182168"/>
+              <a:gd name="connsiteY4" fmla="*/ 49161 h 776792"/>
+              <a:gd name="connsiteX5" fmla="*/ 9507794 w 12182168"/>
+              <a:gd name="connsiteY5" fmla="*/ 678425 h 776792"/>
+              <a:gd name="connsiteX6" fmla="*/ 10962967 w 12182168"/>
+              <a:gd name="connsiteY6" fmla="*/ 58992 h 776792"/>
+              <a:gd name="connsiteX7" fmla="*/ 11614768 w 12182168"/>
+              <a:gd name="connsiteY7" fmla="*/ 724207 h 776792"/>
+              <a:gd name="connsiteX8" fmla="*/ 12182168 w 12182168"/>
+              <a:gd name="connsiteY8" fmla="*/ 19665 h 776792"/>
+              <a:gd name="connsiteX0" fmla="*/ 0 w 12182168"/>
+              <a:gd name="connsiteY0" fmla="*/ 0 h 776793"/>
+              <a:gd name="connsiteX1" fmla="*/ 1887794 w 12182168"/>
+              <a:gd name="connsiteY1" fmla="*/ 757084 h 776793"/>
+              <a:gd name="connsiteX2" fmla="*/ 3392129 w 12182168"/>
+              <a:gd name="connsiteY2" fmla="*/ 9833 h 776793"/>
+              <a:gd name="connsiteX3" fmla="*/ 5289755 w 12182168"/>
+              <a:gd name="connsiteY3" fmla="*/ 776748 h 776793"/>
+              <a:gd name="connsiteX4" fmla="*/ 7452852 w 12182168"/>
+              <a:gd name="connsiteY4" fmla="*/ 49161 h 776793"/>
+              <a:gd name="connsiteX5" fmla="*/ 8837364 w 12182168"/>
+              <a:gd name="connsiteY5" fmla="*/ 616512 h 776793"/>
+              <a:gd name="connsiteX6" fmla="*/ 10962967 w 12182168"/>
+              <a:gd name="connsiteY6" fmla="*/ 58992 h 776793"/>
+              <a:gd name="connsiteX7" fmla="*/ 11614768 w 12182168"/>
+              <a:gd name="connsiteY7" fmla="*/ 724207 h 776793"/>
+              <a:gd name="connsiteX8" fmla="*/ 12182168 w 12182168"/>
+              <a:gd name="connsiteY8" fmla="*/ 19665 h 776793"/>
+              <a:gd name="connsiteX0" fmla="*/ 0 w 12182168"/>
+              <a:gd name="connsiteY0" fmla="*/ 0 h 776793"/>
+              <a:gd name="connsiteX1" fmla="*/ 1887794 w 12182168"/>
+              <a:gd name="connsiteY1" fmla="*/ 757084 h 776793"/>
+              <a:gd name="connsiteX2" fmla="*/ 3392129 w 12182168"/>
+              <a:gd name="connsiteY2" fmla="*/ 9833 h 776793"/>
+              <a:gd name="connsiteX3" fmla="*/ 5289755 w 12182168"/>
+              <a:gd name="connsiteY3" fmla="*/ 776748 h 776793"/>
+              <a:gd name="connsiteX4" fmla="*/ 7452852 w 12182168"/>
+              <a:gd name="connsiteY4" fmla="*/ 49161 h 776793"/>
+              <a:gd name="connsiteX5" fmla="*/ 8837364 w 12182168"/>
+              <a:gd name="connsiteY5" fmla="*/ 616512 h 776793"/>
+              <a:gd name="connsiteX6" fmla="*/ 10378124 w 12182168"/>
+              <a:gd name="connsiteY6" fmla="*/ 44704 h 776793"/>
+              <a:gd name="connsiteX7" fmla="*/ 11614768 w 12182168"/>
+              <a:gd name="connsiteY7" fmla="*/ 724207 h 776793"/>
+              <a:gd name="connsiteX8" fmla="*/ 12182168 w 12182168"/>
+              <a:gd name="connsiteY8" fmla="*/ 19665 h 776793"/>
+              <a:gd name="connsiteX0" fmla="*/ 0 w 12182168"/>
+              <a:gd name="connsiteY0" fmla="*/ 0 h 776793"/>
+              <a:gd name="connsiteX1" fmla="*/ 1488389 w 12182168"/>
+              <a:gd name="connsiteY1" fmla="*/ 766609 h 776793"/>
+              <a:gd name="connsiteX2" fmla="*/ 3392129 w 12182168"/>
+              <a:gd name="connsiteY2" fmla="*/ 9833 h 776793"/>
+              <a:gd name="connsiteX3" fmla="*/ 5289755 w 12182168"/>
+              <a:gd name="connsiteY3" fmla="*/ 776748 h 776793"/>
+              <a:gd name="connsiteX4" fmla="*/ 7452852 w 12182168"/>
+              <a:gd name="connsiteY4" fmla="*/ 49161 h 776793"/>
+              <a:gd name="connsiteX5" fmla="*/ 8837364 w 12182168"/>
+              <a:gd name="connsiteY5" fmla="*/ 616512 h 776793"/>
+              <a:gd name="connsiteX6" fmla="*/ 10378124 w 12182168"/>
+              <a:gd name="connsiteY6" fmla="*/ 44704 h 776793"/>
+              <a:gd name="connsiteX7" fmla="*/ 11614768 w 12182168"/>
+              <a:gd name="connsiteY7" fmla="*/ 724207 h 776793"/>
+              <a:gd name="connsiteX8" fmla="*/ 12182168 w 12182168"/>
+              <a:gd name="connsiteY8" fmla="*/ 19665 h 776793"/>
+              <a:gd name="connsiteX0" fmla="*/ 0 w 12182168"/>
+              <a:gd name="connsiteY0" fmla="*/ 0 h 776793"/>
+              <a:gd name="connsiteX1" fmla="*/ 1516918 w 12182168"/>
+              <a:gd name="connsiteY1" fmla="*/ 757084 h 776793"/>
+              <a:gd name="connsiteX2" fmla="*/ 3392129 w 12182168"/>
+              <a:gd name="connsiteY2" fmla="*/ 9833 h 776793"/>
+              <a:gd name="connsiteX3" fmla="*/ 5289755 w 12182168"/>
+              <a:gd name="connsiteY3" fmla="*/ 776748 h 776793"/>
+              <a:gd name="connsiteX4" fmla="*/ 7452852 w 12182168"/>
+              <a:gd name="connsiteY4" fmla="*/ 49161 h 776793"/>
+              <a:gd name="connsiteX5" fmla="*/ 8837364 w 12182168"/>
+              <a:gd name="connsiteY5" fmla="*/ 616512 h 776793"/>
+              <a:gd name="connsiteX6" fmla="*/ 10378124 w 12182168"/>
+              <a:gd name="connsiteY6" fmla="*/ 44704 h 776793"/>
+              <a:gd name="connsiteX7" fmla="*/ 11614768 w 12182168"/>
+              <a:gd name="connsiteY7" fmla="*/ 724207 h 776793"/>
+              <a:gd name="connsiteX8" fmla="*/ 12182168 w 12182168"/>
+              <a:gd name="connsiteY8" fmla="*/ 19665 h 776793"/>
+              <a:gd name="connsiteX0" fmla="*/ 0 w 12182168"/>
+              <a:gd name="connsiteY0" fmla="*/ 0 h 776774"/>
+              <a:gd name="connsiteX1" fmla="*/ 1516918 w 12182168"/>
+              <a:gd name="connsiteY1" fmla="*/ 757084 h 776774"/>
+              <a:gd name="connsiteX2" fmla="*/ 3021253 w 12182168"/>
+              <a:gd name="connsiteY2" fmla="*/ 19358 h 776774"/>
+              <a:gd name="connsiteX3" fmla="*/ 5289755 w 12182168"/>
+              <a:gd name="connsiteY3" fmla="*/ 776748 h 776774"/>
+              <a:gd name="connsiteX4" fmla="*/ 7452852 w 12182168"/>
+              <a:gd name="connsiteY4" fmla="*/ 49161 h 776774"/>
+              <a:gd name="connsiteX5" fmla="*/ 8837364 w 12182168"/>
+              <a:gd name="connsiteY5" fmla="*/ 616512 h 776774"/>
+              <a:gd name="connsiteX6" fmla="*/ 10378124 w 12182168"/>
+              <a:gd name="connsiteY6" fmla="*/ 44704 h 776774"/>
+              <a:gd name="connsiteX7" fmla="*/ 11614768 w 12182168"/>
+              <a:gd name="connsiteY7" fmla="*/ 724207 h 776774"/>
+              <a:gd name="connsiteX8" fmla="*/ 12182168 w 12182168"/>
+              <a:gd name="connsiteY8" fmla="*/ 19665 h 776774"/>
+              <a:gd name="connsiteX0" fmla="*/ 0 w 12182168"/>
+              <a:gd name="connsiteY0" fmla="*/ 0 h 776817"/>
+              <a:gd name="connsiteX1" fmla="*/ 1516918 w 12182168"/>
+              <a:gd name="connsiteY1" fmla="*/ 757084 h 776817"/>
+              <a:gd name="connsiteX2" fmla="*/ 3078311 w 12182168"/>
+              <a:gd name="connsiteY2" fmla="*/ 308 h 776817"/>
+              <a:gd name="connsiteX3" fmla="*/ 5289755 w 12182168"/>
+              <a:gd name="connsiteY3" fmla="*/ 776748 h 776817"/>
+              <a:gd name="connsiteX4" fmla="*/ 7452852 w 12182168"/>
+              <a:gd name="connsiteY4" fmla="*/ 49161 h 776817"/>
+              <a:gd name="connsiteX5" fmla="*/ 8837364 w 12182168"/>
+              <a:gd name="connsiteY5" fmla="*/ 616512 h 776817"/>
+              <a:gd name="connsiteX6" fmla="*/ 10378124 w 12182168"/>
+              <a:gd name="connsiteY6" fmla="*/ 44704 h 776817"/>
+              <a:gd name="connsiteX7" fmla="*/ 11614768 w 12182168"/>
+              <a:gd name="connsiteY7" fmla="*/ 724207 h 776817"/>
+              <a:gd name="connsiteX8" fmla="*/ 12182168 w 12182168"/>
+              <a:gd name="connsiteY8" fmla="*/ 19665 h 776817"/>
+              <a:gd name="connsiteX0" fmla="*/ 0 w 12182168"/>
+              <a:gd name="connsiteY0" fmla="*/ 0 h 776817"/>
+              <a:gd name="connsiteX1" fmla="*/ 1516918 w 12182168"/>
+              <a:gd name="connsiteY1" fmla="*/ 757084 h 776817"/>
+              <a:gd name="connsiteX2" fmla="*/ 3078311 w 12182168"/>
+              <a:gd name="connsiteY2" fmla="*/ 308 h 776817"/>
+              <a:gd name="connsiteX3" fmla="*/ 5289755 w 12182168"/>
+              <a:gd name="connsiteY3" fmla="*/ 776748 h 776817"/>
+              <a:gd name="connsiteX4" fmla="*/ 7452852 w 12182168"/>
+              <a:gd name="connsiteY4" fmla="*/ 49161 h 776817"/>
+              <a:gd name="connsiteX5" fmla="*/ 8837364 w 12182168"/>
+              <a:gd name="connsiteY5" fmla="*/ 616512 h 776817"/>
+              <a:gd name="connsiteX6" fmla="*/ 10378124 w 12182168"/>
+              <a:gd name="connsiteY6" fmla="*/ 44704 h 776817"/>
+              <a:gd name="connsiteX7" fmla="*/ 11614768 w 12182168"/>
+              <a:gd name="connsiteY7" fmla="*/ 724207 h 776817"/>
+              <a:gd name="connsiteX8" fmla="*/ 12182168 w 12182168"/>
+              <a:gd name="connsiteY8" fmla="*/ 19665 h 776817"/>
+              <a:gd name="connsiteX0" fmla="*/ 0 w 12182168"/>
+              <a:gd name="connsiteY0" fmla="*/ 0 h 776817"/>
+              <a:gd name="connsiteX1" fmla="*/ 1516918 w 12182168"/>
+              <a:gd name="connsiteY1" fmla="*/ 757084 h 776817"/>
+              <a:gd name="connsiteX2" fmla="*/ 3078311 w 12182168"/>
+              <a:gd name="connsiteY2" fmla="*/ 308 h 776817"/>
+              <a:gd name="connsiteX3" fmla="*/ 5289755 w 12182168"/>
+              <a:gd name="connsiteY3" fmla="*/ 776748 h 776817"/>
+              <a:gd name="connsiteX4" fmla="*/ 7452852 w 12182168"/>
+              <a:gd name="connsiteY4" fmla="*/ 49161 h 776817"/>
+              <a:gd name="connsiteX5" fmla="*/ 8837364 w 12182168"/>
+              <a:gd name="connsiteY5" fmla="*/ 616512 h 776817"/>
+              <a:gd name="connsiteX6" fmla="*/ 10378124 w 12182168"/>
+              <a:gd name="connsiteY6" fmla="*/ 44704 h 776817"/>
+              <a:gd name="connsiteX7" fmla="*/ 11614768 w 12182168"/>
+              <a:gd name="connsiteY7" fmla="*/ 724207 h 776817"/>
+              <a:gd name="connsiteX8" fmla="*/ 12182168 w 12182168"/>
+              <a:gd name="connsiteY8" fmla="*/ 19665 h 776817"/>
+              <a:gd name="connsiteX0" fmla="*/ 0 w 12182168"/>
+              <a:gd name="connsiteY0" fmla="*/ 0 h 767293"/>
+              <a:gd name="connsiteX1" fmla="*/ 1516918 w 12182168"/>
+              <a:gd name="connsiteY1" fmla="*/ 757084 h 767293"/>
+              <a:gd name="connsiteX2" fmla="*/ 3078311 w 12182168"/>
+              <a:gd name="connsiteY2" fmla="*/ 308 h 767293"/>
+              <a:gd name="connsiteX3" fmla="*/ 4557513 w 12182168"/>
+              <a:gd name="connsiteY3" fmla="*/ 767223 h 767293"/>
+              <a:gd name="connsiteX4" fmla="*/ 7452852 w 12182168"/>
+              <a:gd name="connsiteY4" fmla="*/ 49161 h 767293"/>
+              <a:gd name="connsiteX5" fmla="*/ 8837364 w 12182168"/>
+              <a:gd name="connsiteY5" fmla="*/ 616512 h 767293"/>
+              <a:gd name="connsiteX6" fmla="*/ 10378124 w 12182168"/>
+              <a:gd name="connsiteY6" fmla="*/ 44704 h 767293"/>
+              <a:gd name="connsiteX7" fmla="*/ 11614768 w 12182168"/>
+              <a:gd name="connsiteY7" fmla="*/ 724207 h 767293"/>
+              <a:gd name="connsiteX8" fmla="*/ 12182168 w 12182168"/>
+              <a:gd name="connsiteY8" fmla="*/ 19665 h 767293"/>
+              <a:gd name="connsiteX0" fmla="*/ 0 w 12182168"/>
+              <a:gd name="connsiteY0" fmla="*/ 0 h 767223"/>
+              <a:gd name="connsiteX1" fmla="*/ 1516918 w 12182168"/>
+              <a:gd name="connsiteY1" fmla="*/ 757084 h 767223"/>
+              <a:gd name="connsiteX2" fmla="*/ 3078311 w 12182168"/>
+              <a:gd name="connsiteY2" fmla="*/ 308 h 767223"/>
+              <a:gd name="connsiteX3" fmla="*/ 4557513 w 12182168"/>
+              <a:gd name="connsiteY3" fmla="*/ 767223 h 767223"/>
+              <a:gd name="connsiteX4" fmla="*/ 6083464 w 12182168"/>
+              <a:gd name="connsiteY4" fmla="*/ 1536 h 767223"/>
+              <a:gd name="connsiteX5" fmla="*/ 8837364 w 12182168"/>
+              <a:gd name="connsiteY5" fmla="*/ 616512 h 767223"/>
+              <a:gd name="connsiteX6" fmla="*/ 10378124 w 12182168"/>
+              <a:gd name="connsiteY6" fmla="*/ 44704 h 767223"/>
+              <a:gd name="connsiteX7" fmla="*/ 11614768 w 12182168"/>
+              <a:gd name="connsiteY7" fmla="*/ 724207 h 767223"/>
+              <a:gd name="connsiteX8" fmla="*/ 12182168 w 12182168"/>
+              <a:gd name="connsiteY8" fmla="*/ 19665 h 767223"/>
+              <a:gd name="connsiteX0" fmla="*/ 0 w 12182168"/>
+              <a:gd name="connsiteY0" fmla="*/ 0 h 767223"/>
+              <a:gd name="connsiteX1" fmla="*/ 1516918 w 12182168"/>
+              <a:gd name="connsiteY1" fmla="*/ 757084 h 767223"/>
+              <a:gd name="connsiteX2" fmla="*/ 3078311 w 12182168"/>
+              <a:gd name="connsiteY2" fmla="*/ 308 h 767223"/>
+              <a:gd name="connsiteX3" fmla="*/ 4557513 w 12182168"/>
+              <a:gd name="connsiteY3" fmla="*/ 767223 h 767223"/>
+              <a:gd name="connsiteX4" fmla="*/ 6083464 w 12182168"/>
+              <a:gd name="connsiteY4" fmla="*/ 1536 h 767223"/>
+              <a:gd name="connsiteX5" fmla="*/ 7650560 w 12182168"/>
+              <a:gd name="connsiteY5" fmla="*/ 753672 h 767223"/>
+              <a:gd name="connsiteX6" fmla="*/ 10378124 w 12182168"/>
+              <a:gd name="connsiteY6" fmla="*/ 44704 h 767223"/>
+              <a:gd name="connsiteX7" fmla="*/ 11614768 w 12182168"/>
+              <a:gd name="connsiteY7" fmla="*/ 724207 h 767223"/>
+              <a:gd name="connsiteX8" fmla="*/ 12182168 w 12182168"/>
+              <a:gd name="connsiteY8" fmla="*/ 19665 h 767223"/>
+              <a:gd name="connsiteX0" fmla="*/ 0 w 12182168"/>
+              <a:gd name="connsiteY0" fmla="*/ 0 h 767223"/>
+              <a:gd name="connsiteX1" fmla="*/ 1516918 w 12182168"/>
+              <a:gd name="connsiteY1" fmla="*/ 757084 h 767223"/>
+              <a:gd name="connsiteX2" fmla="*/ 3078311 w 12182168"/>
+              <a:gd name="connsiteY2" fmla="*/ 308 h 767223"/>
+              <a:gd name="connsiteX3" fmla="*/ 4557513 w 12182168"/>
+              <a:gd name="connsiteY3" fmla="*/ 767223 h 767223"/>
+              <a:gd name="connsiteX4" fmla="*/ 6083464 w 12182168"/>
+              <a:gd name="connsiteY4" fmla="*/ 1536 h 767223"/>
+              <a:gd name="connsiteX5" fmla="*/ 7650560 w 12182168"/>
+              <a:gd name="connsiteY5" fmla="*/ 753672 h 767223"/>
+              <a:gd name="connsiteX6" fmla="*/ 9145674 w 12182168"/>
+              <a:gd name="connsiteY6" fmla="*/ 21844 h 767223"/>
+              <a:gd name="connsiteX7" fmla="*/ 11614768 w 12182168"/>
+              <a:gd name="connsiteY7" fmla="*/ 724207 h 767223"/>
+              <a:gd name="connsiteX8" fmla="*/ 12182168 w 12182168"/>
+              <a:gd name="connsiteY8" fmla="*/ 19665 h 767223"/>
+              <a:gd name="connsiteX0" fmla="*/ 0 w 12182168"/>
+              <a:gd name="connsiteY0" fmla="*/ 0 h 767223"/>
+              <a:gd name="connsiteX1" fmla="*/ 1516918 w 12182168"/>
+              <a:gd name="connsiteY1" fmla="*/ 757084 h 767223"/>
+              <a:gd name="connsiteX2" fmla="*/ 3078311 w 12182168"/>
+              <a:gd name="connsiteY2" fmla="*/ 308 h 767223"/>
+              <a:gd name="connsiteX3" fmla="*/ 4557513 w 12182168"/>
+              <a:gd name="connsiteY3" fmla="*/ 767223 h 767223"/>
+              <a:gd name="connsiteX4" fmla="*/ 6083464 w 12182168"/>
+              <a:gd name="connsiteY4" fmla="*/ 1536 h 767223"/>
+              <a:gd name="connsiteX5" fmla="*/ 7650560 w 12182168"/>
+              <a:gd name="connsiteY5" fmla="*/ 753672 h 767223"/>
+              <a:gd name="connsiteX6" fmla="*/ 9145674 w 12182168"/>
+              <a:gd name="connsiteY6" fmla="*/ 21844 h 767223"/>
+              <a:gd name="connsiteX7" fmla="*/ 10679019 w 12182168"/>
+              <a:gd name="connsiteY7" fmla="*/ 747067 h 767223"/>
+              <a:gd name="connsiteX8" fmla="*/ 12182168 w 12182168"/>
+              <a:gd name="connsiteY8" fmla="*/ 19665 h 767223"/>
+              <a:gd name="connsiteX0" fmla="*/ 0 w 12048819"/>
+              <a:gd name="connsiteY0" fmla="*/ 0 h 767223"/>
+              <a:gd name="connsiteX1" fmla="*/ 1383569 w 12048819"/>
+              <a:gd name="connsiteY1" fmla="*/ 757084 h 767223"/>
+              <a:gd name="connsiteX2" fmla="*/ 2944962 w 12048819"/>
+              <a:gd name="connsiteY2" fmla="*/ 308 h 767223"/>
+              <a:gd name="connsiteX3" fmla="*/ 4424164 w 12048819"/>
+              <a:gd name="connsiteY3" fmla="*/ 767223 h 767223"/>
+              <a:gd name="connsiteX4" fmla="*/ 5950115 w 12048819"/>
+              <a:gd name="connsiteY4" fmla="*/ 1536 h 767223"/>
+              <a:gd name="connsiteX5" fmla="*/ 7517211 w 12048819"/>
+              <a:gd name="connsiteY5" fmla="*/ 753672 h 767223"/>
+              <a:gd name="connsiteX6" fmla="*/ 9012325 w 12048819"/>
+              <a:gd name="connsiteY6" fmla="*/ 21844 h 767223"/>
+              <a:gd name="connsiteX7" fmla="*/ 10545670 w 12048819"/>
+              <a:gd name="connsiteY7" fmla="*/ 747067 h 767223"/>
+              <a:gd name="connsiteX8" fmla="*/ 12048819 w 12048819"/>
+              <a:gd name="connsiteY8" fmla="*/ 19665 h 767223"/>
+              <a:gd name="connsiteX0" fmla="*/ 0 w 12223197"/>
+              <a:gd name="connsiteY0" fmla="*/ 0 h 767223"/>
+              <a:gd name="connsiteX1" fmla="*/ 1557947 w 12223197"/>
+              <a:gd name="connsiteY1" fmla="*/ 757084 h 767223"/>
+              <a:gd name="connsiteX2" fmla="*/ 3119340 w 12223197"/>
+              <a:gd name="connsiteY2" fmla="*/ 308 h 767223"/>
+              <a:gd name="connsiteX3" fmla="*/ 4598542 w 12223197"/>
+              <a:gd name="connsiteY3" fmla="*/ 767223 h 767223"/>
+              <a:gd name="connsiteX4" fmla="*/ 6124493 w 12223197"/>
+              <a:gd name="connsiteY4" fmla="*/ 1536 h 767223"/>
+              <a:gd name="connsiteX5" fmla="*/ 7691589 w 12223197"/>
+              <a:gd name="connsiteY5" fmla="*/ 753672 h 767223"/>
+              <a:gd name="connsiteX6" fmla="*/ 9186703 w 12223197"/>
+              <a:gd name="connsiteY6" fmla="*/ 21844 h 767223"/>
+              <a:gd name="connsiteX7" fmla="*/ 10720048 w 12223197"/>
+              <a:gd name="connsiteY7" fmla="*/ 747067 h 767223"/>
+              <a:gd name="connsiteX8" fmla="*/ 12223197 w 12223197"/>
+              <a:gd name="connsiteY8" fmla="*/ 19665 h 767223"/>
+              <a:gd name="connsiteX0" fmla="*/ 0 w 12582213"/>
+              <a:gd name="connsiteY0" fmla="*/ 40792 h 766918"/>
+              <a:gd name="connsiteX1" fmla="*/ 1916963 w 12582213"/>
+              <a:gd name="connsiteY1" fmla="*/ 756779 h 766918"/>
+              <a:gd name="connsiteX2" fmla="*/ 3478356 w 12582213"/>
+              <a:gd name="connsiteY2" fmla="*/ 3 h 766918"/>
+              <a:gd name="connsiteX3" fmla="*/ 4957558 w 12582213"/>
+              <a:gd name="connsiteY3" fmla="*/ 766918 h 766918"/>
+              <a:gd name="connsiteX4" fmla="*/ 6483509 w 12582213"/>
+              <a:gd name="connsiteY4" fmla="*/ 1231 h 766918"/>
+              <a:gd name="connsiteX5" fmla="*/ 8050605 w 12582213"/>
+              <a:gd name="connsiteY5" fmla="*/ 753367 h 766918"/>
+              <a:gd name="connsiteX6" fmla="*/ 9545719 w 12582213"/>
+              <a:gd name="connsiteY6" fmla="*/ 21539 h 766918"/>
+              <a:gd name="connsiteX7" fmla="*/ 11079064 w 12582213"/>
+              <a:gd name="connsiteY7" fmla="*/ 746762 h 766918"/>
+              <a:gd name="connsiteX8" fmla="*/ 12582213 w 12582213"/>
+              <a:gd name="connsiteY8" fmla="*/ 19360 h 766918"/>
+              <a:gd name="connsiteX0" fmla="*/ 0 w 12571956"/>
+              <a:gd name="connsiteY0" fmla="*/ 0 h 798045"/>
+              <a:gd name="connsiteX1" fmla="*/ 1906706 w 12571956"/>
+              <a:gd name="connsiteY1" fmla="*/ 787906 h 798045"/>
+              <a:gd name="connsiteX2" fmla="*/ 3468099 w 12571956"/>
+              <a:gd name="connsiteY2" fmla="*/ 31130 h 798045"/>
+              <a:gd name="connsiteX3" fmla="*/ 4947301 w 12571956"/>
+              <a:gd name="connsiteY3" fmla="*/ 798045 h 798045"/>
+              <a:gd name="connsiteX4" fmla="*/ 6473252 w 12571956"/>
+              <a:gd name="connsiteY4" fmla="*/ 32358 h 798045"/>
+              <a:gd name="connsiteX5" fmla="*/ 8040348 w 12571956"/>
+              <a:gd name="connsiteY5" fmla="*/ 784494 h 798045"/>
+              <a:gd name="connsiteX6" fmla="*/ 9535462 w 12571956"/>
+              <a:gd name="connsiteY6" fmla="*/ 52666 h 798045"/>
+              <a:gd name="connsiteX7" fmla="*/ 11068807 w 12571956"/>
+              <a:gd name="connsiteY7" fmla="*/ 777889 h 798045"/>
+              <a:gd name="connsiteX8" fmla="*/ 12571956 w 12571956"/>
+              <a:gd name="connsiteY8" fmla="*/ 50487 h 798045"/>
+              <a:gd name="connsiteX0" fmla="*/ 0 w 12571956"/>
+              <a:gd name="connsiteY0" fmla="*/ 20243 h 766918"/>
+              <a:gd name="connsiteX1" fmla="*/ 1906706 w 12571956"/>
+              <a:gd name="connsiteY1" fmla="*/ 756779 h 766918"/>
+              <a:gd name="connsiteX2" fmla="*/ 3468099 w 12571956"/>
+              <a:gd name="connsiteY2" fmla="*/ 3 h 766918"/>
+              <a:gd name="connsiteX3" fmla="*/ 4947301 w 12571956"/>
+              <a:gd name="connsiteY3" fmla="*/ 766918 h 766918"/>
+              <a:gd name="connsiteX4" fmla="*/ 6473252 w 12571956"/>
+              <a:gd name="connsiteY4" fmla="*/ 1231 h 766918"/>
+              <a:gd name="connsiteX5" fmla="*/ 8040348 w 12571956"/>
+              <a:gd name="connsiteY5" fmla="*/ 753367 h 766918"/>
+              <a:gd name="connsiteX6" fmla="*/ 9535462 w 12571956"/>
+              <a:gd name="connsiteY6" fmla="*/ 21539 h 766918"/>
+              <a:gd name="connsiteX7" fmla="*/ 11068807 w 12571956"/>
+              <a:gd name="connsiteY7" fmla="*/ 746762 h 766918"/>
+              <a:gd name="connsiteX8" fmla="*/ 12571956 w 12571956"/>
+              <a:gd name="connsiteY8" fmla="*/ 19360 h 766918"/>
+              <a:gd name="connsiteX0" fmla="*/ 0 w 12571956"/>
+              <a:gd name="connsiteY0" fmla="*/ 0 h 777497"/>
+              <a:gd name="connsiteX1" fmla="*/ 1906706 w 12571956"/>
+              <a:gd name="connsiteY1" fmla="*/ 767358 h 777497"/>
+              <a:gd name="connsiteX2" fmla="*/ 3468099 w 12571956"/>
+              <a:gd name="connsiteY2" fmla="*/ 10582 h 777497"/>
+              <a:gd name="connsiteX3" fmla="*/ 4947301 w 12571956"/>
+              <a:gd name="connsiteY3" fmla="*/ 777497 h 777497"/>
+              <a:gd name="connsiteX4" fmla="*/ 6473252 w 12571956"/>
+              <a:gd name="connsiteY4" fmla="*/ 11810 h 777497"/>
+              <a:gd name="connsiteX5" fmla="*/ 8040348 w 12571956"/>
+              <a:gd name="connsiteY5" fmla="*/ 763946 h 777497"/>
+              <a:gd name="connsiteX6" fmla="*/ 9535462 w 12571956"/>
+              <a:gd name="connsiteY6" fmla="*/ 32118 h 777497"/>
+              <a:gd name="connsiteX7" fmla="*/ 11068807 w 12571956"/>
+              <a:gd name="connsiteY7" fmla="*/ 757341 h 777497"/>
+              <a:gd name="connsiteX8" fmla="*/ 12571956 w 12571956"/>
+              <a:gd name="connsiteY8" fmla="*/ 29939 h 777497"/>
+              <a:gd name="connsiteX0" fmla="*/ 0 w 12212940"/>
+              <a:gd name="connsiteY0" fmla="*/ 30517 h 766918"/>
+              <a:gd name="connsiteX1" fmla="*/ 1547690 w 12212940"/>
+              <a:gd name="connsiteY1" fmla="*/ 756779 h 766918"/>
+              <a:gd name="connsiteX2" fmla="*/ 3109083 w 12212940"/>
+              <a:gd name="connsiteY2" fmla="*/ 3 h 766918"/>
+              <a:gd name="connsiteX3" fmla="*/ 4588285 w 12212940"/>
+              <a:gd name="connsiteY3" fmla="*/ 766918 h 766918"/>
+              <a:gd name="connsiteX4" fmla="*/ 6114236 w 12212940"/>
+              <a:gd name="connsiteY4" fmla="*/ 1231 h 766918"/>
+              <a:gd name="connsiteX5" fmla="*/ 7681332 w 12212940"/>
+              <a:gd name="connsiteY5" fmla="*/ 753367 h 766918"/>
+              <a:gd name="connsiteX6" fmla="*/ 9176446 w 12212940"/>
+              <a:gd name="connsiteY6" fmla="*/ 21539 h 766918"/>
+              <a:gd name="connsiteX7" fmla="*/ 10709791 w 12212940"/>
+              <a:gd name="connsiteY7" fmla="*/ 746762 h 766918"/>
+              <a:gd name="connsiteX8" fmla="*/ 12212940 w 12212940"/>
+              <a:gd name="connsiteY8" fmla="*/ 19360 h 766918"/>
+              <a:gd name="connsiteX0" fmla="*/ 0 w 12161653"/>
+              <a:gd name="connsiteY0" fmla="*/ 9969 h 766918"/>
+              <a:gd name="connsiteX1" fmla="*/ 1496403 w 12161653"/>
+              <a:gd name="connsiteY1" fmla="*/ 756779 h 766918"/>
+              <a:gd name="connsiteX2" fmla="*/ 3057796 w 12161653"/>
+              <a:gd name="connsiteY2" fmla="*/ 3 h 766918"/>
+              <a:gd name="connsiteX3" fmla="*/ 4536998 w 12161653"/>
+              <a:gd name="connsiteY3" fmla="*/ 766918 h 766918"/>
+              <a:gd name="connsiteX4" fmla="*/ 6062949 w 12161653"/>
+              <a:gd name="connsiteY4" fmla="*/ 1231 h 766918"/>
+              <a:gd name="connsiteX5" fmla="*/ 7630045 w 12161653"/>
+              <a:gd name="connsiteY5" fmla="*/ 753367 h 766918"/>
+              <a:gd name="connsiteX6" fmla="*/ 9125159 w 12161653"/>
+              <a:gd name="connsiteY6" fmla="*/ 21539 h 766918"/>
+              <a:gd name="connsiteX7" fmla="*/ 10658504 w 12161653"/>
+              <a:gd name="connsiteY7" fmla="*/ 746762 h 766918"/>
+              <a:gd name="connsiteX8" fmla="*/ 12161653 w 12161653"/>
+              <a:gd name="connsiteY8" fmla="*/ 19360 h 766918"/>
+              <a:gd name="connsiteX0" fmla="*/ 0 w 12161653"/>
+              <a:gd name="connsiteY0" fmla="*/ 9969 h 766918"/>
+              <a:gd name="connsiteX1" fmla="*/ 1496403 w 12161653"/>
+              <a:gd name="connsiteY1" fmla="*/ 756779 h 766918"/>
+              <a:gd name="connsiteX2" fmla="*/ 3027023 w 12161653"/>
+              <a:gd name="connsiteY2" fmla="*/ 3 h 766918"/>
+              <a:gd name="connsiteX3" fmla="*/ 4536998 w 12161653"/>
+              <a:gd name="connsiteY3" fmla="*/ 766918 h 766918"/>
+              <a:gd name="connsiteX4" fmla="*/ 6062949 w 12161653"/>
+              <a:gd name="connsiteY4" fmla="*/ 1231 h 766918"/>
+              <a:gd name="connsiteX5" fmla="*/ 7630045 w 12161653"/>
+              <a:gd name="connsiteY5" fmla="*/ 753367 h 766918"/>
+              <a:gd name="connsiteX6" fmla="*/ 9125159 w 12161653"/>
+              <a:gd name="connsiteY6" fmla="*/ 21539 h 766918"/>
+              <a:gd name="connsiteX7" fmla="*/ 10658504 w 12161653"/>
+              <a:gd name="connsiteY7" fmla="*/ 746762 h 766918"/>
+              <a:gd name="connsiteX8" fmla="*/ 12161653 w 12161653"/>
+              <a:gd name="connsiteY8" fmla="*/ 19360 h 766918"/>
+              <a:gd name="connsiteX0" fmla="*/ 0 w 12161653"/>
+              <a:gd name="connsiteY0" fmla="*/ 9969 h 766918"/>
+              <a:gd name="connsiteX1" fmla="*/ 1496403 w 12161653"/>
+              <a:gd name="connsiteY1" fmla="*/ 756779 h 766918"/>
+              <a:gd name="connsiteX2" fmla="*/ 3027023 w 12161653"/>
+              <a:gd name="connsiteY2" fmla="*/ 3 h 766918"/>
+              <a:gd name="connsiteX3" fmla="*/ 4536998 w 12161653"/>
+              <a:gd name="connsiteY3" fmla="*/ 766918 h 766918"/>
+              <a:gd name="connsiteX4" fmla="*/ 6062949 w 12161653"/>
+              <a:gd name="connsiteY4" fmla="*/ 1231 h 766918"/>
+              <a:gd name="connsiteX5" fmla="*/ 7630045 w 12161653"/>
+              <a:gd name="connsiteY5" fmla="*/ 753367 h 766918"/>
+              <a:gd name="connsiteX6" fmla="*/ 9125159 w 12161653"/>
+              <a:gd name="connsiteY6" fmla="*/ 21539 h 766918"/>
+              <a:gd name="connsiteX7" fmla="*/ 10658504 w 12161653"/>
+              <a:gd name="connsiteY7" fmla="*/ 746762 h 766918"/>
+              <a:gd name="connsiteX8" fmla="*/ 12161653 w 12161653"/>
+              <a:gd name="connsiteY8" fmla="*/ 19360 h 766918"/>
+              <a:gd name="connsiteX0" fmla="*/ 1412 w 12163065"/>
+              <a:gd name="connsiteY0" fmla="*/ 9969 h 766918"/>
+              <a:gd name="connsiteX1" fmla="*/ 1497815 w 12163065"/>
+              <a:gd name="connsiteY1" fmla="*/ 756779 h 766918"/>
+              <a:gd name="connsiteX2" fmla="*/ 3028435 w 12163065"/>
+              <a:gd name="connsiteY2" fmla="*/ 3 h 766918"/>
+              <a:gd name="connsiteX3" fmla="*/ 4538410 w 12163065"/>
+              <a:gd name="connsiteY3" fmla="*/ 766918 h 766918"/>
+              <a:gd name="connsiteX4" fmla="*/ 6064361 w 12163065"/>
+              <a:gd name="connsiteY4" fmla="*/ 1231 h 766918"/>
+              <a:gd name="connsiteX5" fmla="*/ 7631457 w 12163065"/>
+              <a:gd name="connsiteY5" fmla="*/ 753367 h 766918"/>
+              <a:gd name="connsiteX6" fmla="*/ 9126571 w 12163065"/>
+              <a:gd name="connsiteY6" fmla="*/ 21539 h 766918"/>
+              <a:gd name="connsiteX7" fmla="*/ 10659916 w 12163065"/>
+              <a:gd name="connsiteY7" fmla="*/ 746762 h 766918"/>
+              <a:gd name="connsiteX8" fmla="*/ 12163065 w 12163065"/>
+              <a:gd name="connsiteY8" fmla="*/ 19360 h 766918"/>
+              <a:gd name="connsiteX0" fmla="*/ 0 w 12161653"/>
+              <a:gd name="connsiteY0" fmla="*/ 9969 h 766918"/>
+              <a:gd name="connsiteX1" fmla="*/ 1496403 w 12161653"/>
+              <a:gd name="connsiteY1" fmla="*/ 756779 h 766918"/>
+              <a:gd name="connsiteX2" fmla="*/ 3027023 w 12161653"/>
+              <a:gd name="connsiteY2" fmla="*/ 3 h 766918"/>
+              <a:gd name="connsiteX3" fmla="*/ 4536998 w 12161653"/>
+              <a:gd name="connsiteY3" fmla="*/ 766918 h 766918"/>
+              <a:gd name="connsiteX4" fmla="*/ 6062949 w 12161653"/>
+              <a:gd name="connsiteY4" fmla="*/ 1231 h 766918"/>
+              <a:gd name="connsiteX5" fmla="*/ 7630045 w 12161653"/>
+              <a:gd name="connsiteY5" fmla="*/ 753367 h 766918"/>
+              <a:gd name="connsiteX6" fmla="*/ 9125159 w 12161653"/>
+              <a:gd name="connsiteY6" fmla="*/ 21539 h 766918"/>
+              <a:gd name="connsiteX7" fmla="*/ 10658504 w 12161653"/>
+              <a:gd name="connsiteY7" fmla="*/ 746762 h 766918"/>
+              <a:gd name="connsiteX8" fmla="*/ 12161653 w 12161653"/>
+              <a:gd name="connsiteY8" fmla="*/ 19360 h 766918"/>
+              <a:gd name="connsiteX0" fmla="*/ 0 w 12161653"/>
+              <a:gd name="connsiteY0" fmla="*/ 16526 h 773475"/>
+              <a:gd name="connsiteX1" fmla="*/ 1496403 w 12161653"/>
+              <a:gd name="connsiteY1" fmla="*/ 383192 h 773475"/>
+              <a:gd name="connsiteX2" fmla="*/ 3027023 w 12161653"/>
+              <a:gd name="connsiteY2" fmla="*/ 6560 h 773475"/>
+              <a:gd name="connsiteX3" fmla="*/ 4536998 w 12161653"/>
+              <a:gd name="connsiteY3" fmla="*/ 773475 h 773475"/>
+              <a:gd name="connsiteX4" fmla="*/ 6062949 w 12161653"/>
+              <a:gd name="connsiteY4" fmla="*/ 7788 h 773475"/>
+              <a:gd name="connsiteX5" fmla="*/ 7630045 w 12161653"/>
+              <a:gd name="connsiteY5" fmla="*/ 759924 h 773475"/>
+              <a:gd name="connsiteX6" fmla="*/ 9125159 w 12161653"/>
+              <a:gd name="connsiteY6" fmla="*/ 28096 h 773475"/>
+              <a:gd name="connsiteX7" fmla="*/ 10658504 w 12161653"/>
+              <a:gd name="connsiteY7" fmla="*/ 753319 h 773475"/>
+              <a:gd name="connsiteX8" fmla="*/ 12161653 w 12161653"/>
+              <a:gd name="connsiteY8" fmla="*/ 25917 h 773475"/>
+              <a:gd name="connsiteX0" fmla="*/ 0 w 12161653"/>
+              <a:gd name="connsiteY0" fmla="*/ 16526 h 773475"/>
+              <a:gd name="connsiteX1" fmla="*/ 1496403 w 12161653"/>
+              <a:gd name="connsiteY1" fmla="*/ 383192 h 773475"/>
+              <a:gd name="connsiteX2" fmla="*/ 3027023 w 12161653"/>
+              <a:gd name="connsiteY2" fmla="*/ 6560 h 773475"/>
+              <a:gd name="connsiteX3" fmla="*/ 4536998 w 12161653"/>
+              <a:gd name="connsiteY3" fmla="*/ 773475 h 773475"/>
+              <a:gd name="connsiteX4" fmla="*/ 6062949 w 12161653"/>
+              <a:gd name="connsiteY4" fmla="*/ 7788 h 773475"/>
+              <a:gd name="connsiteX5" fmla="*/ 7630045 w 12161653"/>
+              <a:gd name="connsiteY5" fmla="*/ 759924 h 773475"/>
+              <a:gd name="connsiteX6" fmla="*/ 9125159 w 12161653"/>
+              <a:gd name="connsiteY6" fmla="*/ 28096 h 773475"/>
+              <a:gd name="connsiteX7" fmla="*/ 10658504 w 12161653"/>
+              <a:gd name="connsiteY7" fmla="*/ 753319 h 773475"/>
+              <a:gd name="connsiteX8" fmla="*/ 12161653 w 12161653"/>
+              <a:gd name="connsiteY8" fmla="*/ 25917 h 773475"/>
+              <a:gd name="connsiteX0" fmla="*/ 0 w 12161653"/>
+              <a:gd name="connsiteY0" fmla="*/ 13702 h 757111"/>
+              <a:gd name="connsiteX1" fmla="*/ 1496403 w 12161653"/>
+              <a:gd name="connsiteY1" fmla="*/ 380368 h 757111"/>
+              <a:gd name="connsiteX2" fmla="*/ 3027023 w 12161653"/>
+              <a:gd name="connsiteY2" fmla="*/ 3736 h 757111"/>
+              <a:gd name="connsiteX3" fmla="*/ 4536998 w 12161653"/>
+              <a:gd name="connsiteY3" fmla="*/ 411056 h 757111"/>
+              <a:gd name="connsiteX4" fmla="*/ 6062949 w 12161653"/>
+              <a:gd name="connsiteY4" fmla="*/ 4964 h 757111"/>
+              <a:gd name="connsiteX5" fmla="*/ 7630045 w 12161653"/>
+              <a:gd name="connsiteY5" fmla="*/ 757100 h 757111"/>
+              <a:gd name="connsiteX6" fmla="*/ 9125159 w 12161653"/>
+              <a:gd name="connsiteY6" fmla="*/ 25272 h 757111"/>
+              <a:gd name="connsiteX7" fmla="*/ 10658504 w 12161653"/>
+              <a:gd name="connsiteY7" fmla="*/ 750495 h 757111"/>
+              <a:gd name="connsiteX8" fmla="*/ 12161653 w 12161653"/>
+              <a:gd name="connsiteY8" fmla="*/ 23093 h 757111"/>
+              <a:gd name="connsiteX0" fmla="*/ 0 w 12161653"/>
+              <a:gd name="connsiteY0" fmla="*/ 10018 h 746811"/>
+              <a:gd name="connsiteX1" fmla="*/ 1496403 w 12161653"/>
+              <a:gd name="connsiteY1" fmla="*/ 376684 h 746811"/>
+              <a:gd name="connsiteX2" fmla="*/ 3027023 w 12161653"/>
+              <a:gd name="connsiteY2" fmla="*/ 52 h 746811"/>
+              <a:gd name="connsiteX3" fmla="*/ 4536998 w 12161653"/>
+              <a:gd name="connsiteY3" fmla="*/ 407372 h 746811"/>
+              <a:gd name="connsiteX4" fmla="*/ 6062949 w 12161653"/>
+              <a:gd name="connsiteY4" fmla="*/ 1280 h 746811"/>
+              <a:gd name="connsiteX5" fmla="*/ 7609531 w 12161653"/>
+              <a:gd name="connsiteY5" fmla="*/ 414369 h 746811"/>
+              <a:gd name="connsiteX6" fmla="*/ 9125159 w 12161653"/>
+              <a:gd name="connsiteY6" fmla="*/ 21588 h 746811"/>
+              <a:gd name="connsiteX7" fmla="*/ 10658504 w 12161653"/>
+              <a:gd name="connsiteY7" fmla="*/ 746811 h 746811"/>
+              <a:gd name="connsiteX8" fmla="*/ 12161653 w 12161653"/>
+              <a:gd name="connsiteY8" fmla="*/ 19409 h 746811"/>
+              <a:gd name="connsiteX0" fmla="*/ 0 w 12161653"/>
+              <a:gd name="connsiteY0" fmla="*/ 10018 h 414390"/>
+              <a:gd name="connsiteX1" fmla="*/ 1496403 w 12161653"/>
+              <a:gd name="connsiteY1" fmla="*/ 376684 h 414390"/>
+              <a:gd name="connsiteX2" fmla="*/ 3027023 w 12161653"/>
+              <a:gd name="connsiteY2" fmla="*/ 52 h 414390"/>
+              <a:gd name="connsiteX3" fmla="*/ 4536998 w 12161653"/>
+              <a:gd name="connsiteY3" fmla="*/ 407372 h 414390"/>
+              <a:gd name="connsiteX4" fmla="*/ 6062949 w 12161653"/>
+              <a:gd name="connsiteY4" fmla="*/ 1280 h 414390"/>
+              <a:gd name="connsiteX5" fmla="*/ 7609531 w 12161653"/>
+              <a:gd name="connsiteY5" fmla="*/ 414369 h 414390"/>
+              <a:gd name="connsiteX6" fmla="*/ 9125159 w 12161653"/>
+              <a:gd name="connsiteY6" fmla="*/ 21588 h 414390"/>
+              <a:gd name="connsiteX7" fmla="*/ 10637989 w 12161653"/>
+              <a:gd name="connsiteY7" fmla="*/ 407763 h 414390"/>
+              <a:gd name="connsiteX8" fmla="*/ 12161653 w 12161653"/>
+              <a:gd name="connsiteY8" fmla="*/ 19409 h 414390"/>
+              <a:gd name="connsiteX0" fmla="*/ 0 w 12161653"/>
+              <a:gd name="connsiteY0" fmla="*/ 10018 h 479682"/>
+              <a:gd name="connsiteX1" fmla="*/ 1496403 w 12161653"/>
+              <a:gd name="connsiteY1" fmla="*/ 376684 h 479682"/>
+              <a:gd name="connsiteX2" fmla="*/ 3027023 w 12161653"/>
+              <a:gd name="connsiteY2" fmla="*/ 52 h 479682"/>
+              <a:gd name="connsiteX3" fmla="*/ 4536998 w 12161653"/>
+              <a:gd name="connsiteY3" fmla="*/ 407372 h 479682"/>
+              <a:gd name="connsiteX4" fmla="*/ 6062949 w 12161653"/>
+              <a:gd name="connsiteY4" fmla="*/ 1280 h 479682"/>
+              <a:gd name="connsiteX5" fmla="*/ 7609531 w 12161653"/>
+              <a:gd name="connsiteY5" fmla="*/ 414369 h 479682"/>
+              <a:gd name="connsiteX6" fmla="*/ 9125159 w 12161653"/>
+              <a:gd name="connsiteY6" fmla="*/ 21588 h 479682"/>
+              <a:gd name="connsiteX7" fmla="*/ 10637989 w 12161653"/>
+              <a:gd name="connsiteY7" fmla="*/ 479682 h 479682"/>
+              <a:gd name="connsiteX8" fmla="*/ 12161653 w 12161653"/>
+              <a:gd name="connsiteY8" fmla="*/ 19409 h 479682"/>
+              <a:gd name="connsiteX0" fmla="*/ 430 w 12162083"/>
+              <a:gd name="connsiteY0" fmla="*/ 10018 h 479682"/>
+              <a:gd name="connsiteX1" fmla="*/ 1496833 w 12162083"/>
+              <a:gd name="connsiteY1" fmla="*/ 376684 h 479682"/>
+              <a:gd name="connsiteX2" fmla="*/ 3027453 w 12162083"/>
+              <a:gd name="connsiteY2" fmla="*/ 52 h 479682"/>
+              <a:gd name="connsiteX3" fmla="*/ 4537428 w 12162083"/>
+              <a:gd name="connsiteY3" fmla="*/ 407372 h 479682"/>
+              <a:gd name="connsiteX4" fmla="*/ 6063379 w 12162083"/>
+              <a:gd name="connsiteY4" fmla="*/ 1280 h 479682"/>
+              <a:gd name="connsiteX5" fmla="*/ 7609961 w 12162083"/>
+              <a:gd name="connsiteY5" fmla="*/ 414369 h 479682"/>
+              <a:gd name="connsiteX6" fmla="*/ 9125589 w 12162083"/>
+              <a:gd name="connsiteY6" fmla="*/ 21588 h 479682"/>
+              <a:gd name="connsiteX7" fmla="*/ 10638419 w 12162083"/>
+              <a:gd name="connsiteY7" fmla="*/ 479682 h 479682"/>
+              <a:gd name="connsiteX8" fmla="*/ 12162083 w 12162083"/>
+              <a:gd name="connsiteY8" fmla="*/ 19409 h 479682"/>
+              <a:gd name="connsiteX0" fmla="*/ 430 w 12162083"/>
+              <a:gd name="connsiteY0" fmla="*/ 10043 h 479707"/>
+              <a:gd name="connsiteX1" fmla="*/ 1496833 w 12162083"/>
+              <a:gd name="connsiteY1" fmla="*/ 376709 h 479707"/>
+              <a:gd name="connsiteX2" fmla="*/ 3027453 w 12162083"/>
+              <a:gd name="connsiteY2" fmla="*/ 77 h 479707"/>
+              <a:gd name="connsiteX3" fmla="*/ 4563580 w 12162083"/>
+              <a:gd name="connsiteY3" fmla="*/ 414541 h 479707"/>
+              <a:gd name="connsiteX4" fmla="*/ 6063379 w 12162083"/>
+              <a:gd name="connsiteY4" fmla="*/ 1305 h 479707"/>
+              <a:gd name="connsiteX5" fmla="*/ 7609961 w 12162083"/>
+              <a:gd name="connsiteY5" fmla="*/ 414394 h 479707"/>
+              <a:gd name="connsiteX6" fmla="*/ 9125589 w 12162083"/>
+              <a:gd name="connsiteY6" fmla="*/ 21613 h 479707"/>
+              <a:gd name="connsiteX7" fmla="*/ 10638419 w 12162083"/>
+              <a:gd name="connsiteY7" fmla="*/ 479707 h 479707"/>
+              <a:gd name="connsiteX8" fmla="*/ 12162083 w 12162083"/>
+              <a:gd name="connsiteY8" fmla="*/ 19434 h 479707"/>
+              <a:gd name="connsiteX0" fmla="*/ 430 w 12162083"/>
+              <a:gd name="connsiteY0" fmla="*/ 10053 h 479717"/>
+              <a:gd name="connsiteX1" fmla="*/ 1496833 w 12162083"/>
+              <a:gd name="connsiteY1" fmla="*/ 376719 h 479717"/>
+              <a:gd name="connsiteX2" fmla="*/ 3027453 w 12162083"/>
+              <a:gd name="connsiteY2" fmla="*/ 87 h 479717"/>
+              <a:gd name="connsiteX3" fmla="*/ 4539805 w 12162083"/>
+              <a:gd name="connsiteY3" fmla="*/ 416932 h 479717"/>
+              <a:gd name="connsiteX4" fmla="*/ 6063379 w 12162083"/>
+              <a:gd name="connsiteY4" fmla="*/ 1315 h 479717"/>
+              <a:gd name="connsiteX5" fmla="*/ 7609961 w 12162083"/>
+              <a:gd name="connsiteY5" fmla="*/ 414404 h 479717"/>
+              <a:gd name="connsiteX6" fmla="*/ 9125589 w 12162083"/>
+              <a:gd name="connsiteY6" fmla="*/ 21623 h 479717"/>
+              <a:gd name="connsiteX7" fmla="*/ 10638419 w 12162083"/>
+              <a:gd name="connsiteY7" fmla="*/ 479717 h 479717"/>
+              <a:gd name="connsiteX8" fmla="*/ 12162083 w 12162083"/>
+              <a:gd name="connsiteY8" fmla="*/ 19444 h 479717"/>
+              <a:gd name="connsiteX0" fmla="*/ 430 w 12162083"/>
+              <a:gd name="connsiteY0" fmla="*/ 10063 h 479727"/>
+              <a:gd name="connsiteX1" fmla="*/ 1496833 w 12162083"/>
+              <a:gd name="connsiteY1" fmla="*/ 376729 h 479727"/>
+              <a:gd name="connsiteX2" fmla="*/ 3027453 w 12162083"/>
+              <a:gd name="connsiteY2" fmla="*/ 97 h 479727"/>
+              <a:gd name="connsiteX3" fmla="*/ 4549315 w 12162083"/>
+              <a:gd name="connsiteY3" fmla="*/ 419323 h 479727"/>
+              <a:gd name="connsiteX4" fmla="*/ 6063379 w 12162083"/>
+              <a:gd name="connsiteY4" fmla="*/ 1325 h 479727"/>
+              <a:gd name="connsiteX5" fmla="*/ 7609961 w 12162083"/>
+              <a:gd name="connsiteY5" fmla="*/ 414414 h 479727"/>
+              <a:gd name="connsiteX6" fmla="*/ 9125589 w 12162083"/>
+              <a:gd name="connsiteY6" fmla="*/ 21633 h 479727"/>
+              <a:gd name="connsiteX7" fmla="*/ 10638419 w 12162083"/>
+              <a:gd name="connsiteY7" fmla="*/ 479727 h 479727"/>
+              <a:gd name="connsiteX8" fmla="*/ 12162083 w 12162083"/>
+              <a:gd name="connsiteY8" fmla="*/ 19454 h 479727"/>
+              <a:gd name="connsiteX0" fmla="*/ 428 w 12162081"/>
+              <a:gd name="connsiteY0" fmla="*/ 9967 h 479631"/>
+              <a:gd name="connsiteX1" fmla="*/ 1503962 w 12162081"/>
+              <a:gd name="connsiteY1" fmla="*/ 419496 h 479631"/>
+              <a:gd name="connsiteX2" fmla="*/ 3027451 w 12162081"/>
+              <a:gd name="connsiteY2" fmla="*/ 1 h 479631"/>
+              <a:gd name="connsiteX3" fmla="*/ 4549313 w 12162081"/>
+              <a:gd name="connsiteY3" fmla="*/ 419227 h 479631"/>
+              <a:gd name="connsiteX4" fmla="*/ 6063377 w 12162081"/>
+              <a:gd name="connsiteY4" fmla="*/ 1229 h 479631"/>
+              <a:gd name="connsiteX5" fmla="*/ 7609959 w 12162081"/>
+              <a:gd name="connsiteY5" fmla="*/ 414318 h 479631"/>
+              <a:gd name="connsiteX6" fmla="*/ 9125587 w 12162081"/>
+              <a:gd name="connsiteY6" fmla="*/ 21537 h 479631"/>
+              <a:gd name="connsiteX7" fmla="*/ 10638417 w 12162081"/>
+              <a:gd name="connsiteY7" fmla="*/ 479631 h 479631"/>
+              <a:gd name="connsiteX8" fmla="*/ 12162081 w 12162081"/>
+              <a:gd name="connsiteY8" fmla="*/ 19358 h 479631"/>
+              <a:gd name="connsiteX0" fmla="*/ 428 w 12162081"/>
+              <a:gd name="connsiteY0" fmla="*/ 9967 h 419500"/>
+              <a:gd name="connsiteX1" fmla="*/ 1503962 w 12162081"/>
+              <a:gd name="connsiteY1" fmla="*/ 419496 h 419500"/>
+              <a:gd name="connsiteX2" fmla="*/ 3027451 w 12162081"/>
+              <a:gd name="connsiteY2" fmla="*/ 1 h 419500"/>
+              <a:gd name="connsiteX3" fmla="*/ 4549313 w 12162081"/>
+              <a:gd name="connsiteY3" fmla="*/ 419227 h 419500"/>
+              <a:gd name="connsiteX4" fmla="*/ 6063377 w 12162081"/>
+              <a:gd name="connsiteY4" fmla="*/ 1229 h 419500"/>
+              <a:gd name="connsiteX5" fmla="*/ 7609959 w 12162081"/>
+              <a:gd name="connsiteY5" fmla="*/ 414318 h 419500"/>
+              <a:gd name="connsiteX6" fmla="*/ 9125587 w 12162081"/>
+              <a:gd name="connsiteY6" fmla="*/ 21537 h 419500"/>
+              <a:gd name="connsiteX7" fmla="*/ 10626531 w 12162081"/>
+              <a:gd name="connsiteY7" fmla="*/ 417718 h 419500"/>
+              <a:gd name="connsiteX8" fmla="*/ 12162081 w 12162081"/>
+              <a:gd name="connsiteY8" fmla="*/ 19358 h 419500"/>
+              <a:gd name="connsiteX0" fmla="*/ 428 w 12162081"/>
+              <a:gd name="connsiteY0" fmla="*/ 9967 h 422480"/>
+              <a:gd name="connsiteX1" fmla="*/ 1503962 w 12162081"/>
+              <a:gd name="connsiteY1" fmla="*/ 419496 h 422480"/>
+              <a:gd name="connsiteX2" fmla="*/ 3027451 w 12162081"/>
+              <a:gd name="connsiteY2" fmla="*/ 1 h 422480"/>
+              <a:gd name="connsiteX3" fmla="*/ 4549313 w 12162081"/>
+              <a:gd name="connsiteY3" fmla="*/ 419227 h 422480"/>
+              <a:gd name="connsiteX4" fmla="*/ 6063377 w 12162081"/>
+              <a:gd name="connsiteY4" fmla="*/ 1229 h 422480"/>
+              <a:gd name="connsiteX5" fmla="*/ 7609959 w 12162081"/>
+              <a:gd name="connsiteY5" fmla="*/ 414318 h 422480"/>
+              <a:gd name="connsiteX6" fmla="*/ 9125587 w 12162081"/>
+              <a:gd name="connsiteY6" fmla="*/ 21537 h 422480"/>
+              <a:gd name="connsiteX7" fmla="*/ 10650304 w 12162081"/>
+              <a:gd name="connsiteY7" fmla="*/ 422480 h 422480"/>
+              <a:gd name="connsiteX8" fmla="*/ 12162081 w 12162081"/>
+              <a:gd name="connsiteY8" fmla="*/ 19358 h 422480"/>
+              <a:gd name="connsiteX0" fmla="*/ 428 w 12162081"/>
+              <a:gd name="connsiteY0" fmla="*/ 9967 h 422480"/>
+              <a:gd name="connsiteX1" fmla="*/ 1503962 w 12162081"/>
+              <a:gd name="connsiteY1" fmla="*/ 419496 h 422480"/>
+              <a:gd name="connsiteX2" fmla="*/ 3027451 w 12162081"/>
+              <a:gd name="connsiteY2" fmla="*/ 1 h 422480"/>
+              <a:gd name="connsiteX3" fmla="*/ 4549313 w 12162081"/>
+              <a:gd name="connsiteY3" fmla="*/ 419227 h 422480"/>
+              <a:gd name="connsiteX4" fmla="*/ 6063377 w 12162081"/>
+              <a:gd name="connsiteY4" fmla="*/ 1229 h 422480"/>
+              <a:gd name="connsiteX5" fmla="*/ 7609959 w 12162081"/>
+              <a:gd name="connsiteY5" fmla="*/ 414318 h 422480"/>
+              <a:gd name="connsiteX6" fmla="*/ 9125587 w 12162081"/>
+              <a:gd name="connsiteY6" fmla="*/ 21537 h 422480"/>
+              <a:gd name="connsiteX7" fmla="*/ 10640795 w 12162081"/>
+              <a:gd name="connsiteY7" fmla="*/ 422480 h 422480"/>
+              <a:gd name="connsiteX8" fmla="*/ 12162081 w 12162081"/>
+              <a:gd name="connsiteY8" fmla="*/ 19358 h 422480"/>
+              <a:gd name="connsiteX0" fmla="*/ 428 w 12162081"/>
+              <a:gd name="connsiteY0" fmla="*/ 9967 h 422480"/>
+              <a:gd name="connsiteX1" fmla="*/ 1503962 w 12162081"/>
+              <a:gd name="connsiteY1" fmla="*/ 419496 h 422480"/>
+              <a:gd name="connsiteX2" fmla="*/ 3027451 w 12162081"/>
+              <a:gd name="connsiteY2" fmla="*/ 1 h 422480"/>
+              <a:gd name="connsiteX3" fmla="*/ 4549313 w 12162081"/>
+              <a:gd name="connsiteY3" fmla="*/ 419227 h 422480"/>
+              <a:gd name="connsiteX4" fmla="*/ 6063377 w 12162081"/>
+              <a:gd name="connsiteY4" fmla="*/ 1229 h 422480"/>
+              <a:gd name="connsiteX5" fmla="*/ 7598073 w 12162081"/>
+              <a:gd name="connsiteY5" fmla="*/ 414318 h 422480"/>
+              <a:gd name="connsiteX6" fmla="*/ 9125587 w 12162081"/>
+              <a:gd name="connsiteY6" fmla="*/ 21537 h 422480"/>
+              <a:gd name="connsiteX7" fmla="*/ 10640795 w 12162081"/>
+              <a:gd name="connsiteY7" fmla="*/ 422480 h 422480"/>
+              <a:gd name="connsiteX8" fmla="*/ 12162081 w 12162081"/>
+              <a:gd name="connsiteY8" fmla="*/ 19358 h 422480"/>
+              <a:gd name="connsiteX0" fmla="*/ 428 w 12162081"/>
+              <a:gd name="connsiteY0" fmla="*/ 9967 h 422480"/>
+              <a:gd name="connsiteX1" fmla="*/ 1503962 w 12162081"/>
+              <a:gd name="connsiteY1" fmla="*/ 419496 h 422480"/>
+              <a:gd name="connsiteX2" fmla="*/ 3027451 w 12162081"/>
+              <a:gd name="connsiteY2" fmla="*/ 1 h 422480"/>
+              <a:gd name="connsiteX3" fmla="*/ 4549313 w 12162081"/>
+              <a:gd name="connsiteY3" fmla="*/ 419227 h 422480"/>
+              <a:gd name="connsiteX4" fmla="*/ 6063377 w 12162081"/>
+              <a:gd name="connsiteY4" fmla="*/ 1229 h 422480"/>
+              <a:gd name="connsiteX5" fmla="*/ 7595696 w 12162081"/>
+              <a:gd name="connsiteY5" fmla="*/ 421461 h 422480"/>
+              <a:gd name="connsiteX6" fmla="*/ 9125587 w 12162081"/>
+              <a:gd name="connsiteY6" fmla="*/ 21537 h 422480"/>
+              <a:gd name="connsiteX7" fmla="*/ 10640795 w 12162081"/>
+              <a:gd name="connsiteY7" fmla="*/ 422480 h 422480"/>
+              <a:gd name="connsiteX8" fmla="*/ 12162081 w 12162081"/>
+              <a:gd name="connsiteY8" fmla="*/ 19358 h 422480"/>
+              <a:gd name="connsiteX0" fmla="*/ 428 w 12162081"/>
+              <a:gd name="connsiteY0" fmla="*/ 15088 h 427601"/>
+              <a:gd name="connsiteX1" fmla="*/ 1503962 w 12162081"/>
+              <a:gd name="connsiteY1" fmla="*/ 424617 h 427601"/>
+              <a:gd name="connsiteX2" fmla="*/ 3027451 w 12162081"/>
+              <a:gd name="connsiteY2" fmla="*/ 5122 h 427601"/>
+              <a:gd name="connsiteX3" fmla="*/ 4549313 w 12162081"/>
+              <a:gd name="connsiteY3" fmla="*/ 424348 h 427601"/>
+              <a:gd name="connsiteX4" fmla="*/ 6072887 w 12162081"/>
+              <a:gd name="connsiteY4" fmla="*/ 0 h 427601"/>
+              <a:gd name="connsiteX5" fmla="*/ 7595696 w 12162081"/>
+              <a:gd name="connsiteY5" fmla="*/ 426582 h 427601"/>
+              <a:gd name="connsiteX6" fmla="*/ 9125587 w 12162081"/>
+              <a:gd name="connsiteY6" fmla="*/ 26658 h 427601"/>
+              <a:gd name="connsiteX7" fmla="*/ 10640795 w 12162081"/>
+              <a:gd name="connsiteY7" fmla="*/ 427601 h 427601"/>
+              <a:gd name="connsiteX8" fmla="*/ 12162081 w 12162081"/>
+              <a:gd name="connsiteY8" fmla="*/ 24479 h 427601"/>
+              <a:gd name="connsiteX0" fmla="*/ 428 w 12162081"/>
+              <a:gd name="connsiteY0" fmla="*/ 15088 h 427606"/>
+              <a:gd name="connsiteX1" fmla="*/ 1503962 w 12162081"/>
+              <a:gd name="connsiteY1" fmla="*/ 424617 h 427606"/>
+              <a:gd name="connsiteX2" fmla="*/ 3027451 w 12162081"/>
+              <a:gd name="connsiteY2" fmla="*/ 5122 h 427606"/>
+              <a:gd name="connsiteX3" fmla="*/ 4549313 w 12162081"/>
+              <a:gd name="connsiteY3" fmla="*/ 424348 h 427606"/>
+              <a:gd name="connsiteX4" fmla="*/ 6072887 w 12162081"/>
+              <a:gd name="connsiteY4" fmla="*/ 0 h 427606"/>
+              <a:gd name="connsiteX5" fmla="*/ 7595696 w 12162081"/>
+              <a:gd name="connsiteY5" fmla="*/ 426582 h 427606"/>
+              <a:gd name="connsiteX6" fmla="*/ 9122417 w 12162081"/>
+              <a:gd name="connsiteY6" fmla="*/ 13958 h 427606"/>
+              <a:gd name="connsiteX7" fmla="*/ 10640795 w 12162081"/>
+              <a:gd name="connsiteY7" fmla="*/ 427601 h 427606"/>
+              <a:gd name="connsiteX8" fmla="*/ 12162081 w 12162081"/>
+              <a:gd name="connsiteY8" fmla="*/ 24479 h 427606"/>
+              <a:gd name="connsiteX0" fmla="*/ 428 w 12168421"/>
+              <a:gd name="connsiteY0" fmla="*/ 15299 h 427818"/>
+              <a:gd name="connsiteX1" fmla="*/ 1503962 w 12168421"/>
+              <a:gd name="connsiteY1" fmla="*/ 424828 h 427818"/>
+              <a:gd name="connsiteX2" fmla="*/ 3027451 w 12168421"/>
+              <a:gd name="connsiteY2" fmla="*/ 5333 h 427818"/>
+              <a:gd name="connsiteX3" fmla="*/ 4549313 w 12168421"/>
+              <a:gd name="connsiteY3" fmla="*/ 424559 h 427818"/>
+              <a:gd name="connsiteX4" fmla="*/ 6072887 w 12168421"/>
+              <a:gd name="connsiteY4" fmla="*/ 211 h 427818"/>
+              <a:gd name="connsiteX5" fmla="*/ 7595696 w 12168421"/>
+              <a:gd name="connsiteY5" fmla="*/ 426793 h 427818"/>
+              <a:gd name="connsiteX6" fmla="*/ 9122417 w 12168421"/>
+              <a:gd name="connsiteY6" fmla="*/ 14169 h 427818"/>
+              <a:gd name="connsiteX7" fmla="*/ 10640795 w 12168421"/>
+              <a:gd name="connsiteY7" fmla="*/ 427812 h 427818"/>
+              <a:gd name="connsiteX8" fmla="*/ 12168421 w 12168421"/>
+              <a:gd name="connsiteY8" fmla="*/ 2465 h 427818"/>
+            </a:gdLst>
+            <a:ahLst/>
+            <a:cxnLst>
+              <a:cxn ang="0">
+                <a:pos x="connsiteX0" y="connsiteY0"/>
+              </a:cxn>
+              <a:cxn ang="0">
+                <a:pos x="connsiteX1" y="connsiteY1"/>
+              </a:cxn>
+              <a:cxn ang="0">
+                <a:pos x="connsiteX2" y="connsiteY2"/>
+              </a:cxn>
+              <a:cxn ang="0">
+                <a:pos x="connsiteX3" y="connsiteY3"/>
+              </a:cxn>
+              <a:cxn ang="0">
+                <a:pos x="connsiteX4" y="connsiteY4"/>
+              </a:cxn>
+              <a:cxn ang="0">
+                <a:pos x="connsiteX5" y="connsiteY5"/>
+              </a:cxn>
+              <a:cxn ang="0">
+                <a:pos x="connsiteX6" y="connsiteY6"/>
+              </a:cxn>
+              <a:cxn ang="0">
+                <a:pos x="connsiteX7" y="connsiteY7"/>
+              </a:cxn>
+              <a:cxn ang="0">
+                <a:pos x="connsiteX8" y="connsiteY8"/>
+              </a:cxn>
+            </a:cxnLst>
+            <a:rect l="l" t="t" r="r" b="b"/>
+            <a:pathLst>
+              <a:path w="12168421" h="427818">
+                <a:moveTo>
+                  <a:pt x="428" y="15299"/>
+                </a:moveTo>
+                <a:cubicBezTo>
+                  <a:pt x="-23949" y="3229"/>
+                  <a:pt x="999458" y="426489"/>
+                  <a:pt x="1503962" y="424828"/>
+                </a:cubicBezTo>
+                <a:cubicBezTo>
+                  <a:pt x="2008466" y="423167"/>
+                  <a:pt x="2519893" y="5378"/>
+                  <a:pt x="3027451" y="5333"/>
+                </a:cubicBezTo>
+                <a:cubicBezTo>
+                  <a:pt x="3535009" y="5288"/>
+                  <a:pt x="4041740" y="425413"/>
+                  <a:pt x="4549313" y="424559"/>
+                </a:cubicBezTo>
+                <a:cubicBezTo>
+                  <a:pt x="5056886" y="423705"/>
+                  <a:pt x="5565157" y="-161"/>
+                  <a:pt x="6072887" y="211"/>
+                </a:cubicBezTo>
+                <a:cubicBezTo>
+                  <a:pt x="6580618" y="583"/>
+                  <a:pt x="7087441" y="424467"/>
+                  <a:pt x="7595696" y="426793"/>
+                </a:cubicBezTo>
+                <a:cubicBezTo>
+                  <a:pt x="8103951" y="429119"/>
+                  <a:pt x="8614901" y="13999"/>
+                  <a:pt x="9122417" y="14169"/>
+                </a:cubicBezTo>
+                <a:cubicBezTo>
+                  <a:pt x="9629933" y="14339"/>
+                  <a:pt x="10133128" y="429763"/>
+                  <a:pt x="10640795" y="427812"/>
+                </a:cubicBezTo>
+                <a:cubicBezTo>
+                  <a:pt x="11148462" y="425861"/>
+                  <a:pt x="12122537" y="-37684"/>
+                  <a:pt x="12168421" y="2465"/>
+                </a:cubicBezTo>
+              </a:path>
+            </a:pathLst>
+          </a:custGeom>
+          <a:solidFill>
+            <a:srgbClr val="F0E199"/>
+          </a:solidFill>
+          <a:ln>
+            <a:solidFill>
+              <a:srgbClr val="F0E199"/>
+            </a:solidFill>
+          </a:ln>
+        </p:spPr>
+        <p:style>
+          <a:lnRef idx="2">
+            <a:schemeClr val="accent1">
+              <a:shade val="15000"/>
+            </a:schemeClr>
+          </a:lnRef>
+          <a:fillRef idx="1">
+            <a:schemeClr val="accent1"/>
+          </a:fillRef>
+          <a:effectRef idx="0">
+            <a:schemeClr val="accent1"/>
+          </a:effectRef>
+          <a:fontRef idx="minor">
+            <a:schemeClr val="lt1"/>
+          </a:fontRef>
+        </p:style>
+        <p:txBody>
+          <a:bodyPr rtlCol="0" anchor="ctr"/>
+          <a:lstStyle/>
+          <a:p>
+            <a:pPr algn="ctr"/>
+            <a:endParaRPr lang="en-US" dirty="0"/>
+          </a:p>
+        </p:txBody>
+      </p:sp>
+      <p:cxnSp>
+        <p:nvCxnSpPr>
+          <p:cNvPr id="9" name="Straight Connector 8">
+            <a:extLst>
+              <a:ext uri="{FF2B5EF4-FFF2-40B4-BE49-F238E27FC236}">
+                <a16:creationId xmlns:a16="http://schemas.microsoft.com/office/drawing/2014/main" id="{32970AB3-3028-0EAE-5AF4-CF9AFA5C042F}"/>
+              </a:ext>
+            </a:extLst>
+          </p:cNvPr>
+          <p:cNvCxnSpPr/>
+          <p:nvPr/>
+        </p:nvCxnSpPr>
+        <p:spPr>
+          <a:xfrm>
+            <a:off x="12201525" y="0"/>
+            <a:ext cx="0" cy="6858000"/>
+          </a:xfrm>
+          <a:prstGeom prst="line">
+            <a:avLst/>
+          </a:prstGeom>
+        </p:spPr>
+        <p:style>
+          <a:lnRef idx="2">
+            <a:schemeClr val="accent1"/>
+          </a:lnRef>
+          <a:fillRef idx="0">
+            <a:schemeClr val="accent1"/>
+          </a:fillRef>
+          <a:effectRef idx="1">
+            <a:schemeClr val="accent1"/>
+          </a:effectRef>
+          <a:fontRef idx="minor">
+            <a:schemeClr val="tx1"/>
+          </a:fontRef>
+        </p:style>
+      </p:cxnSp>
+      <p:cxnSp>
+        <p:nvCxnSpPr>
+          <p:cNvPr id="10" name="Straight Connector 9">
+            <a:extLst>
+              <a:ext uri="{FF2B5EF4-FFF2-40B4-BE49-F238E27FC236}">
+                <a16:creationId xmlns:a16="http://schemas.microsoft.com/office/drawing/2014/main" id="{96DD03D9-83C5-A449-DEDA-A2CF03F38A2A}"/>
+              </a:ext>
+            </a:extLst>
+          </p:cNvPr>
+          <p:cNvCxnSpPr/>
+          <p:nvPr/>
+        </p:nvCxnSpPr>
+        <p:spPr>
+          <a:xfrm>
+            <a:off x="0" y="0"/>
+            <a:ext cx="0" cy="6858000"/>
+          </a:xfrm>
+          <a:prstGeom prst="line">
+            <a:avLst/>
+          </a:prstGeom>
+        </p:spPr>
+        <p:style>
+          <a:lnRef idx="2">
+            <a:schemeClr val="accent1"/>
+          </a:lnRef>
+          <a:fillRef idx="0">
+            <a:schemeClr val="accent1"/>
+          </a:fillRef>
+          <a:effectRef idx="1">
+            <a:schemeClr val="accent1"/>
+          </a:effectRef>
+          <a:fontRef idx="minor">
+            <a:schemeClr val="tx1"/>
+          </a:fontRef>
+        </p:style>
+      </p:cxnSp>
+    </p:spTree>
+    <p:extLst>
+      <p:ext uri="{BB962C8B-B14F-4D97-AF65-F5344CB8AC3E}">
+        <p14:creationId xmlns:p14="http://schemas.microsoft.com/office/powerpoint/2010/main" val="1376787294"/>
+      </p:ext>
+    </p:extLst>
+  </p:cSld>
+  <p:clrMapOvr>
+    <a:masterClrMapping/>
+  </p:clrMapOvr>
+</p:sld>
+</file>
+
 <file path=ppt/theme/theme1.xml><?xml version="1.0" encoding="utf-8"?>
 <a:theme xmlns:a="http://schemas.openxmlformats.org/drawingml/2006/main" name="Office Theme">
   <a:themeElements>

</xml_diff>

<commit_message>
fixed background duck photo
</commit_message>
<xml_diff>
--- a/Power BI V2/Images/PPTX Template.pptx
+++ b/Power BI V2/Images/PPTX Template.pptx
@@ -4,6 +4,9 @@
   <p:sldMasterIdLst>
     <p:sldMasterId id="2147483648" r:id="rId1"/>
   </p:sldMasterIdLst>
+  <p:notesMasterIdLst>
+    <p:notesMasterId r:id="rId6"/>
+  </p:notesMasterIdLst>
   <p:sldIdLst>
     <p:sldId id="256" r:id="rId2"/>
     <p:sldId id="257" r:id="rId3"/>
@@ -11,7 +14,7 @@
     <p:sldId id="259" r:id="rId5"/>
   </p:sldIdLst>
   <p:sldSz cx="12192000" cy="6858000"/>
-  <p:notesSz cx="7010400" cy="9296400"/>
+  <p:notesSz cx="7315200" cy="9601200"/>
   <p:defaultTextStyle>
     <a:defPPr>
       <a:defRPr lang="en-US"/>
@@ -115,6 +118,355 @@
 </p:presentation>
 </file>
 
+<file path=ppt/notesMasters/notesMaster1.xml><?xml version="1.0" encoding="utf-8"?>
+<p:notesMaster xmlns:a="http://schemas.openxmlformats.org/drawingml/2006/main" xmlns:r="http://schemas.openxmlformats.org/officeDocument/2006/relationships" xmlns:p="http://schemas.openxmlformats.org/presentationml/2006/main">
+  <p:cSld>
+    <p:bg>
+      <p:bgRef idx="1001">
+        <a:schemeClr val="bg1"/>
+      </p:bgRef>
+    </p:bg>
+    <p:spTree>
+      <p:nvGrpSpPr>
+        <p:cNvPr id="1" name=""/>
+        <p:cNvGrpSpPr/>
+        <p:nvPr/>
+      </p:nvGrpSpPr>
+      <p:grpSpPr>
+        <a:xfrm>
+          <a:off x="0" y="0"/>
+          <a:ext cx="0" cy="0"/>
+          <a:chOff x="0" y="0"/>
+          <a:chExt cx="0" cy="0"/>
+        </a:xfrm>
+      </p:grpSpPr>
+      <p:sp>
+        <p:nvSpPr>
+          <p:cNvPr id="2" name="Header Placeholder 1"/>
+          <p:cNvSpPr>
+            <a:spLocks noGrp="1"/>
+          </p:cNvSpPr>
+          <p:nvPr>
+            <p:ph type="hdr" sz="quarter"/>
+          </p:nvPr>
+        </p:nvSpPr>
+        <p:spPr>
+          <a:xfrm>
+            <a:off x="0" y="0"/>
+            <a:ext cx="3170238" cy="481013"/>
+          </a:xfrm>
+          <a:prstGeom prst="rect">
+            <a:avLst/>
+          </a:prstGeom>
+        </p:spPr>
+        <p:txBody>
+          <a:bodyPr vert="horz" lIns="91440" tIns="45720" rIns="91440" bIns="45720" rtlCol="0"/>
+          <a:lstStyle>
+            <a:lvl1pPr algn="l">
+              <a:defRPr sz="1200"/>
+            </a:lvl1pPr>
+          </a:lstStyle>
+          <a:p>
+            <a:endParaRPr lang="en-US"/>
+          </a:p>
+        </p:txBody>
+      </p:sp>
+      <p:sp>
+        <p:nvSpPr>
+          <p:cNvPr id="3" name="Date Placeholder 2"/>
+          <p:cNvSpPr>
+            <a:spLocks noGrp="1"/>
+          </p:cNvSpPr>
+          <p:nvPr>
+            <p:ph type="dt" idx="1"/>
+          </p:nvPr>
+        </p:nvSpPr>
+        <p:spPr>
+          <a:xfrm>
+            <a:off x="4143375" y="0"/>
+            <a:ext cx="3170238" cy="481013"/>
+          </a:xfrm>
+          <a:prstGeom prst="rect">
+            <a:avLst/>
+          </a:prstGeom>
+        </p:spPr>
+        <p:txBody>
+          <a:bodyPr vert="horz" lIns="91440" tIns="45720" rIns="91440" bIns="45720" rtlCol="0"/>
+          <a:lstStyle>
+            <a:lvl1pPr algn="r">
+              <a:defRPr sz="1200"/>
+            </a:lvl1pPr>
+          </a:lstStyle>
+          <a:p>
+            <a:fld id="{F354B24C-E432-4E46-97F1-0251C05BD5DC}" type="datetimeFigureOut">
+              <a:rPr lang="en-US" smtClean="0"/>
+              <a:t>8/31/2026</a:t>
+            </a:fld>
+            <a:endParaRPr lang="en-US"/>
+          </a:p>
+        </p:txBody>
+      </p:sp>
+      <p:sp>
+        <p:nvSpPr>
+          <p:cNvPr id="4" name="Slide Image Placeholder 3"/>
+          <p:cNvSpPr>
+            <a:spLocks noGrp="1" noRot="1" noChangeAspect="1"/>
+          </p:cNvSpPr>
+          <p:nvPr>
+            <p:ph type="sldImg" idx="2"/>
+          </p:nvPr>
+        </p:nvSpPr>
+        <p:spPr>
+          <a:xfrm>
+            <a:off x="777875" y="1200150"/>
+            <a:ext cx="5759450" cy="3240088"/>
+          </a:xfrm>
+          <a:prstGeom prst="rect">
+            <a:avLst/>
+          </a:prstGeom>
+          <a:noFill/>
+          <a:ln w="12700">
+            <a:solidFill>
+              <a:prstClr val="black"/>
+            </a:solidFill>
+          </a:ln>
+        </p:spPr>
+        <p:txBody>
+          <a:bodyPr vert="horz" lIns="91440" tIns="45720" rIns="91440" bIns="45720" rtlCol="0" anchor="ctr"/>
+          <a:lstStyle/>
+          <a:p>
+            <a:endParaRPr lang="en-US"/>
+          </a:p>
+        </p:txBody>
+      </p:sp>
+      <p:sp>
+        <p:nvSpPr>
+          <p:cNvPr id="5" name="Notes Placeholder 4"/>
+          <p:cNvSpPr>
+            <a:spLocks noGrp="1"/>
+          </p:cNvSpPr>
+          <p:nvPr>
+            <p:ph type="body" sz="quarter" idx="3"/>
+          </p:nvPr>
+        </p:nvSpPr>
+        <p:spPr>
+          <a:xfrm>
+            <a:off x="731838" y="4621213"/>
+            <a:ext cx="5851525" cy="3779837"/>
+          </a:xfrm>
+          <a:prstGeom prst="rect">
+            <a:avLst/>
+          </a:prstGeom>
+        </p:spPr>
+        <p:txBody>
+          <a:bodyPr vert="horz" lIns="91440" tIns="45720" rIns="91440" bIns="45720" rtlCol="0"/>
+          <a:lstStyle/>
+          <a:p>
+            <a:pPr lvl="0"/>
+            <a:r>
+              <a:rPr lang="en-US"/>
+              <a:t>Click to edit Master text styles</a:t>
+            </a:r>
+          </a:p>
+          <a:p>
+            <a:pPr lvl="1"/>
+            <a:r>
+              <a:rPr lang="en-US"/>
+              <a:t>Second level</a:t>
+            </a:r>
+          </a:p>
+          <a:p>
+            <a:pPr lvl="2"/>
+            <a:r>
+              <a:rPr lang="en-US"/>
+              <a:t>Third level</a:t>
+            </a:r>
+          </a:p>
+          <a:p>
+            <a:pPr lvl="3"/>
+            <a:r>
+              <a:rPr lang="en-US"/>
+              <a:t>Fourth level</a:t>
+            </a:r>
+          </a:p>
+          <a:p>
+            <a:pPr lvl="4"/>
+            <a:r>
+              <a:rPr lang="en-US"/>
+              <a:t>Fifth level</a:t>
+            </a:r>
+          </a:p>
+        </p:txBody>
+      </p:sp>
+      <p:sp>
+        <p:nvSpPr>
+          <p:cNvPr id="6" name="Footer Placeholder 5"/>
+          <p:cNvSpPr>
+            <a:spLocks noGrp="1"/>
+          </p:cNvSpPr>
+          <p:nvPr>
+            <p:ph type="ftr" sz="quarter" idx="4"/>
+          </p:nvPr>
+        </p:nvSpPr>
+        <p:spPr>
+          <a:xfrm>
+            <a:off x="0" y="9120188"/>
+            <a:ext cx="3170238" cy="481012"/>
+          </a:xfrm>
+          <a:prstGeom prst="rect">
+            <a:avLst/>
+          </a:prstGeom>
+        </p:spPr>
+        <p:txBody>
+          <a:bodyPr vert="horz" lIns="91440" tIns="45720" rIns="91440" bIns="45720" rtlCol="0" anchor="b"/>
+          <a:lstStyle>
+            <a:lvl1pPr algn="l">
+              <a:defRPr sz="1200"/>
+            </a:lvl1pPr>
+          </a:lstStyle>
+          <a:p>
+            <a:endParaRPr lang="en-US"/>
+          </a:p>
+        </p:txBody>
+      </p:sp>
+      <p:sp>
+        <p:nvSpPr>
+          <p:cNvPr id="7" name="Slide Number Placeholder 6"/>
+          <p:cNvSpPr>
+            <a:spLocks noGrp="1"/>
+          </p:cNvSpPr>
+          <p:nvPr>
+            <p:ph type="sldNum" sz="quarter" idx="5"/>
+          </p:nvPr>
+        </p:nvSpPr>
+        <p:spPr>
+          <a:xfrm>
+            <a:off x="4143375" y="9120188"/>
+            <a:ext cx="3170238" cy="481012"/>
+          </a:xfrm>
+          <a:prstGeom prst="rect">
+            <a:avLst/>
+          </a:prstGeom>
+        </p:spPr>
+        <p:txBody>
+          <a:bodyPr vert="horz" lIns="91440" tIns="45720" rIns="91440" bIns="45720" rtlCol="0" anchor="b"/>
+          <a:lstStyle>
+            <a:lvl1pPr algn="r">
+              <a:defRPr sz="1200"/>
+            </a:lvl1pPr>
+          </a:lstStyle>
+          <a:p>
+            <a:fld id="{2EE0D48C-C6D0-4758-9D0C-E3D0CFAF0E63}" type="slidenum">
+              <a:rPr lang="en-US" smtClean="0"/>
+              <a:t>‹#›</a:t>
+            </a:fld>
+            <a:endParaRPr lang="en-US"/>
+          </a:p>
+        </p:txBody>
+      </p:sp>
+    </p:spTree>
+    <p:extLst>
+      <p:ext uri="{BB962C8B-B14F-4D97-AF65-F5344CB8AC3E}">
+        <p14:creationId xmlns:p14="http://schemas.microsoft.com/office/powerpoint/2010/main" val="1092522379"/>
+      </p:ext>
+    </p:extLst>
+  </p:cSld>
+  <p:clrMap bg1="lt1" tx1="dk1" bg2="lt2" tx2="dk2" accent1="accent1" accent2="accent2" accent3="accent3" accent4="accent4" accent5="accent5" accent6="accent6" hlink="hlink" folHlink="folHlink"/>
+  <p:notesStyle>
+    <a:lvl1pPr marL="0" algn="l" defTabSz="914400" rtl="0" eaLnBrk="1" latinLnBrk="0" hangingPunct="1">
+      <a:defRPr sz="1200" kern="1200">
+        <a:solidFill>
+          <a:schemeClr val="tx1"/>
+        </a:solidFill>
+        <a:latin typeface="+mn-lt"/>
+        <a:ea typeface="+mn-ea"/>
+        <a:cs typeface="+mn-cs"/>
+      </a:defRPr>
+    </a:lvl1pPr>
+    <a:lvl2pPr marL="457200" algn="l" defTabSz="914400" rtl="0" eaLnBrk="1" latinLnBrk="0" hangingPunct="1">
+      <a:defRPr sz="1200" kern="1200">
+        <a:solidFill>
+          <a:schemeClr val="tx1"/>
+        </a:solidFill>
+        <a:latin typeface="+mn-lt"/>
+        <a:ea typeface="+mn-ea"/>
+        <a:cs typeface="+mn-cs"/>
+      </a:defRPr>
+    </a:lvl2pPr>
+    <a:lvl3pPr marL="914400" algn="l" defTabSz="914400" rtl="0" eaLnBrk="1" latinLnBrk="0" hangingPunct="1">
+      <a:defRPr sz="1200" kern="1200">
+        <a:solidFill>
+          <a:schemeClr val="tx1"/>
+        </a:solidFill>
+        <a:latin typeface="+mn-lt"/>
+        <a:ea typeface="+mn-ea"/>
+        <a:cs typeface="+mn-cs"/>
+      </a:defRPr>
+    </a:lvl3pPr>
+    <a:lvl4pPr marL="1371600" algn="l" defTabSz="914400" rtl="0" eaLnBrk="1" latinLnBrk="0" hangingPunct="1">
+      <a:defRPr sz="1200" kern="1200">
+        <a:solidFill>
+          <a:schemeClr val="tx1"/>
+        </a:solidFill>
+        <a:latin typeface="+mn-lt"/>
+        <a:ea typeface="+mn-ea"/>
+        <a:cs typeface="+mn-cs"/>
+      </a:defRPr>
+    </a:lvl4pPr>
+    <a:lvl5pPr marL="1828800" algn="l" defTabSz="914400" rtl="0" eaLnBrk="1" latinLnBrk="0" hangingPunct="1">
+      <a:defRPr sz="1200" kern="1200">
+        <a:solidFill>
+          <a:schemeClr val="tx1"/>
+        </a:solidFill>
+        <a:latin typeface="+mn-lt"/>
+        <a:ea typeface="+mn-ea"/>
+        <a:cs typeface="+mn-cs"/>
+      </a:defRPr>
+    </a:lvl5pPr>
+    <a:lvl6pPr marL="2286000" algn="l" defTabSz="914400" rtl="0" eaLnBrk="1" latinLnBrk="0" hangingPunct="1">
+      <a:defRPr sz="1200" kern="1200">
+        <a:solidFill>
+          <a:schemeClr val="tx1"/>
+        </a:solidFill>
+        <a:latin typeface="+mn-lt"/>
+        <a:ea typeface="+mn-ea"/>
+        <a:cs typeface="+mn-cs"/>
+      </a:defRPr>
+    </a:lvl6pPr>
+    <a:lvl7pPr marL="2743200" algn="l" defTabSz="914400" rtl="0" eaLnBrk="1" latinLnBrk="0" hangingPunct="1">
+      <a:defRPr sz="1200" kern="1200">
+        <a:solidFill>
+          <a:schemeClr val="tx1"/>
+        </a:solidFill>
+        <a:latin typeface="+mn-lt"/>
+        <a:ea typeface="+mn-ea"/>
+        <a:cs typeface="+mn-cs"/>
+      </a:defRPr>
+    </a:lvl7pPr>
+    <a:lvl8pPr marL="3200400" algn="l" defTabSz="914400" rtl="0" eaLnBrk="1" latinLnBrk="0" hangingPunct="1">
+      <a:defRPr sz="1200" kern="1200">
+        <a:solidFill>
+          <a:schemeClr val="tx1"/>
+        </a:solidFill>
+        <a:latin typeface="+mn-lt"/>
+        <a:ea typeface="+mn-ea"/>
+        <a:cs typeface="+mn-cs"/>
+      </a:defRPr>
+    </a:lvl8pPr>
+    <a:lvl9pPr marL="3657600" algn="l" defTabSz="914400" rtl="0" eaLnBrk="1" latinLnBrk="0" hangingPunct="1">
+      <a:defRPr sz="1200" kern="1200">
+        <a:solidFill>
+          <a:schemeClr val="tx1"/>
+        </a:solidFill>
+        <a:latin typeface="+mn-lt"/>
+        <a:ea typeface="+mn-ea"/>
+        <a:cs typeface="+mn-cs"/>
+      </a:defRPr>
+    </a:lvl9pPr>
+  </p:notesStyle>
+</p:notesMaster>
+</file>
+
 <file path=ppt/slideLayouts/slideLayout1.xml><?xml version="1.0" encoding="utf-8"?>
 <p:sldLayout xmlns:a="http://schemas.openxmlformats.org/drawingml/2006/main" xmlns:r="http://schemas.openxmlformats.org/officeDocument/2006/relationships" xmlns:p="http://schemas.openxmlformats.org/presentationml/2006/main" type="title" preserve="1">
   <p:cSld name="Title Slide">
@@ -262,7 +614,7 @@
           <a:p>
             <a:fld id="{E44219A9-FE5C-4F0B-9FF8-4AC037278759}" type="datetimeFigureOut">
               <a:rPr lang="en-US" smtClean="0"/>
-              <a:t>10/12/2025</a:t>
+              <a:t>8/31/2026</a:t>
             </a:fld>
             <a:endParaRPr lang="en-US"/>
           </a:p>
@@ -460,7 +812,7 @@
           <a:p>
             <a:fld id="{E44219A9-FE5C-4F0B-9FF8-4AC037278759}" type="datetimeFigureOut">
               <a:rPr lang="en-US" smtClean="0"/>
-              <a:t>10/12/2025</a:t>
+              <a:t>8/31/2026</a:t>
             </a:fld>
             <a:endParaRPr lang="en-US"/>
           </a:p>
@@ -668,7 +1020,7 @@
           <a:p>
             <a:fld id="{E44219A9-FE5C-4F0B-9FF8-4AC037278759}" type="datetimeFigureOut">
               <a:rPr lang="en-US" smtClean="0"/>
-              <a:t>10/12/2025</a:t>
+              <a:t>8/31/2026</a:t>
             </a:fld>
             <a:endParaRPr lang="en-US"/>
           </a:p>
@@ -866,7 +1218,7 @@
           <a:p>
             <a:fld id="{E44219A9-FE5C-4F0B-9FF8-4AC037278759}" type="datetimeFigureOut">
               <a:rPr lang="en-US" smtClean="0"/>
-              <a:t>10/12/2025</a:t>
+              <a:t>8/31/2026</a:t>
             </a:fld>
             <a:endParaRPr lang="en-US"/>
           </a:p>
@@ -1141,7 +1493,7 @@
           <a:p>
             <a:fld id="{E44219A9-FE5C-4F0B-9FF8-4AC037278759}" type="datetimeFigureOut">
               <a:rPr lang="en-US" smtClean="0"/>
-              <a:t>10/12/2025</a:t>
+              <a:t>8/31/2026</a:t>
             </a:fld>
             <a:endParaRPr lang="en-US"/>
           </a:p>
@@ -1406,7 +1758,7 @@
           <a:p>
             <a:fld id="{E44219A9-FE5C-4F0B-9FF8-4AC037278759}" type="datetimeFigureOut">
               <a:rPr lang="en-US" smtClean="0"/>
-              <a:t>10/12/2025</a:t>
+              <a:t>8/31/2026</a:t>
             </a:fld>
             <a:endParaRPr lang="en-US"/>
           </a:p>
@@ -1818,7 +2170,7 @@
           <a:p>
             <a:fld id="{E44219A9-FE5C-4F0B-9FF8-4AC037278759}" type="datetimeFigureOut">
               <a:rPr lang="en-US" smtClean="0"/>
-              <a:t>10/12/2025</a:t>
+              <a:t>8/31/2026</a:t>
             </a:fld>
             <a:endParaRPr lang="en-US"/>
           </a:p>
@@ -1959,7 +2311,7 @@
           <a:p>
             <a:fld id="{E44219A9-FE5C-4F0B-9FF8-4AC037278759}" type="datetimeFigureOut">
               <a:rPr lang="en-US" smtClean="0"/>
-              <a:t>10/12/2025</a:t>
+              <a:t>8/31/2026</a:t>
             </a:fld>
             <a:endParaRPr lang="en-US"/>
           </a:p>
@@ -2072,7 +2424,7 @@
           <a:p>
             <a:fld id="{E44219A9-FE5C-4F0B-9FF8-4AC037278759}" type="datetimeFigureOut">
               <a:rPr lang="en-US" smtClean="0"/>
-              <a:t>10/12/2025</a:t>
+              <a:t>8/31/2026</a:t>
             </a:fld>
             <a:endParaRPr lang="en-US"/>
           </a:p>
@@ -2383,7 +2735,7 @@
           <a:p>
             <a:fld id="{E44219A9-FE5C-4F0B-9FF8-4AC037278759}" type="datetimeFigureOut">
               <a:rPr lang="en-US" smtClean="0"/>
-              <a:t>10/12/2025</a:t>
+              <a:t>8/31/2026</a:t>
             </a:fld>
             <a:endParaRPr lang="en-US"/>
           </a:p>
@@ -2671,7 +3023,7 @@
           <a:p>
             <a:fld id="{E44219A9-FE5C-4F0B-9FF8-4AC037278759}" type="datetimeFigureOut">
               <a:rPr lang="en-US" smtClean="0"/>
-              <a:t>10/12/2025</a:t>
+              <a:t>8/31/2026</a:t>
             </a:fld>
             <a:endParaRPr lang="en-US"/>
           </a:p>
@@ -2912,7 +3264,7 @@
           <a:p>
             <a:fld id="{E44219A9-FE5C-4F0B-9FF8-4AC037278759}" type="datetimeFigureOut">
               <a:rPr lang="en-US" smtClean="0"/>
-              <a:t>10/12/2025</a:t>
+              <a:t>8/31/2026</a:t>
             </a:fld>
             <a:endParaRPr lang="en-US"/>
           </a:p>
@@ -11267,8 +11619,8 @@
         </p:nvSpPr>
         <p:spPr>
           <a:xfrm>
-            <a:off x="10734564" y="-12500"/>
-            <a:ext cx="1457407" cy="6885563"/>
+            <a:off x="11868151" y="-12500"/>
+            <a:ext cx="323822" cy="6885563"/>
           </a:xfrm>
           <a:prstGeom prst="rect">
             <a:avLst/>
@@ -14715,4 +15067,319 @@
     </a:ext>
   </a:extLst>
 </a:theme>
+</file>
+
+<file path=ppt/theme/theme2.xml><?xml version="1.0" encoding="utf-8"?>
+<a:theme xmlns:a="http://schemas.openxmlformats.org/drawingml/2006/main" name="Office Theme">
+  <a:themeElements>
+    <a:clrScheme name="Office">
+      <a:dk1>
+        <a:sysClr val="windowText" lastClr="000000"/>
+      </a:dk1>
+      <a:lt1>
+        <a:sysClr val="window" lastClr="FFFFFF"/>
+      </a:lt1>
+      <a:dk2>
+        <a:srgbClr val="0E2841"/>
+      </a:dk2>
+      <a:lt2>
+        <a:srgbClr val="E8E8E8"/>
+      </a:lt2>
+      <a:accent1>
+        <a:srgbClr val="156082"/>
+      </a:accent1>
+      <a:accent2>
+        <a:srgbClr val="E97132"/>
+      </a:accent2>
+      <a:accent3>
+        <a:srgbClr val="196B24"/>
+      </a:accent3>
+      <a:accent4>
+        <a:srgbClr val="0F9ED5"/>
+      </a:accent4>
+      <a:accent5>
+        <a:srgbClr val="A02B93"/>
+      </a:accent5>
+      <a:accent6>
+        <a:srgbClr val="4EA72E"/>
+      </a:accent6>
+      <a:hlink>
+        <a:srgbClr val="467886"/>
+      </a:hlink>
+      <a:folHlink>
+        <a:srgbClr val="96607D"/>
+      </a:folHlink>
+    </a:clrScheme>
+    <a:fontScheme name="Office">
+      <a:majorFont>
+        <a:latin typeface="Aptos Display" panose="02110004020202020204"/>
+        <a:ea typeface=""/>
+        <a:cs typeface=""/>
+        <a:font script="Jpan" typeface="游ゴシック Light"/>
+        <a:font script="Hang" typeface="맑은 고딕"/>
+        <a:font script="Hans" typeface="等线 Light"/>
+        <a:font script="Hant" typeface="新細明體"/>
+        <a:font script="Arab" typeface="Times New Roman"/>
+        <a:font script="Hebr" typeface="Times New Roman"/>
+        <a:font script="Thai" typeface="Angsana New"/>
+        <a:font script="Ethi" typeface="Nyala"/>
+        <a:font script="Beng" typeface="Vrinda"/>
+        <a:font script="Gujr" typeface="Shruti"/>
+        <a:font script="Khmr" typeface="MoolBoran"/>
+        <a:font script="Knda" typeface="Tunga"/>
+        <a:font script="Guru" typeface="Raavi"/>
+        <a:font script="Cans" typeface="Euphemia"/>
+        <a:font script="Cher" typeface="Plantagenet Cherokee"/>
+        <a:font script="Yiii" typeface="Microsoft Yi Baiti"/>
+        <a:font script="Tibt" typeface="Microsoft Himalaya"/>
+        <a:font script="Thaa" typeface="MV Boli"/>
+        <a:font script="Deva" typeface="Mangal"/>
+        <a:font script="Telu" typeface="Gautami"/>
+        <a:font script="Taml" typeface="Latha"/>
+        <a:font script="Syrc" typeface="Estrangelo Edessa"/>
+        <a:font script="Orya" typeface="Kalinga"/>
+        <a:font script="Mlym" typeface="Kartika"/>
+        <a:font script="Laoo" typeface="DokChampa"/>
+        <a:font script="Sinh" typeface="Iskoola Pota"/>
+        <a:font script="Mong" typeface="Mongolian Baiti"/>
+        <a:font script="Viet" typeface="Times New Roman"/>
+        <a:font script="Uigh" typeface="Microsoft Uighur"/>
+        <a:font script="Geor" typeface="Sylfaen"/>
+        <a:font script="Armn" typeface="Arial"/>
+        <a:font script="Bugi" typeface="Leelawadee UI"/>
+        <a:font script="Bopo" typeface="Microsoft JhengHei"/>
+        <a:font script="Java" typeface="Javanese Text"/>
+        <a:font script="Lisu" typeface="Segoe UI"/>
+        <a:font script="Mymr" typeface="Myanmar Text"/>
+        <a:font script="Nkoo" typeface="Ebrima"/>
+        <a:font script="Olck" typeface="Nirmala UI"/>
+        <a:font script="Osma" typeface="Ebrima"/>
+        <a:font script="Phag" typeface="Phagspa"/>
+        <a:font script="Syrn" typeface="Estrangelo Edessa"/>
+        <a:font script="Syrj" typeface="Estrangelo Edessa"/>
+        <a:font script="Syre" typeface="Estrangelo Edessa"/>
+        <a:font script="Sora" typeface="Nirmala UI"/>
+        <a:font script="Tale" typeface="Microsoft Tai Le"/>
+        <a:font script="Talu" typeface="Microsoft New Tai Lue"/>
+        <a:font script="Tfng" typeface="Ebrima"/>
+      </a:majorFont>
+      <a:minorFont>
+        <a:latin typeface="Aptos" panose="02110004020202020204"/>
+        <a:ea typeface=""/>
+        <a:cs typeface=""/>
+        <a:font script="Jpan" typeface="游ゴシック"/>
+        <a:font script="Hang" typeface="맑은 고딕"/>
+        <a:font script="Hans" typeface="等线"/>
+        <a:font script="Hant" typeface="新細明體"/>
+        <a:font script="Arab" typeface="Arial"/>
+        <a:font script="Hebr" typeface="Arial"/>
+        <a:font script="Thai" typeface="Cordia New"/>
+        <a:font script="Ethi" typeface="Nyala"/>
+        <a:font script="Beng" typeface="Vrinda"/>
+        <a:font script="Gujr" typeface="Shruti"/>
+        <a:font script="Khmr" typeface="DaunPenh"/>
+        <a:font script="Knda" typeface="Tunga"/>
+        <a:font script="Guru" typeface="Raavi"/>
+        <a:font script="Cans" typeface="Euphemia"/>
+        <a:font script="Cher" typeface="Plantagenet Cherokee"/>
+        <a:font script="Yiii" typeface="Microsoft Yi Baiti"/>
+        <a:font script="Tibt" typeface="Microsoft Himalaya"/>
+        <a:font script="Thaa" typeface="MV Boli"/>
+        <a:font script="Deva" typeface="Mangal"/>
+        <a:font script="Telu" typeface="Gautami"/>
+        <a:font script="Taml" typeface="Latha"/>
+        <a:font script="Syrc" typeface="Estrangelo Edessa"/>
+        <a:font script="Orya" typeface="Kalinga"/>
+        <a:font script="Mlym" typeface="Kartika"/>
+        <a:font script="Laoo" typeface="DokChampa"/>
+        <a:font script="Sinh" typeface="Iskoola Pota"/>
+        <a:font script="Mong" typeface="Mongolian Baiti"/>
+        <a:font script="Viet" typeface="Arial"/>
+        <a:font script="Uigh" typeface="Microsoft Uighur"/>
+        <a:font script="Geor" typeface="Sylfaen"/>
+        <a:font script="Armn" typeface="Arial"/>
+        <a:font script="Bugi" typeface="Leelawadee UI"/>
+        <a:font script="Bopo" typeface="Microsoft JhengHei"/>
+        <a:font script="Java" typeface="Javanese Text"/>
+        <a:font script="Lisu" typeface="Segoe UI"/>
+        <a:font script="Mymr" typeface="Myanmar Text"/>
+        <a:font script="Nkoo" typeface="Ebrima"/>
+        <a:font script="Olck" typeface="Nirmala UI"/>
+        <a:font script="Osma" typeface="Ebrima"/>
+        <a:font script="Phag" typeface="Phagspa"/>
+        <a:font script="Syrn" typeface="Estrangelo Edessa"/>
+        <a:font script="Syrj" typeface="Estrangelo Edessa"/>
+        <a:font script="Syre" typeface="Estrangelo Edessa"/>
+        <a:font script="Sora" typeface="Nirmala UI"/>
+        <a:font script="Tale" typeface="Microsoft Tai Le"/>
+        <a:font script="Talu" typeface="Microsoft New Tai Lue"/>
+        <a:font script="Tfng" typeface="Ebrima"/>
+      </a:minorFont>
+    </a:fontScheme>
+    <a:fmtScheme name="Office">
+      <a:fillStyleLst>
+        <a:solidFill>
+          <a:schemeClr val="phClr"/>
+        </a:solidFill>
+        <a:gradFill rotWithShape="1">
+          <a:gsLst>
+            <a:gs pos="0">
+              <a:schemeClr val="phClr">
+                <a:lumMod val="110000"/>
+                <a:satMod val="105000"/>
+                <a:tint val="67000"/>
+              </a:schemeClr>
+            </a:gs>
+            <a:gs pos="50000">
+              <a:schemeClr val="phClr">
+                <a:lumMod val="105000"/>
+                <a:satMod val="103000"/>
+                <a:tint val="73000"/>
+              </a:schemeClr>
+            </a:gs>
+            <a:gs pos="100000">
+              <a:schemeClr val="phClr">
+                <a:lumMod val="105000"/>
+                <a:satMod val="109000"/>
+                <a:tint val="81000"/>
+              </a:schemeClr>
+            </a:gs>
+          </a:gsLst>
+          <a:lin ang="5400000" scaled="0"/>
+        </a:gradFill>
+        <a:gradFill rotWithShape="1">
+          <a:gsLst>
+            <a:gs pos="0">
+              <a:schemeClr val="phClr">
+                <a:satMod val="103000"/>
+                <a:lumMod val="102000"/>
+                <a:tint val="94000"/>
+              </a:schemeClr>
+            </a:gs>
+            <a:gs pos="50000">
+              <a:schemeClr val="phClr">
+                <a:satMod val="110000"/>
+                <a:lumMod val="100000"/>
+                <a:shade val="100000"/>
+              </a:schemeClr>
+            </a:gs>
+            <a:gs pos="100000">
+              <a:schemeClr val="phClr">
+                <a:lumMod val="99000"/>
+                <a:satMod val="120000"/>
+                <a:shade val="78000"/>
+              </a:schemeClr>
+            </a:gs>
+          </a:gsLst>
+          <a:lin ang="5400000" scaled="0"/>
+        </a:gradFill>
+      </a:fillStyleLst>
+      <a:lnStyleLst>
+        <a:ln w="12700" cap="flat" cmpd="sng" algn="ctr">
+          <a:solidFill>
+            <a:schemeClr val="phClr"/>
+          </a:solidFill>
+          <a:prstDash val="solid"/>
+          <a:miter lim="800000"/>
+        </a:ln>
+        <a:ln w="19050" cap="flat" cmpd="sng" algn="ctr">
+          <a:solidFill>
+            <a:schemeClr val="phClr"/>
+          </a:solidFill>
+          <a:prstDash val="solid"/>
+          <a:miter lim="800000"/>
+        </a:ln>
+        <a:ln w="25400" cap="flat" cmpd="sng" algn="ctr">
+          <a:solidFill>
+            <a:schemeClr val="phClr"/>
+          </a:solidFill>
+          <a:prstDash val="solid"/>
+          <a:miter lim="800000"/>
+        </a:ln>
+      </a:lnStyleLst>
+      <a:effectStyleLst>
+        <a:effectStyle>
+          <a:effectLst/>
+        </a:effectStyle>
+        <a:effectStyle>
+          <a:effectLst/>
+        </a:effectStyle>
+        <a:effectStyle>
+          <a:effectLst>
+            <a:outerShdw blurRad="57150" dist="19050" dir="5400000" algn="ctr" rotWithShape="0">
+              <a:srgbClr val="000000">
+                <a:alpha val="63000"/>
+              </a:srgbClr>
+            </a:outerShdw>
+          </a:effectLst>
+        </a:effectStyle>
+      </a:effectStyleLst>
+      <a:bgFillStyleLst>
+        <a:solidFill>
+          <a:schemeClr val="phClr"/>
+        </a:solidFill>
+        <a:solidFill>
+          <a:schemeClr val="phClr">
+            <a:tint val="95000"/>
+            <a:satMod val="170000"/>
+          </a:schemeClr>
+        </a:solidFill>
+        <a:gradFill rotWithShape="1">
+          <a:gsLst>
+            <a:gs pos="0">
+              <a:schemeClr val="phClr">
+                <a:tint val="93000"/>
+                <a:satMod val="150000"/>
+                <a:shade val="98000"/>
+                <a:lumMod val="102000"/>
+              </a:schemeClr>
+            </a:gs>
+            <a:gs pos="50000">
+              <a:schemeClr val="phClr">
+                <a:tint val="98000"/>
+                <a:satMod val="130000"/>
+                <a:shade val="90000"/>
+                <a:lumMod val="103000"/>
+              </a:schemeClr>
+            </a:gs>
+            <a:gs pos="100000">
+              <a:schemeClr val="phClr">
+                <a:shade val="63000"/>
+                <a:satMod val="120000"/>
+              </a:schemeClr>
+            </a:gs>
+          </a:gsLst>
+          <a:lin ang="5400000" scaled="0"/>
+        </a:gradFill>
+      </a:bgFillStyleLst>
+    </a:fmtScheme>
+  </a:themeElements>
+  <a:objectDefaults>
+    <a:lnDef>
+      <a:spPr/>
+      <a:bodyPr/>
+      <a:lstStyle/>
+      <a:style>
+        <a:lnRef idx="2">
+          <a:schemeClr val="accent1"/>
+        </a:lnRef>
+        <a:fillRef idx="0">
+          <a:schemeClr val="accent1"/>
+        </a:fillRef>
+        <a:effectRef idx="1">
+          <a:schemeClr val="accent1"/>
+        </a:effectRef>
+        <a:fontRef idx="minor">
+          <a:schemeClr val="tx1"/>
+        </a:fontRef>
+      </a:style>
+    </a:lnDef>
+  </a:objectDefaults>
+  <a:extraClrSchemeLst/>
+  <a:extLst>
+    <a:ext uri="{05A4C25C-085E-4340-85A3-A5531E510DB2}">
+      <thm15:themeFamily xmlns:thm15="http://schemas.microsoft.com/office/thememl/2012/main" name="Office Theme" id="{2E142A2C-CD16-42D6-873A-C26D2A0506FA}" vid="{1BDDFF52-6CD6-40A5-AB3C-68EB2F1E4D0A}"/>
+    </a:ext>
+  </a:extLst>
+</a:theme>
 </file>
</xml_diff>